<commit_message>
Präsentation optisch aufwerten: Farbverläufe und Illustrationen
Neue kräftigere Farbpalette, Verlaufs-Hintergründe pro Kapitel und
eigene Illustrationen zu Karneval (Dom, Maske, Konfetti) und Ostern
(Sonnenaufgang, drei Kreuze, leeres Grab).

Co-Authored-By: Claude Opus 5.5 <noreply@anthropic.com>
Claude-Session: https://claude.ai/code/session_01EsbPSfyjZCqBtDb5d3uQeV
</commit_message>
<xml_diff>
--- a/Karneval_und_Ostern.pptx
+++ b/Karneval_und_Ostern.pptx
@@ -124,26 +124,26 @@
   <p:extLst>
     <p:ext uri="{521415D9-36F7-43E2-AB2F-B90AF26B5E84}">
       <p14:sectionLst xmlns:p14="http://schemas.microsoft.com/office/powerpoint/2010/main">
-        <p14:section name="Einstieg" id="{0e9e9b4b-9a79-24a6-6b11-6936a42629d7}">
+        <p14:section name="Einstieg" id="{b7bbd7a8-d5f7-036d-c648-2d309db2c315}">
           <p14:sldIdLst>
             <p14:sldId id="256"/>
             <p14:sldId id="257"/>
           </p14:sldIdLst>
         </p14:section>
-        <p14:section name="Karneval" id="{b1e9ecbf-c1de-3248-1c85-394ce0ae8cd6}">
+        <p14:section name="Karneval" id="{b8066072-7287-5b43-2438-e4baaff24ed6}">
           <p14:sldIdLst>
             <p14:sldId id="258"/>
             <p14:sldId id="259"/>
             <p14:sldId id="260"/>
           </p14:sldIdLst>
         </p14:section>
-        <p14:section name="Fastenzeit" id="{dbf8ecc7-1f42-1219-701b-5d1b4b5a950c}">
+        <p14:section name="Fastenzeit" id="{fe7a2edc-fa65-1b84-2be7-0538086c6a3a}">
           <p14:sldIdLst>
             <p14:sldId id="261"/>
             <p14:sldId id="262"/>
           </p14:sldIdLst>
         </p14:section>
-        <p14:section name="Ostern" id="{cdcc4e8b-eaef-a59f-fa72-50d7ae7f09f8}">
+        <p14:section name="Ostern" id="{33cbab7f-2823-6f02-0f1a-551c76439007}">
           <p14:sldIdLst>
             <p14:sldId id="263"/>
             <p14:sldId id="264"/>
@@ -151,14 +151,14 @@
             <p14:sldId id="266"/>
           </p14:sldIdLst>
         </p14:section>
-        <p14:section name="Andere Religionen" id="{29dd3693-d972-a10f-ab02-adf5bcdce1fc}">
+        <p14:section name="Andere Religionen" id="{20b94870-6e44-e244-3e4d-e21337d64083}">
           <p14:sldIdLst>
             <p14:sldId id="267"/>
             <p14:sldId id="268"/>
             <p14:sldId id="269"/>
           </p14:sldIdLst>
         </p14:section>
-        <p14:section name="Abschluss" id="{4f318c55-3881-0cdc-a56b-a9930bfc3124}">
+        <p14:section name="Abschluss" id="{6df7541a-f199-4a0e-a09b-24e1b1e8a75c}">
           <p14:sldIdLst>
             <p14:sldId id="270"/>
             <p14:sldId id="271"/>
@@ -2143,9 +2143,16 @@
   <p:cSld name="Drei Karten">
     <p:bg>
       <p:bgPr>
-        <a:solidFill>
-          <a:schemeClr val="bg2"/>
-        </a:solidFill>
+        <a:blipFill dpi="0" rotWithShape="1">
+          <a:blip r:embed="rId1">
+            <a:lum/>
+          </a:blip>
+          <a:srcRect/>
+          <a:stretch>
+            <a:fillRect/>
+          </a:stretch>
+        </a:blipFill>
+        <a:effectLst/>
       </p:bgPr>
     </p:bg>
     <p:spTree>
@@ -2609,9 +2616,16 @@
   <p:cSld name="Zeitstrahl 4">
     <p:bg>
       <p:bgPr>
-        <a:solidFill>
-          <a:schemeClr val="bg1"/>
-        </a:solidFill>
+        <a:blipFill dpi="0" rotWithShape="1">
+          <a:blip r:embed="rId1">
+            <a:lum/>
+          </a:blip>
+          <a:srcRect/>
+          <a:stretch>
+            <a:fillRect/>
+          </a:stretch>
+        </a:blipFill>
+        <a:effectLst/>
       </p:bgPr>
     </p:bg>
     <p:spTree>
@@ -2963,9 +2977,16 @@
   <p:cSld name="Zeitstrahl 5">
     <p:bg>
       <p:bgPr>
-        <a:solidFill>
-          <a:schemeClr val="bg1"/>
-        </a:solidFill>
+        <a:blipFill dpi="0" rotWithShape="1">
+          <a:blip r:embed="rId1">
+            <a:lum/>
+          </a:blip>
+          <a:srcRect/>
+          <a:stretch>
+            <a:fillRect/>
+          </a:stretch>
+        </a:blipFill>
+        <a:effectLst/>
       </p:bgPr>
     </p:bg>
     <p:spTree>
@@ -3364,9 +3385,16 @@
   <p:cSld name="Zwei Spalten">
     <p:bg>
       <p:bgPr>
-        <a:solidFill>
-          <a:schemeClr val="bg1"/>
-        </a:solidFill>
+        <a:blipFill dpi="0" rotWithShape="1">
+          <a:blip r:embed="rId1">
+            <a:lum/>
+          </a:blip>
+          <a:srcRect/>
+          <a:stretch>
+            <a:fillRect/>
+          </a:stretch>
+        </a:blipFill>
+        <a:effectLst/>
       </p:bgPr>
     </p:bg>
     <p:spTree>
@@ -3683,9 +3711,16 @@
   <p:cSld name="Drei Stationen">
     <p:bg>
       <p:bgPr>
-        <a:solidFill>
-          <a:schemeClr val="bg1"/>
-        </a:solidFill>
+        <a:blipFill dpi="0" rotWithShape="1">
+          <a:blip r:embed="rId1">
+            <a:lum/>
+          </a:blip>
+          <a:srcRect/>
+          <a:stretch>
+            <a:fillRect/>
+          </a:stretch>
+        </a:blipFill>
+        <a:effectLst/>
       </p:bgPr>
     </p:bg>
     <p:spTree>
@@ -3990,9 +4025,16 @@
   <p:cSld name="Leitfrage">
     <p:bg>
       <p:bgPr>
-        <a:solidFill>
-          <a:schemeClr val="tx2"/>
-        </a:solidFill>
+        <a:blipFill dpi="0" rotWithShape="1">
+          <a:blip r:embed="rId1">
+            <a:lum/>
+          </a:blip>
+          <a:srcRect/>
+          <a:stretch>
+            <a:fillRect/>
+          </a:stretch>
+        </a:blipFill>
+        <a:effectLst/>
       </p:bgPr>
     </p:bg>
     <p:spTree>
@@ -4203,9 +4245,16 @@
   <p:cSld name="Nur Titel">
     <p:bg>
       <p:bgPr>
-        <a:solidFill>
-          <a:schemeClr val="bg1"/>
-        </a:solidFill>
+        <a:blipFill dpi="0" rotWithShape="1">
+          <a:blip r:embed="rId1">
+            <a:lum/>
+          </a:blip>
+          <a:srcRect/>
+          <a:stretch>
+            <a:fillRect/>
+          </a:stretch>
+        </a:blipFill>
+        <a:effectLst/>
       </p:bgPr>
     </p:bg>
     <p:spTree>
@@ -4369,9 +4418,16 @@
   <p:cSld name="Abschluss">
     <p:bg>
       <p:bgPr>
-        <a:solidFill>
-          <a:schemeClr val="tx1"/>
-        </a:solidFill>
+        <a:blipFill dpi="0" rotWithShape="1">
+          <a:blip r:embed="rId1">
+            <a:lum/>
+          </a:blip>
+          <a:srcRect/>
+          <a:stretch>
+            <a:fillRect/>
+          </a:stretch>
+        </a:blipFill>
+        <a:effectLst/>
       </p:bgPr>
     </p:bg>
     <p:spTree>
@@ -4515,9 +4571,16 @@
   <p:cSld name="Titel">
     <p:bg>
       <p:bgPr>
-        <a:solidFill>
-          <a:schemeClr val="tx1"/>
-        </a:solidFill>
+        <a:blipFill dpi="0" rotWithShape="1">
+          <a:blip r:embed="rId1">
+            <a:lum/>
+          </a:blip>
+          <a:srcRect/>
+          <a:stretch>
+            <a:fillRect/>
+          </a:stretch>
+        </a:blipFill>
+        <a:effectLst/>
       </p:bgPr>
     </p:bg>
     <p:spTree>
@@ -4661,9 +4724,16 @@
   <p:cSld name="Abschnitt Karneval">
     <p:bg>
       <p:bgPr>
-        <a:solidFill>
-          <a:schemeClr val="accent1"/>
-        </a:solidFill>
+        <a:blipFill dpi="0" rotWithShape="1">
+          <a:blip r:embed="rId1">
+            <a:lum/>
+          </a:blip>
+          <a:srcRect/>
+          <a:stretch>
+            <a:fillRect/>
+          </a:stretch>
+        </a:blipFill>
+        <a:effectLst/>
       </p:bgPr>
     </p:bg>
     <p:spTree>
@@ -4807,9 +4877,16 @@
   <p:cSld name="Abschnitt Fastenzeit">
     <p:bg>
       <p:bgPr>
-        <a:solidFill>
-          <a:schemeClr val="tx2"/>
-        </a:solidFill>
+        <a:blipFill dpi="0" rotWithShape="1">
+          <a:blip r:embed="rId1">
+            <a:lum/>
+          </a:blip>
+          <a:srcRect/>
+          <a:stretch>
+            <a:fillRect/>
+          </a:stretch>
+        </a:blipFill>
+        <a:effectLst/>
       </p:bgPr>
     </p:bg>
     <p:spTree>
@@ -4953,9 +5030,16 @@
   <p:cSld name="Abschnitt Ostern">
     <p:bg>
       <p:bgPr>
-        <a:solidFill>
-          <a:schemeClr val="accent5"/>
-        </a:solidFill>
+        <a:blipFill dpi="0" rotWithShape="1">
+          <a:blip r:embed="rId1">
+            <a:lum/>
+          </a:blip>
+          <a:srcRect/>
+          <a:stretch>
+            <a:fillRect/>
+          </a:stretch>
+        </a:blipFill>
+        <a:effectLst/>
       </p:bgPr>
     </p:bg>
     <p:spTree>
@@ -5099,9 +5183,16 @@
   <p:cSld name="Abschnitt Religionen">
     <p:bg>
       <p:bgPr>
-        <a:solidFill>
-          <a:schemeClr val="accent3"/>
-        </a:solidFill>
+        <a:blipFill dpi="0" rotWithShape="1">
+          <a:blip r:embed="rId1">
+            <a:lum/>
+          </a:blip>
+          <a:srcRect/>
+          <a:stretch>
+            <a:fillRect/>
+          </a:stretch>
+        </a:blipFill>
+        <a:effectLst/>
       </p:bgPr>
     </p:bg>
     <p:spTree>
@@ -5245,9 +5336,16 @@
   <p:cSld name="Agenda">
     <p:bg>
       <p:bgPr>
-        <a:solidFill>
-          <a:schemeClr val="bg1"/>
-        </a:solidFill>
+        <a:blipFill dpi="0" rotWithShape="1">
+          <a:blip r:embed="rId1">
+            <a:lum/>
+          </a:blip>
+          <a:srcRect/>
+          <a:stretch>
+            <a:fillRect/>
+          </a:stretch>
+        </a:blipFill>
+        <a:effectLst/>
       </p:bgPr>
     </p:bg>
     <p:spTree>
@@ -5599,9 +5697,16 @@
   <p:cSld name="Text und Bild">
     <p:bg>
       <p:bgPr>
-        <a:solidFill>
-          <a:schemeClr val="bg1"/>
-        </a:solidFill>
+        <a:blipFill dpi="0" rotWithShape="1">
+          <a:blip r:embed="rId1">
+            <a:lum/>
+          </a:blip>
+          <a:srcRect/>
+          <a:stretch>
+            <a:fillRect/>
+          </a:stretch>
+        </a:blipFill>
+        <a:effectLst/>
       </p:bgPr>
     </p:bg>
     <p:spTree>
@@ -5865,9 +5970,16 @@
   <p:cSld name="Bild und Text">
     <p:bg>
       <p:bgPr>
-        <a:solidFill>
-          <a:schemeClr val="bg1"/>
-        </a:solidFill>
+        <a:blipFill dpi="0" rotWithShape="1">
+          <a:blip r:embed="rId1">
+            <a:lum/>
+          </a:blip>
+          <a:srcRect/>
+          <a:stretch>
+            <a:fillRect/>
+          </a:stretch>
+        </a:blipFill>
+        <a:effectLst/>
       </p:bgPr>
     </p:bg>
     <p:spTree>
@@ -7203,7 +7315,7 @@
           <a:ln/>
           <a:effectLst>
             <a:outerShdw sx="100000" sy="100000" kx="0" ky="0" algn="bl" rotWithShape="0" blurRad="248920" dist="106680" dir="5400000">
-              <a:srgbClr val="2A1640">
+              <a:srgbClr val="1A1033">
                 <a:alpha val="30800"/>
               </a:srgbClr>
             </a:outerShdw>
@@ -7259,7 +7371,7 @@
           <a:ln/>
           <a:effectLst>
             <a:outerShdw sx="100000" sy="100000" kx="0" ky="0" algn="bl" rotWithShape="0" blurRad="248920" dist="106680" dir="5400000">
-              <a:srgbClr val="2A1640">
+              <a:srgbClr val="1A1033">
                 <a:alpha val="30800"/>
               </a:srgbClr>
             </a:outerShdw>
@@ -7315,7 +7427,7 @@
           <a:ln/>
           <a:effectLst>
             <a:outerShdw sx="100000" sy="100000" kx="0" ky="0" algn="bl" rotWithShape="0" blurRad="248920" dist="106680" dir="5400000">
-              <a:srgbClr val="2A1640">
+              <a:srgbClr val="1A1033">
                 <a:alpha val="30800"/>
               </a:srgbClr>
             </a:outerShdw>
@@ -7371,7 +7483,7 @@
           <a:ln/>
           <a:effectLst>
             <a:outerShdw sx="100000" sy="100000" kx="0" ky="0" algn="bl" rotWithShape="0" blurRad="142240" dist="60960" dir="5400000">
-              <a:srgbClr val="2A1640">
+              <a:srgbClr val="1A1033">
                 <a:alpha val="17600"/>
               </a:srgbClr>
             </a:outerShdw>
@@ -7826,7 +7938,7 @@
           <a:ln/>
           <a:effectLst>
             <a:outerShdw sx="100000" sy="100000" kx="0" ky="0" algn="bl" rotWithShape="0" blurRad="248920" dist="106680" dir="5400000">
-              <a:srgbClr val="2A1640">
+              <a:srgbClr val="1A1033">
                 <a:alpha val="30800"/>
               </a:srgbClr>
             </a:outerShdw>
@@ -7998,7 +8110,7 @@
           <a:ln/>
           <a:effectLst>
             <a:outerShdw sx="100000" sy="100000" kx="0" ky="0" algn="bl" rotWithShape="0" blurRad="248920" dist="106680" dir="5400000">
-              <a:srgbClr val="2A1640">
+              <a:srgbClr val="1A1033">
                 <a:alpha val="30800"/>
               </a:srgbClr>
             </a:outerShdw>
@@ -8170,7 +8282,7 @@
           <a:ln/>
           <a:effectLst>
             <a:outerShdw sx="100000" sy="100000" kx="0" ky="0" algn="bl" rotWithShape="0" blurRad="248920" dist="106680" dir="5400000">
-              <a:srgbClr val="2A1640">
+              <a:srgbClr val="1A1033">
                 <a:alpha val="30800"/>
               </a:srgbClr>
             </a:outerShdw>
@@ -8342,7 +8454,7 @@
           <a:ln/>
           <a:effectLst>
             <a:outerShdw sx="100000" sy="100000" kx="0" ky="0" algn="bl" rotWithShape="0" blurRad="248920" dist="106680" dir="5400000">
-              <a:srgbClr val="2A1640">
+              <a:srgbClr val="1A1033">
                 <a:alpha val="30800"/>
               </a:srgbClr>
             </a:outerShdw>
@@ -8514,7 +8626,7 @@
           <a:ln/>
           <a:effectLst>
             <a:outerShdw sx="100000" sy="100000" kx="0" ky="0" algn="bl" rotWithShape="0" blurRad="248920" dist="106680" dir="5400000">
-              <a:srgbClr val="2A1640">
+              <a:srgbClr val="1A1033">
                 <a:alpha val="30800"/>
               </a:srgbClr>
             </a:outerShdw>
@@ -8835,7 +8947,7 @@
           <a:ln/>
           <a:effectLst>
             <a:outerShdw sx="100000" sy="100000" kx="0" ky="0" algn="bl" rotWithShape="0" blurRad="231140" dist="99060" dir="5400000">
-              <a:srgbClr val="2A1640">
+              <a:srgbClr val="1A1033">
                 <a:alpha val="28600"/>
               </a:srgbClr>
             </a:outerShdw>
@@ -8869,7 +8981,7 @@
           <a:ln/>
           <a:effectLst>
             <a:outerShdw sx="100000" sy="100000" kx="0" ky="0" algn="bl" rotWithShape="0" blurRad="248920" dist="106680" dir="5400000">
-              <a:srgbClr val="2A1640">
+              <a:srgbClr val="1A1033">
                 <a:alpha val="30800"/>
               </a:srgbClr>
             </a:outerShdw>
@@ -8990,7 +9102,7 @@
           <a:ln/>
           <a:effectLst>
             <a:outerShdw sx="100000" sy="100000" kx="0" ky="0" algn="bl" rotWithShape="0" blurRad="88900" dist="38100" dir="5400000">
-              <a:srgbClr val="2A1640">
+              <a:srgbClr val="1A1033">
                 <a:alpha val="11000"/>
               </a:srgbClr>
             </a:outerShdw>
@@ -9062,7 +9174,7 @@
           <a:ln/>
           <a:effectLst>
             <a:outerShdw sx="100000" sy="100000" kx="0" ky="0" algn="bl" rotWithShape="0" blurRad="231140" dist="99060" dir="5400000">
-              <a:srgbClr val="2A1640">
+              <a:srgbClr val="1A1033">
                 <a:alpha val="28600"/>
               </a:srgbClr>
             </a:outerShdw>
@@ -9096,7 +9208,7 @@
           <a:ln/>
           <a:effectLst>
             <a:outerShdw sx="100000" sy="100000" kx="0" ky="0" algn="bl" rotWithShape="0" blurRad="248920" dist="106680" dir="5400000">
-              <a:srgbClr val="2A1640">
+              <a:srgbClr val="1A1033">
                 <a:alpha val="30800"/>
               </a:srgbClr>
             </a:outerShdw>
@@ -9217,7 +9329,7 @@
           <a:ln/>
           <a:effectLst>
             <a:outerShdw sx="100000" sy="100000" kx="0" ky="0" algn="bl" rotWithShape="0" blurRad="88900" dist="38100" dir="5400000">
-              <a:srgbClr val="2A1640">
+              <a:srgbClr val="1A1033">
                 <a:alpha val="11000"/>
               </a:srgbClr>
             </a:outerShdw>
@@ -10330,7 +10442,7 @@
           <a:ln/>
           <a:effectLst>
             <a:outerShdw sx="100000" sy="100000" kx="0" ky="0" algn="bl" rotWithShape="0" blurRad="142240" dist="60960" dir="5400000">
-              <a:srgbClr val="2A1640">
+              <a:srgbClr val="1A1033">
                 <a:alpha val="17600"/>
               </a:srgbClr>
             </a:outerShdw>
@@ -10388,7 +10500,7 @@
           <a:ln/>
           <a:effectLst>
             <a:outerShdw sx="100000" sy="100000" kx="0" ky="0" algn="bl" rotWithShape="0" blurRad="142240" dist="60960" dir="5400000">
-              <a:srgbClr val="2A1640">
+              <a:srgbClr val="1A1033">
                 <a:alpha val="17600"/>
               </a:srgbClr>
             </a:outerShdw>
@@ -10446,7 +10558,7 @@
           <a:ln/>
           <a:effectLst>
             <a:outerShdw sx="100000" sy="100000" kx="0" ky="0" algn="bl" rotWithShape="0" blurRad="142240" dist="60960" dir="5400000">
-              <a:srgbClr val="2A1640">
+              <a:srgbClr val="1A1033">
                 <a:alpha val="17600"/>
               </a:srgbClr>
             </a:outerShdw>
@@ -10502,7 +10614,7 @@
           <a:ln/>
           <a:effectLst>
             <a:outerShdw sx="100000" sy="100000" kx="0" ky="0" algn="bl" rotWithShape="0" blurRad="76200" dist="38100" dir="5400000">
-              <a:srgbClr val="2A1640">
+              <a:srgbClr val="1A1033">
                 <a:alpha val="35000"/>
               </a:srgbClr>
             </a:outerShdw>
@@ -10656,7 +10768,7 @@
           <a:ln/>
           <a:effectLst>
             <a:outerShdw sx="100000" sy="100000" kx="0" ky="0" algn="bl" rotWithShape="0" blurRad="177800" dist="76200" dir="5400000">
-              <a:srgbClr val="2A1640">
+              <a:srgbClr val="1A1033">
                 <a:alpha val="22000"/>
               </a:srgbClr>
             </a:outerShdw>
@@ -10690,7 +10802,7 @@
           <a:ln/>
           <a:effectLst>
             <a:outerShdw sx="100000" sy="100000" kx="0" ky="0" algn="bl" rotWithShape="0" blurRad="142240" dist="60960" dir="5400000">
-              <a:srgbClr val="2A1640">
+              <a:srgbClr val="1A1033">
                 <a:alpha val="17600"/>
               </a:srgbClr>
             </a:outerShdw>
@@ -10786,7 +10898,7 @@
           <a:ln/>
           <a:effectLst>
             <a:outerShdw sx="100000" sy="100000" kx="0" ky="0" algn="bl" rotWithShape="0" blurRad="177800" dist="76200" dir="5400000">
-              <a:srgbClr val="2A1640">
+              <a:srgbClr val="1A1033">
                 <a:alpha val="22000"/>
               </a:srgbClr>
             </a:outerShdw>
@@ -10820,7 +10932,7 @@
           <a:ln/>
           <a:effectLst>
             <a:outerShdw sx="100000" sy="100000" kx="0" ky="0" algn="bl" rotWithShape="0" blurRad="142240" dist="60960" dir="5400000">
-              <a:srgbClr val="2A1640">
+              <a:srgbClr val="1A1033">
                 <a:alpha val="17600"/>
               </a:srgbClr>
             </a:outerShdw>
@@ -10916,7 +11028,7 @@
           <a:ln/>
           <a:effectLst>
             <a:outerShdw sx="100000" sy="100000" kx="0" ky="0" algn="bl" rotWithShape="0" blurRad="177800" dist="76200" dir="5400000">
-              <a:srgbClr val="2A1640">
+              <a:srgbClr val="1A1033">
                 <a:alpha val="22000"/>
               </a:srgbClr>
             </a:outerShdw>
@@ -10950,7 +11062,7 @@
           <a:ln/>
           <a:effectLst>
             <a:outerShdw sx="100000" sy="100000" kx="0" ky="0" algn="bl" rotWithShape="0" blurRad="142240" dist="60960" dir="5400000">
-              <a:srgbClr val="2A1640">
+              <a:srgbClr val="1A1033">
                 <a:alpha val="17600"/>
               </a:srgbClr>
             </a:outerShdw>
@@ -11430,7 +11542,7 @@
           <a:ln/>
           <a:effectLst>
             <a:outerShdw sx="100000" sy="100000" kx="0" ky="0" algn="bl" rotWithShape="0" blurRad="248920" dist="106680" dir="5400000">
-              <a:srgbClr val="2A1640">
+              <a:srgbClr val="1A1033">
                 <a:alpha val="30800"/>
               </a:srgbClr>
             </a:outerShdw>
@@ -11464,7 +11576,7 @@
           <a:ln/>
           <a:effectLst>
             <a:outerShdw sx="100000" sy="100000" kx="0" ky="0" algn="bl" rotWithShape="0" blurRad="142240" dist="60960" dir="5400000">
-              <a:srgbClr val="2A1640">
+              <a:srgbClr val="1A1033">
                 <a:alpha val="17600"/>
               </a:srgbClr>
             </a:outerShdw>
@@ -11561,7 +11673,7 @@
           <a:ln/>
           <a:effectLst>
             <a:outerShdw sx="100000" sy="100000" kx="0" ky="0" algn="bl" rotWithShape="0" blurRad="106680" dist="45720" dir="5400000">
-              <a:srgbClr val="2A1640">
+              <a:srgbClr val="1A1033">
                 <a:alpha val="13200"/>
               </a:srgbClr>
             </a:outerShdw>
@@ -11633,7 +11745,7 @@
           <a:ln/>
           <a:effectLst>
             <a:outerShdw sx="100000" sy="100000" kx="0" ky="0" algn="bl" rotWithShape="0" blurRad="248920" dist="106680" dir="5400000">
-              <a:srgbClr val="2A1640">
+              <a:srgbClr val="1A1033">
                 <a:alpha val="30800"/>
               </a:srgbClr>
             </a:outerShdw>
@@ -11667,7 +11779,7 @@
           <a:ln/>
           <a:effectLst>
             <a:outerShdw sx="100000" sy="100000" kx="0" ky="0" algn="bl" rotWithShape="0" blurRad="142240" dist="60960" dir="5400000">
-              <a:srgbClr val="2A1640">
+              <a:srgbClr val="1A1033">
                 <a:alpha val="17600"/>
               </a:srgbClr>
             </a:outerShdw>
@@ -11764,7 +11876,7 @@
           <a:ln/>
           <a:effectLst>
             <a:outerShdw sx="100000" sy="100000" kx="0" ky="0" algn="bl" rotWithShape="0" blurRad="106680" dist="45720" dir="5400000">
-              <a:srgbClr val="2A1640">
+              <a:srgbClr val="1A1033">
                 <a:alpha val="13200"/>
               </a:srgbClr>
             </a:outerShdw>
@@ -11836,7 +11948,7 @@
           <a:ln/>
           <a:effectLst>
             <a:outerShdw sx="100000" sy="100000" kx="0" ky="0" algn="bl" rotWithShape="0" blurRad="248920" dist="106680" dir="5400000">
-              <a:srgbClr val="2A1640">
+              <a:srgbClr val="1A1033">
                 <a:alpha val="30800"/>
               </a:srgbClr>
             </a:outerShdw>
@@ -11870,7 +11982,7 @@
           <a:ln/>
           <a:effectLst>
             <a:outerShdw sx="100000" sy="100000" kx="0" ky="0" algn="bl" rotWithShape="0" blurRad="142240" dist="60960" dir="5400000">
-              <a:srgbClr val="2A1640">
+              <a:srgbClr val="1A1033">
                 <a:alpha val="17600"/>
               </a:srgbClr>
             </a:outerShdw>
@@ -12225,12 +12337,12 @@
             </a:avLst>
           </a:prstGeom>
           <a:solidFill>
-            <a:schemeClr val="bg2"/>
+            <a:schemeClr val="bg1"/>
           </a:solidFill>
           <a:ln/>
           <a:effectLst>
             <a:outerShdw sx="100000" sy="100000" kx="0" ky="0" algn="bl" rotWithShape="0" blurRad="195580" dist="83820" dir="5400000">
-              <a:srgbClr val="2A1640">
+              <a:srgbClr val="1A1033">
                 <a:alpha val="24200"/>
               </a:srgbClr>
             </a:outerShdw>
@@ -12264,7 +12376,7 @@
           <a:ln/>
           <a:effectLst>
             <a:outerShdw sx="100000" sy="100000" kx="0" ky="0" algn="bl" rotWithShape="0" blurRad="142240" dist="60960" dir="5400000">
-              <a:srgbClr val="2A1640">
+              <a:srgbClr val="1A1033">
                 <a:alpha val="17600"/>
               </a:srgbClr>
             </a:outerShdw>
@@ -12358,12 +12470,12 @@
             </a:avLst>
           </a:prstGeom>
           <a:solidFill>
-            <a:schemeClr val="bg2"/>
+            <a:schemeClr val="bg1"/>
           </a:solidFill>
           <a:ln/>
           <a:effectLst>
             <a:outerShdw sx="100000" sy="100000" kx="0" ky="0" algn="bl" rotWithShape="0" blurRad="195580" dist="83820" dir="5400000">
-              <a:srgbClr val="2A1640">
+              <a:srgbClr val="1A1033">
                 <a:alpha val="24200"/>
               </a:srgbClr>
             </a:outerShdw>
@@ -12397,7 +12509,7 @@
           <a:ln/>
           <a:effectLst>
             <a:outerShdw sx="100000" sy="100000" kx="0" ky="0" algn="bl" rotWithShape="0" blurRad="142240" dist="60960" dir="5400000">
-              <a:srgbClr val="2A1640">
+              <a:srgbClr val="1A1033">
                 <a:alpha val="17600"/>
               </a:srgbClr>
             </a:outerShdw>
@@ -12820,7 +12932,7 @@
           <a:ln/>
           <a:effectLst>
             <a:outerShdw sx="100000" sy="100000" kx="0" ky="0" algn="bl" rotWithShape="0" blurRad="248920" dist="106680" dir="5400000">
-              <a:srgbClr val="2A1640">
+              <a:srgbClr val="1A1033">
                 <a:alpha val="30800"/>
               </a:srgbClr>
             </a:outerShdw>
@@ -13397,7 +13509,7 @@
           <a:ln/>
           <a:effectLst>
             <a:outerShdw sx="100000" sy="100000" kx="0" ky="0" algn="bl" rotWithShape="0" blurRad="142240" dist="60960" dir="5400000">
-              <a:srgbClr val="2A1640">
+              <a:srgbClr val="1A1033">
                 <a:alpha val="17600"/>
               </a:srgbClr>
             </a:outerShdw>
@@ -13512,7 +13624,7 @@
           <a:ln/>
           <a:effectLst>
             <a:outerShdw sx="100000" sy="100000" kx="0" ky="0" algn="bl" rotWithShape="0" blurRad="142240" dist="60960" dir="5400000">
-              <a:srgbClr val="2A1640">
+              <a:srgbClr val="1A1033">
                 <a:alpha val="17600"/>
               </a:srgbClr>
             </a:outerShdw>
@@ -13627,7 +13739,7 @@
           <a:ln/>
           <a:effectLst>
             <a:outerShdw sx="100000" sy="100000" kx="0" ky="0" algn="bl" rotWithShape="0" blurRad="142240" dist="60960" dir="5400000">
-              <a:srgbClr val="2A1640">
+              <a:srgbClr val="1A1033">
                 <a:alpha val="17600"/>
               </a:srgbClr>
             </a:outerShdw>
@@ -13742,7 +13854,7 @@
           <a:ln/>
           <a:effectLst>
             <a:outerShdw sx="100000" sy="100000" kx="0" ky="0" algn="bl" rotWithShape="0" blurRad="142240" dist="60960" dir="5400000">
-              <a:srgbClr val="2A1640">
+              <a:srgbClr val="1A1033">
                 <a:alpha val="17600"/>
               </a:srgbClr>
             </a:outerShdw>
@@ -14886,7 +14998,7 @@
           <a:ln/>
           <a:effectLst>
             <a:outerShdw sx="100000" sy="100000" kx="0" ky="0" algn="bl" rotWithShape="0" blurRad="248920" dist="106680" dir="5400000">
-              <a:srgbClr val="2A1640">
+              <a:srgbClr val="1A1033">
                 <a:alpha val="30800"/>
               </a:srgbClr>
             </a:outerShdw>
@@ -14942,7 +15054,7 @@
           <a:ln/>
           <a:effectLst>
             <a:outerShdw sx="100000" sy="100000" kx="0" ky="0" algn="bl" rotWithShape="0" blurRad="248920" dist="106680" dir="5400000">
-              <a:srgbClr val="2A1640">
+              <a:srgbClr val="1A1033">
                 <a:alpha val="30800"/>
               </a:srgbClr>
             </a:outerShdw>
@@ -14998,7 +15110,7 @@
           <a:ln/>
           <a:effectLst>
             <a:outerShdw sx="100000" sy="100000" kx="0" ky="0" algn="bl" rotWithShape="0" blurRad="248920" dist="106680" dir="5400000">
-              <a:srgbClr val="2A1640">
+              <a:srgbClr val="1A1033">
                 <a:alpha val="30800"/>
               </a:srgbClr>
             </a:outerShdw>
@@ -15054,7 +15166,7 @@
           <a:ln/>
           <a:effectLst>
             <a:outerShdw sx="100000" sy="100000" kx="0" ky="0" algn="bl" rotWithShape="0" blurRad="248920" dist="106680" dir="5400000">
-              <a:srgbClr val="2A1640">
+              <a:srgbClr val="1A1033">
                 <a:alpha val="30800"/>
               </a:srgbClr>
             </a:outerShdw>
@@ -15592,7 +15704,7 @@
           <a:ln/>
           <a:effectLst>
             <a:outerShdw sx="100000" sy="100000" kx="0" ky="0" algn="bl" rotWithShape="0" blurRad="106680" dist="45720" dir="5400000">
-              <a:srgbClr val="2A1640">
+              <a:srgbClr val="1A1033">
                 <a:alpha val="13200"/>
               </a:srgbClr>
             </a:outerShdw>
@@ -15703,7 +15815,7 @@
           <a:ln/>
           <a:effectLst>
             <a:outerShdw sx="100000" sy="100000" kx="0" ky="0" algn="bl" rotWithShape="0" blurRad="106680" dist="45720" dir="5400000">
-              <a:srgbClr val="2A1640">
+              <a:srgbClr val="1A1033">
                 <a:alpha val="13200"/>
               </a:srgbClr>
             </a:outerShdw>
@@ -15814,7 +15926,7 @@
           <a:ln/>
           <a:effectLst>
             <a:outerShdw sx="100000" sy="100000" kx="0" ky="0" algn="bl" rotWithShape="0" blurRad="106680" dist="45720" dir="5400000">
-              <a:srgbClr val="2A1640">
+              <a:srgbClr val="1A1033">
                 <a:alpha val="13200"/>
               </a:srgbClr>
             </a:outerShdw>
@@ -15925,7 +16037,7 @@
           <a:ln/>
           <a:effectLst>
             <a:outerShdw sx="100000" sy="100000" kx="0" ky="0" algn="bl" rotWithShape="0" blurRad="106680" dist="45720" dir="5400000">
-              <a:srgbClr val="2A1640">
+              <a:srgbClr val="1A1033">
                 <a:alpha val="13200"/>
               </a:srgbClr>
             </a:outerShdw>
@@ -16038,7 +16150,7 @@
           <a:ln/>
           <a:effectLst>
             <a:outerShdw sx="100000" sy="100000" kx="0" ky="0" algn="bl" rotWithShape="0" blurRad="248920" dist="106680" dir="5400000">
-              <a:srgbClr val="2A1640">
+              <a:srgbClr val="1A1033">
                 <a:alpha val="30800"/>
               </a:srgbClr>
             </a:outerShdw>
@@ -16504,7 +16616,7 @@
           <a:ln/>
           <a:effectLst>
             <a:outerShdw sx="100000" sy="100000" kx="0" ky="0" algn="bl" rotWithShape="0" blurRad="248920" dist="106680" dir="5400000">
-              <a:srgbClr val="2A1640">
+              <a:srgbClr val="1A1033">
                 <a:alpha val="30800"/>
               </a:srgbClr>
             </a:outerShdw>
@@ -16560,7 +16672,7 @@
           <a:ln/>
           <a:effectLst>
             <a:outerShdw sx="100000" sy="100000" kx="0" ky="0" algn="bl" rotWithShape="0" blurRad="248920" dist="106680" dir="5400000">
-              <a:srgbClr val="2A1640">
+              <a:srgbClr val="1A1033">
                 <a:alpha val="30800"/>
               </a:srgbClr>
             </a:outerShdw>
@@ -16616,7 +16728,7 @@
           <a:ln/>
           <a:effectLst>
             <a:outerShdw sx="100000" sy="100000" kx="0" ky="0" algn="bl" rotWithShape="0" blurRad="142240" dist="60960" dir="5400000">
-              <a:srgbClr val="2A1640">
+              <a:srgbClr val="1A1033">
                 <a:alpha val="17600"/>
               </a:srgbClr>
             </a:outerShdw>
@@ -16674,7 +16786,7 @@
           <a:ln/>
           <a:effectLst>
             <a:outerShdw sx="100000" sy="100000" kx="0" ky="0" algn="bl" rotWithShape="0" blurRad="142240" dist="60960" dir="5400000">
-              <a:srgbClr val="2A1640">
+              <a:srgbClr val="1A1033">
                 <a:alpha val="17600"/>
               </a:srgbClr>
             </a:outerShdw>
@@ -17923,7 +18035,7 @@
           <a:ln/>
           <a:effectLst>
             <a:outerShdw sx="100000" sy="100000" kx="0" ky="0" algn="bl" rotWithShape="0" blurRad="355600" dist="152400" dir="5400000">
-              <a:srgbClr val="2A1640">
+              <a:srgbClr val="1A1033">
                 <a:alpha val="44000"/>
               </a:srgbClr>
             </a:outerShdw>
@@ -17979,7 +18091,7 @@
           <a:ln/>
           <a:effectLst>
             <a:outerShdw sx="100000" sy="100000" kx="0" ky="0" algn="bl" rotWithShape="0" blurRad="76200" dist="38100" dir="5400000">
-              <a:srgbClr val="2A1640">
+              <a:srgbClr val="1A1033">
                 <a:alpha val="35000"/>
               </a:srgbClr>
             </a:outerShdw>
@@ -18113,7 +18225,7 @@
       </p:grpSpPr>
       <p:sp>
         <p:nvSpPr>
-          <p:cNvPr id="2" name="3D-Karte Bildfläche"/>
+          <p:cNvPr id="2" name="3D-Karte Bildschatten"/>
           <p:cNvSpPr/>
           <p:nvPr/>
         </p:nvSpPr>
@@ -18128,13 +18240,13 @@
             </a:avLst>
           </a:prstGeom>
           <a:solidFill>
-            <a:schemeClr val="bg2"/>
+            <a:schemeClr val="bg1"/>
           </a:solidFill>
           <a:ln/>
           <a:effectLst>
-            <a:outerShdw sx="100000" sy="100000" kx="0" ky="0" algn="bl" rotWithShape="0" blurRad="124460" dist="53340" dir="5400000">
-              <a:srgbClr val="2A1640">
-                <a:alpha val="15400"/>
+            <a:outerShdw sx="100000" sy="100000" kx="0" ky="0" algn="bl" rotWithShape="0" blurRad="284480" dist="121920" dir="5400000">
+              <a:srgbClr val="1A1033">
+                <a:alpha val="35200"/>
               </a:srgbClr>
             </a:outerShdw>
           </a:effectLst>
@@ -18149,24 +18261,22 @@
       </p:sp>
       <p:pic>
         <p:nvPicPr>
-          <p:cNvPr id="3" name="Bildhinweis" descr="preencoded.png">    </p:cNvPr>
+          <p:cNvPr id="3" name="Illustration karneval" descr="art/karneval.png">    </p:cNvPr>
           <p:cNvPicPr>
             <a:picLocks noChangeAspect="1"/>
           </p:cNvPicPr>
           <p:nvPr/>
         </p:nvPicPr>
         <p:blipFill>
-          <a:blip r:embed="rId1">
-            <a:alphaModFix amt="40000"/>
-          </a:blip>
+          <a:blip r:embed="rId1"/>
           <a:stretch>
             <a:fillRect/>
           </a:stretch>
         </p:blipFill>
         <p:spPr>
           <a:xfrm>
-            <a:off x="8801100" y="3474720"/>
-            <a:ext cx="731520" cy="731520"/>
+            <a:off x="6720840" y="1600200"/>
+            <a:ext cx="4892040" cy="4480560"/>
           </a:xfrm>
           <a:prstGeom prst="rect">
             <a:avLst/>
@@ -18584,37 +18694,7 @@
       </p:sp>
       <p:sp>
         <p:nvSpPr>
-          <p:cNvPr id="14" name="Text 0"/>
-          <p:cNvSpPr/>
-          <p:nvPr>
-            <p:ph idx="102" hasCustomPrompt="1"/>
-          </p:nvPr>
-        </p:nvSpPr>
-        <p:spPr>
-          <a:xfrm>
-            <a:off x="6720840" y="1600200"/>
-            <a:ext cx="4892040" cy="4480560"/>
-          </a:xfrm>
-          <a:prstGeom prst="rect">
-            <a:avLst/>
-          </a:prstGeom>
-          <a:noFill/>
-          <a:ln/>
-        </p:spPr>
-        <p:txBody>
-          <a:bodyPr wrap="square" lIns="0" tIns="0" rIns="0" bIns="0" rtlCol="0" anchor="t"/>
-          <a:lstStyle/>
-          <a:p>
-            <a:pPr indent="0" marL="0">
-              <a:buNone/>
-            </a:pPr>
-            <a:endParaRPr lang="en-US" dirty="0"/>
-          </a:p>
-        </p:txBody>
-      </p:sp>
-      <p:sp>
-        <p:nvSpPr>
-          <p:cNvPr id="15" name="Quelle"/>
+          <p:cNvPr id="14" name="Quelle"/>
           <p:cNvSpPr txBox="1"/>
           <p:nvPr/>
         </p:nvSpPr>
@@ -18645,6 +18725,36 @@
               <a:t>Quelle: Erzbistum Köln</a:t>
             </a:r>
             <a:endParaRPr lang="en-US" sz="1000" dirty="0"/>
+          </a:p>
+        </p:txBody>
+      </p:sp>
+      <p:sp>
+        <p:nvSpPr>
+          <p:cNvPr id="15" name="Text 0"/>
+          <p:cNvSpPr/>
+          <p:nvPr>
+            <p:ph idx="102" hasCustomPrompt="1"/>
+          </p:nvPr>
+        </p:nvSpPr>
+        <p:spPr>
+          <a:xfrm>
+            <a:off x="6720840" y="1600200"/>
+            <a:ext cx="4892040" cy="4480560"/>
+          </a:xfrm>
+          <a:prstGeom prst="rect">
+            <a:avLst/>
+          </a:prstGeom>
+          <a:noFill/>
+          <a:ln/>
+        </p:spPr>
+        <p:txBody>
+          <a:bodyPr wrap="square" lIns="0" tIns="0" rIns="0" bIns="0" rtlCol="0" anchor="t"/>
+          <a:lstStyle/>
+          <a:p>
+            <a:pPr indent="0" marL="0">
+              <a:buNone/>
+            </a:pPr>
+            <a:endParaRPr lang="en-US" dirty="0"/>
           </a:p>
         </p:txBody>
       </p:sp>
@@ -18740,7 +18850,7 @@
           <a:ln/>
           <a:effectLst>
             <a:outerShdw sx="100000" sy="100000" kx="0" ky="0" algn="bl" rotWithShape="0" blurRad="177800" dist="76200" dir="5400000">
-              <a:srgbClr val="2A1640">
+              <a:srgbClr val="1A1033">
                 <a:alpha val="22000"/>
               </a:srgbClr>
             </a:outerShdw>
@@ -18774,7 +18884,7 @@
           <a:ln/>
           <a:effectLst>
             <a:outerShdw sx="100000" sy="100000" kx="0" ky="0" algn="bl" rotWithShape="0" blurRad="142240" dist="60960" dir="5400000">
-              <a:srgbClr val="2A1640">
+              <a:srgbClr val="1A1033">
                 <a:alpha val="17600"/>
               </a:srgbClr>
             </a:outerShdw>
@@ -18834,7 +18944,7 @@
           <a:ln/>
           <a:effectLst>
             <a:outerShdw sx="100000" sy="100000" kx="0" ky="0" algn="bl" rotWithShape="0" blurRad="177800" dist="76200" dir="5400000">
-              <a:srgbClr val="2A1640">
+              <a:srgbClr val="1A1033">
                 <a:alpha val="22000"/>
               </a:srgbClr>
             </a:outerShdw>
@@ -18868,7 +18978,7 @@
           <a:ln/>
           <a:effectLst>
             <a:outerShdw sx="100000" sy="100000" kx="0" ky="0" algn="bl" rotWithShape="0" blurRad="142240" dist="60960" dir="5400000">
-              <a:srgbClr val="2A1640">
+              <a:srgbClr val="1A1033">
                 <a:alpha val="17600"/>
               </a:srgbClr>
             </a:outerShdw>
@@ -18928,7 +19038,7 @@
           <a:ln/>
           <a:effectLst>
             <a:outerShdw sx="100000" sy="100000" kx="0" ky="0" algn="bl" rotWithShape="0" blurRad="177800" dist="76200" dir="5400000">
-              <a:srgbClr val="2A1640">
+              <a:srgbClr val="1A1033">
                 <a:alpha val="22000"/>
               </a:srgbClr>
             </a:outerShdw>
@@ -18962,7 +19072,7 @@
           <a:ln/>
           <a:effectLst>
             <a:outerShdw sx="100000" sy="100000" kx="0" ky="0" algn="bl" rotWithShape="0" blurRad="142240" dist="60960" dir="5400000">
-              <a:srgbClr val="2A1640">
+              <a:srgbClr val="1A1033">
                 <a:alpha val="17600"/>
               </a:srgbClr>
             </a:outerShdw>
@@ -19998,7 +20108,7 @@
           <a:ln/>
           <a:effectLst>
             <a:outerShdw sx="100000" sy="100000" kx="0" ky="0" algn="bl" rotWithShape="0" blurRad="355600" dist="152400" dir="5400000">
-              <a:srgbClr val="2A1640">
+              <a:srgbClr val="1A1033">
                 <a:alpha val="44000"/>
               </a:srgbClr>
             </a:outerShdw>
@@ -20054,7 +20164,7 @@
           <a:ln/>
           <a:effectLst>
             <a:outerShdw sx="100000" sy="100000" kx="0" ky="0" algn="bl" rotWithShape="0" blurRad="76200" dist="38100" dir="5400000">
-              <a:srgbClr val="2A1640">
+              <a:srgbClr val="1A1033">
                 <a:alpha val="35000"/>
               </a:srgbClr>
             </a:outerShdw>
@@ -20229,7 +20339,7 @@
           <a:ln/>
           <a:effectLst>
             <a:outerShdw sx="100000" sy="100000" kx="0" ky="0" algn="bl" rotWithShape="0" blurRad="142240" dist="60960" dir="5400000">
-              <a:srgbClr val="2A1640">
+              <a:srgbClr val="1A1033">
                 <a:alpha val="17600"/>
               </a:srgbClr>
             </a:outerShdw>
@@ -20378,7 +20488,7 @@
           <a:ln/>
           <a:effectLst>
             <a:outerShdw sx="100000" sy="100000" kx="0" ky="0" algn="bl" rotWithShape="0" blurRad="142240" dist="60960" dir="5400000">
-              <a:srgbClr val="2A1640">
+              <a:srgbClr val="1A1033">
                 <a:alpha val="17600"/>
               </a:srgbClr>
             </a:outerShdw>
@@ -20527,7 +20637,7 @@
           <a:ln/>
           <a:effectLst>
             <a:outerShdw sx="100000" sy="100000" kx="0" ky="0" algn="bl" rotWithShape="0" blurRad="142240" dist="60960" dir="5400000">
-              <a:srgbClr val="2A1640">
+              <a:srgbClr val="1A1033">
                 <a:alpha val="17600"/>
               </a:srgbClr>
             </a:outerShdw>
@@ -20676,7 +20786,7 @@
           <a:ln/>
           <a:effectLst>
             <a:outerShdw sx="100000" sy="100000" kx="0" ky="0" algn="bl" rotWithShape="0" blurRad="142240" dist="60960" dir="5400000">
-              <a:srgbClr val="2A1640">
+              <a:srgbClr val="1A1033">
                 <a:alpha val="17600"/>
               </a:srgbClr>
             </a:outerShdw>
@@ -20972,7 +21082,7 @@
           <a:ln/>
           <a:effectLst>
             <a:outerShdw sx="100000" sy="100000" kx="0" ky="0" algn="bl" rotWithShape="0" blurRad="248920" dist="106680" dir="5400000">
-              <a:srgbClr val="2A1640">
+              <a:srgbClr val="1A1033">
                 <a:alpha val="30800"/>
               </a:srgbClr>
             </a:outerShdw>
@@ -21028,7 +21138,7 @@
           <a:ln/>
           <a:effectLst>
             <a:outerShdw sx="100000" sy="100000" kx="0" ky="0" algn="bl" rotWithShape="0" blurRad="248920" dist="106680" dir="5400000">
-              <a:srgbClr val="2A1640">
+              <a:srgbClr val="1A1033">
                 <a:alpha val="30800"/>
               </a:srgbClr>
             </a:outerShdw>
@@ -21084,7 +21194,7 @@
           <a:ln/>
           <a:effectLst>
             <a:outerShdw sx="100000" sy="100000" kx="0" ky="0" algn="bl" rotWithShape="0" blurRad="248920" dist="106680" dir="5400000">
-              <a:srgbClr val="2A1640">
+              <a:srgbClr val="1A1033">
                 <a:alpha val="30800"/>
               </a:srgbClr>
             </a:outerShdw>
@@ -21140,7 +21250,7 @@
           <a:ln/>
           <a:effectLst>
             <a:outerShdw sx="100000" sy="100000" kx="0" ky="0" algn="bl" rotWithShape="0" blurRad="248920" dist="106680" dir="5400000">
-              <a:srgbClr val="2A1640">
+              <a:srgbClr val="1A1033">
                 <a:alpha val="30800"/>
               </a:srgbClr>
             </a:outerShdw>
@@ -21520,7 +21630,7 @@
           <a:ln/>
           <a:effectLst>
             <a:outerShdw sx="100000" sy="100000" kx="0" ky="0" algn="bl" rotWithShape="0" blurRad="76200" dist="38100" dir="5400000">
-              <a:srgbClr val="2A1640">
+              <a:srgbClr val="1A1033">
                 <a:alpha val="35000"/>
               </a:srgbClr>
             </a:outerShdw>
@@ -21654,7 +21764,7 @@
       </p:grpSpPr>
       <p:sp>
         <p:nvSpPr>
-          <p:cNvPr id="2" name="3D-Karte Bildfläche"/>
+          <p:cNvPr id="2" name="3D-Karte Bildschatten"/>
           <p:cNvSpPr/>
           <p:nvPr/>
         </p:nvSpPr>
@@ -21669,13 +21779,13 @@
             </a:avLst>
           </a:prstGeom>
           <a:solidFill>
-            <a:schemeClr val="bg2"/>
+            <a:schemeClr val="bg1"/>
           </a:solidFill>
           <a:ln/>
           <a:effectLst>
-            <a:outerShdw sx="100000" sy="100000" kx="0" ky="0" algn="bl" rotWithShape="0" blurRad="124460" dist="53340" dir="5400000">
-              <a:srgbClr val="2A1640">
-                <a:alpha val="15400"/>
+            <a:outerShdw sx="100000" sy="100000" kx="0" ky="0" algn="bl" rotWithShape="0" blurRad="284480" dist="121920" dir="5400000">
+              <a:srgbClr val="1A1033">
+                <a:alpha val="35200"/>
               </a:srgbClr>
             </a:outerShdw>
           </a:effectLst>
@@ -21690,24 +21800,22 @@
       </p:sp>
       <p:pic>
         <p:nvPicPr>
-          <p:cNvPr id="3" name="Bildhinweis" descr="preencoded.png">    </p:cNvPr>
+          <p:cNvPr id="3" name="Illustration ostern" descr="art/ostern.png">    </p:cNvPr>
           <p:cNvPicPr>
             <a:picLocks noChangeAspect="1"/>
           </p:cNvPicPr>
           <p:nvPr/>
         </p:nvPicPr>
         <p:blipFill>
-          <a:blip r:embed="rId1">
-            <a:alphaModFix amt="40000"/>
-          </a:blip>
+          <a:blip r:embed="rId1"/>
           <a:stretch>
             <a:fillRect/>
           </a:stretch>
         </p:blipFill>
         <p:spPr>
           <a:xfrm>
-            <a:off x="2628900" y="3474720"/>
-            <a:ext cx="731520" cy="731520"/>
+            <a:off x="548640" y="1600200"/>
+            <a:ext cx="4892040" cy="4480560"/>
           </a:xfrm>
           <a:prstGeom prst="rect">
             <a:avLst/>
@@ -21734,7 +21842,7 @@
           <a:ln/>
           <a:effectLst>
             <a:outerShdw sx="100000" sy="100000" kx="0" ky="0" algn="bl" rotWithShape="0" blurRad="248920" dist="106680" dir="5400000">
-              <a:srgbClr val="2A1640">
+              <a:srgbClr val="1A1033">
                 <a:alpha val="30800"/>
               </a:srgbClr>
             </a:outerShdw>
@@ -21790,7 +21898,7 @@
           <a:ln/>
           <a:effectLst>
             <a:outerShdw sx="100000" sy="100000" kx="0" ky="0" algn="bl" rotWithShape="0" blurRad="248920" dist="106680" dir="5400000">
-              <a:srgbClr val="2A1640">
+              <a:srgbClr val="1A1033">
                 <a:alpha val="30800"/>
               </a:srgbClr>
             </a:outerShdw>
@@ -21846,7 +21954,7 @@
           <a:ln/>
           <a:effectLst>
             <a:outerShdw sx="100000" sy="100000" kx="0" ky="0" algn="bl" rotWithShape="0" blurRad="248920" dist="106680" dir="5400000">
-              <a:srgbClr val="2A1640">
+              <a:srgbClr val="1A1033">
                 <a:alpha val="30800"/>
               </a:srgbClr>
             </a:outerShdw>
@@ -21926,36 +22034,6 @@
       <p:sp>
         <p:nvSpPr>
           <p:cNvPr id="11" name="Text 0"/>
-          <p:cNvSpPr/>
-          <p:nvPr>
-            <p:ph idx="101" hasCustomPrompt="1"/>
-          </p:nvPr>
-        </p:nvSpPr>
-        <p:spPr>
-          <a:xfrm>
-            <a:off x="548640" y="1600200"/>
-            <a:ext cx="4892040" cy="4480560"/>
-          </a:xfrm>
-          <a:prstGeom prst="rect">
-            <a:avLst/>
-          </a:prstGeom>
-          <a:noFill/>
-          <a:ln/>
-        </p:spPr>
-        <p:txBody>
-          <a:bodyPr wrap="square" lIns="0" tIns="0" rIns="0" bIns="0" rtlCol="0" anchor="t"/>
-          <a:lstStyle/>
-          <a:p>
-            <a:pPr indent="0" marL="0">
-              <a:buNone/>
-            </a:pPr>
-            <a:endParaRPr lang="en-US" dirty="0"/>
-          </a:p>
-        </p:txBody>
-      </p:sp>
-      <p:sp>
-        <p:nvSpPr>
-          <p:cNvPr id="12" name="Text 0"/>
           <p:cNvSpPr/>
           <p:nvPr>
             <p:ph idx="102" type="body" hasCustomPrompt="1"/>
@@ -22107,7 +22185,7 @@
       </p:sp>
       <p:sp>
         <p:nvSpPr>
-          <p:cNvPr id="13" name="Quelle"/>
+          <p:cNvPr id="12" name="Quelle"/>
           <p:cNvSpPr txBox="1"/>
           <p:nvPr/>
         </p:nvSpPr>
@@ -22138,6 +22216,36 @@
               <a:t>Quelle: ZDFheute</a:t>
             </a:r>
             <a:endParaRPr lang="en-US" sz="1000" dirty="0"/>
+          </a:p>
+        </p:txBody>
+      </p:sp>
+      <p:sp>
+        <p:nvSpPr>
+          <p:cNvPr id="13" name="Text 0"/>
+          <p:cNvSpPr/>
+          <p:nvPr>
+            <p:ph idx="101" hasCustomPrompt="1"/>
+          </p:nvPr>
+        </p:nvSpPr>
+        <p:spPr>
+          <a:xfrm>
+            <a:off x="548640" y="1600200"/>
+            <a:ext cx="4892040" cy="4480560"/>
+          </a:xfrm>
+          <a:prstGeom prst="rect">
+            <a:avLst/>
+          </a:prstGeom>
+          <a:noFill/>
+          <a:ln/>
+        </p:spPr>
+        <p:txBody>
+          <a:bodyPr wrap="square" lIns="0" tIns="0" rIns="0" bIns="0" rtlCol="0" anchor="t"/>
+          <a:lstStyle/>
+          <a:p>
+            <a:pPr indent="0" marL="0">
+              <a:buNone/>
+            </a:pPr>
+            <a:endParaRPr lang="en-US" dirty="0"/>
           </a:p>
         </p:txBody>
       </p:sp>
@@ -22199,40 +22307,40 @@
   <a:themeElements>
     <a:clrScheme name="Karneval und Ostern">
       <a:dk1>
-        <a:srgbClr val="2A1640"/>
+        <a:srgbClr val="1A1033"/>
       </a:dk1>
       <a:lt1>
         <a:srgbClr val="FFFFFF"/>
       </a:lt1>
       <a:dk2>
-        <a:srgbClr val="5B3A7E"/>
+        <a:srgbClr val="6A3FB5"/>
       </a:dk2>
       <a:lt2>
-        <a:srgbClr val="F6F2FA"/>
+        <a:srgbClr val="F4F0FF"/>
       </a:lt2>
       <a:accent1>
-        <a:srgbClr val="E4364B"/>
+        <a:srgbClr val="FF2E63"/>
       </a:accent1>
       <a:accent2>
-        <a:srgbClr val="FFB81C"/>
+        <a:srgbClr val="FFB703"/>
       </a:accent2>
       <a:accent3>
-        <a:srgbClr val="1FA38A"/>
+        <a:srgbClr val="0FB5A6"/>
       </a:accent3>
       <a:accent4>
-        <a:srgbClr val="3D7DF2"/>
+        <a:srgbClr val="3A6FF7"/>
       </a:accent4>
       <a:accent5>
-        <a:srgbClr val="B6DFA0"/>
+        <a:srgbClr val="9BE3B0"/>
       </a:accent5>
       <a:accent6>
-        <a:srgbClr val="F6B5D4"/>
+        <a:srgbClr val="FFB3D1"/>
       </a:accent6>
       <a:hlink>
-        <a:srgbClr val="3D7DF2"/>
+        <a:srgbClr val="3A6FF7"/>
       </a:hlink>
       <a:folHlink>
-        <a:srgbClr val="5B3A7E"/>
+        <a:srgbClr val="6A3FB5"/>
       </a:folHlink>
     </a:clrScheme>
     <a:fontScheme name="Karneval und Ostern">

</xml_diff>

<commit_message>
Aufgabe 7 mit ALDI-SÜD-Beispielen ergänzen
Eigene Folie zu Saisonware, Aktionen sowie Feiertagen und Dienstplan
bei ALDI SÜD, Quellenangaben auf der Quellenfolie ergänzt.

Co-Authored-By: Claude Opus 5.5 <noreply@anthropic.com>
Claude-Session: https://claude.ai/code/session_01EsbPSfyjZCqBtDb5d3uQeV
</commit_message>
<xml_diff>
--- a/Karneval_und_Ostern.pptx
+++ b/Karneval_und_Ostern.pptx
@@ -25,9 +25,10 @@
     <p:sldId id="273" r:id="rId19"/>
     <p:sldId id="274" r:id="rId20"/>
     <p:sldId id="275" r:id="rId21"/>
+    <p:sldId id="276" r:id="rId22"/>
   </p:sldIdLst>
   <p:notesMasterIdLst>
-    <p:notesMasterId r:id="rId22"/>
+    <p:notesMasterId r:id="rId23"/>
   </p:notesMasterIdLst>
   <p:sldSz cx="12192000" cy="6858000"/>
   <p:notesSz cx="6858000" cy="12192000"/>
@@ -126,13 +127,13 @@
   <p:extLst>
     <p:ext uri="{521415D9-36F7-43E2-AB2F-B90AF26B5E84}">
       <p14:sectionLst xmlns:p14="http://schemas.microsoft.com/office/powerpoint/2010/main">
-        <p14:section name="Einstieg" id="{c727b1dd-c3bf-08ce-3486-613778842c6f}">
+        <p14:section name="Einstieg" id="{604d9fda-8042-7380-47d3-3e23b0becd1b}">
           <p14:sldIdLst>
             <p14:sldId id="256"/>
             <p14:sldId id="257"/>
           </p14:sldIdLst>
         </p14:section>
-        <p14:section name="Karneval" id="{77e6cbdb-c071-f80f-c90f-a0f8b5bfb2fd}">
+        <p14:section name="Karneval" id="{b19c8424-377e-a99d-0c70-f6e8ac805c96}">
           <p14:sldIdLst>
             <p14:sldId id="258"/>
             <p14:sldId id="259"/>
@@ -140,13 +141,13 @@
             <p14:sldId id="261"/>
           </p14:sldIdLst>
         </p14:section>
-        <p14:section name="Fastenzeit" id="{8d88e452-9469-2169-74b2-cc0324e2e26c}">
+        <p14:section name="Fastenzeit" id="{2b356bec-be95-0068-c29e-d0b4699dbb36}">
           <p14:sldIdLst>
             <p14:sldId id="262"/>
             <p14:sldId id="263"/>
           </p14:sldIdLst>
         </p14:section>
-        <p14:section name="Ostern" id="{b77610db-ba45-ebf7-ad44-10816eefb4db}">
+        <p14:section name="Ostern" id="{10bc8eb9-3a9e-55d7-8964-7ab74131a4fd}">
           <p14:sldIdLst>
             <p14:sldId id="264"/>
             <p14:sldId id="265"/>
@@ -154,7 +155,7 @@
             <p14:sldId id="267"/>
           </p14:sldIdLst>
         </p14:section>
-        <p14:section name="Andere Religionen" id="{65753a96-264d-b8db-7cf3-716d794cefd0}">
+        <p14:section name="Andere Religionen" id="{d5f62f1e-b3a4-60b5-37f7-f4dd7f0f053a}">
           <p14:sldIdLst>
             <p14:sldId id="268"/>
             <p14:sldId id="269"/>
@@ -162,12 +163,13 @@
             <p14:sldId id="271"/>
           </p14:sldIdLst>
         </p14:section>
-        <p14:section name="Abschluss" id="{a5811b28-9a53-f686-1cc2-10c0b75747e5}">
+        <p14:section name="Abschluss" id="{441c3365-53e4-9015-74cd-54919125d990}">
           <p14:sldIdLst>
             <p14:sldId id="272"/>
             <p14:sldId id="273"/>
             <p14:sldId id="274"/>
             <p14:sldId id="275"/>
+            <p14:sldId id="276"/>
           </p14:sldIdLst>
         </p14:section>
       </p14:sectionLst>
@@ -1654,6 +1656,94 @@
             <a:fld id="{F7021451-1387-4CA6-816F-3879F97B5CBC}" type="slidenum">
               <a:rPr lang="en-US"/>
               <a:t>20</a:t>
+            </a:fld>
+            <a:endParaRPr lang="en-US"/>
+          </a:p>
+        </p:txBody>
+      </p:sp>
+    </p:spTree>
+    <p:extLst>
+      <p:ext uri="{BB962C8B-B14F-4D97-AF65-F5344CB8AC3E}">
+        <p14:creationId xmlns:p14="http://schemas.microsoft.com/office/powerpoint/2010/main" val="1024086991"/>
+      </p:ext>
+    </p:extLst>
+  </p:cSld>
+  <p:clrMapOvr>
+    <a:masterClrMapping/>
+  </p:clrMapOvr>
+</p:notes>
+</file>
+
+<file path=ppt/notesSlides/notesSlide21.xml><?xml version="1.0" encoding="utf-8"?>
+<p:notes xmlns:a="http://schemas.openxmlformats.org/drawingml/2006/main" xmlns:r="http://schemas.openxmlformats.org/officeDocument/2006/relationships" xmlns:p="http://schemas.openxmlformats.org/presentationml/2006/main">
+  <p:cSld>
+    <p:spTree>
+      <p:nvGrpSpPr>
+        <p:cNvPr id="1" name=""/>
+        <p:cNvGrpSpPr/>
+        <p:nvPr/>
+      </p:nvGrpSpPr>
+      <p:grpSpPr>
+        <a:xfrm>
+          <a:off x="0" y="0"/>
+          <a:ext cx="0" cy="0"/>
+          <a:chOff x="0" y="0"/>
+          <a:chExt cx="0" cy="0"/>
+        </a:xfrm>
+      </p:grpSpPr>
+      <p:sp>
+        <p:nvSpPr>
+          <p:cNvPr id="2" name="Slide Image Placeholder 1"/>
+          <p:cNvSpPr>
+            <a:spLocks noGrp="1" noRot="1" noChangeAspect="1"/>
+          </p:cNvSpPr>
+          <p:nvPr>
+            <p:ph type="sldImg"/>
+          </p:nvPr>
+        </p:nvSpPr>
+        <p:spPr/>
+      </p:sp>
+      <p:sp>
+        <p:nvSpPr>
+          <p:cNvPr id="3" name="Notes Placeholder 2"/>
+          <p:cNvSpPr>
+            <a:spLocks noGrp="1"/>
+          </p:cNvSpPr>
+          <p:nvPr>
+            <p:ph type="body" idx="1"/>
+          </p:nvPr>
+        </p:nvSpPr>
+        <p:spPr/>
+        <p:txBody>
+          <a:bodyPr/>
+          <a:lstStyle/>
+          <a:p>
+            <a:r>
+              <a:rPr lang="en-US" dirty="0"/>
+              <a:t/>
+            </a:r>
+            <a:endParaRPr lang="en-US" dirty="0"/>
+          </a:p>
+        </p:txBody>
+      </p:sp>
+      <p:sp>
+        <p:nvSpPr>
+          <p:cNvPr id="4" name="Slide Number Placeholder 3"/>
+          <p:cNvSpPr>
+            <a:spLocks noGrp="1"/>
+          </p:cNvSpPr>
+          <p:nvPr>
+            <p:ph type="sldNum" sz="quarter" idx="10"/>
+          </p:nvPr>
+        </p:nvSpPr>
+        <p:spPr/>
+        <p:txBody>
+          <a:bodyPr/>
+          <a:lstStyle/>
+          <a:p>
+            <a:fld id="{F7021451-1387-4CA6-816F-3879F97B5CBC}" type="slidenum">
+              <a:rPr lang="en-US"/>
+              <a:t>21</a:t>
             </a:fld>
             <a:endParaRPr lang="en-US"/>
           </a:p>
@@ -9198,9 +9288,100 @@
           <a:chExt cx="0" cy="0"/>
         </a:xfrm>
       </p:grpSpPr>
-      <p:sp>
-        <p:nvSpPr>
-          <p:cNvPr id="2" name="Text 0"/>
+      <p:pic>
+        <p:nvPicPr>
+          <p:cNvPr id="2" name="Foto Maske" descr="p2/half-maske.jpg">    </p:cNvPr>
+          <p:cNvPicPr>
+            <a:picLocks noChangeAspect="1"/>
+          </p:cNvPicPr>
+          <p:nvPr/>
+        </p:nvPicPr>
+        <p:blipFill>
+          <a:blip r:embed="rId1"/>
+          <a:srcRect l="0" r="0" t="0" b="0"/>
+          <a:stretch/>
+        </p:blipFill>
+        <p:spPr>
+          <a:xfrm>
+            <a:off x="6766560" y="0"/>
+            <a:ext cx="5422392" cy="6858000"/>
+          </a:xfrm>
+          <a:prstGeom prst="rect">
+            <a:avLst/>
+          </a:prstGeom>
+        </p:spPr>
+      </p:pic>
+      <p:sp>
+        <p:nvSpPr>
+          <p:cNvPr id="3" name="Rahmen"/>
+          <p:cNvSpPr/>
+          <p:nvPr/>
+        </p:nvSpPr>
+        <p:spPr>
+          <a:xfrm>
+            <a:off x="7269480" y="548640"/>
+            <a:ext cx="4389120" cy="5760720"/>
+          </a:xfrm>
+          <a:prstGeom prst="rect">
+            <a:avLst/>
+          </a:prstGeom>
+          <a:ln w="15875">
+            <a:solidFill>
+              <a:schemeClr val="bg1"/>
+            </a:solidFill>
+            <a:prstDash val="solid"/>
+          </a:ln>
+        </p:spPr>
+      </p:sp>
+      <p:sp>
+        <p:nvSpPr>
+          <p:cNvPr id="4" name="Plus"/>
+          <p:cNvSpPr/>
+          <p:nvPr/>
+        </p:nvSpPr>
+        <p:spPr>
+          <a:xfrm>
+            <a:off x="7104888" y="6309360"/>
+            <a:ext cx="329184" cy="0"/>
+          </a:xfrm>
+          <a:prstGeom prst="line">
+            <a:avLst/>
+          </a:prstGeom>
+          <a:noFill/>
+          <a:ln w="19050">
+            <a:solidFill>
+              <a:schemeClr val="bg1"/>
+            </a:solidFill>
+            <a:prstDash val="solid"/>
+          </a:ln>
+        </p:spPr>
+      </p:sp>
+      <p:sp>
+        <p:nvSpPr>
+          <p:cNvPr id="5" name="Plus"/>
+          <p:cNvSpPr/>
+          <p:nvPr/>
+        </p:nvSpPr>
+        <p:spPr>
+          <a:xfrm>
+            <a:off x="7269480" y="6144768"/>
+            <a:ext cx="0" cy="329184"/>
+          </a:xfrm>
+          <a:prstGeom prst="line">
+            <a:avLst/>
+          </a:prstGeom>
+          <a:noFill/>
+          <a:ln w="19050">
+            <a:solidFill>
+              <a:schemeClr val="bg1"/>
+            </a:solidFill>
+            <a:prstDash val="solid"/>
+          </a:ln>
+        </p:spPr>
+      </p:sp>
+      <p:sp>
+        <p:nvSpPr>
+          <p:cNvPr id="6" name="Text 3"/>
           <p:cNvSpPr txBox="1"/>
           <p:nvPr/>
         </p:nvSpPr>
@@ -9228,7 +9409,7 @@
                   <a:schemeClr val="accent1"/>
                 </a:solidFill>
               </a:rPr>
-              <a:t>AUFGABEN 6 &amp; 7</a:t>
+              <a:t>AUFGABE 6 · AUSGANGSSITUATION</a:t>
             </a:r>
             <a:endParaRPr lang="en-US" sz="1100" dirty="0"/>
           </a:p>
@@ -9236,14 +9417,14 @@
       </p:sp>
       <p:sp>
         <p:nvSpPr>
-          <p:cNvPr id="3" name="Feld Antwort an den Kunden"/>
+          <p:cNvPr id="7" name="Feld Kundenantwort"/>
           <p:cNvSpPr/>
           <p:nvPr/>
         </p:nvSpPr>
         <p:spPr>
           <a:xfrm>
             <a:off x="640080" y="1691640"/>
-            <a:ext cx="5349240" cy="4343400"/>
+            <a:ext cx="5577840" cy="4343400"/>
           </a:xfrm>
           <a:prstGeom prst="rect">
             <a:avLst/>
@@ -9256,7 +9437,7 @@
       </p:sp>
       <p:sp>
         <p:nvSpPr>
-          <p:cNvPr id="4" name="Text 2"/>
+          <p:cNvPr id="8" name="Text 5"/>
           <p:cNvSpPr txBox="1"/>
           <p:nvPr/>
         </p:nvSpPr>
@@ -9292,14 +9473,14 @@
       </p:sp>
       <p:sp>
         <p:nvSpPr>
-          <p:cNvPr id="5" name="Text 3"/>
+          <p:cNvPr id="9" name="Text 6"/>
           <p:cNvSpPr txBox="1"/>
           <p:nvPr/>
         </p:nvSpPr>
         <p:spPr>
           <a:xfrm>
             <a:off x="914400" y="2103120"/>
-            <a:ext cx="4754880" cy="411480"/>
+            <a:ext cx="5029200" cy="411480"/>
           </a:xfrm>
           <a:prstGeom prst="rect">
             <a:avLst/>
@@ -9328,145 +9509,7 @@
       </p:sp>
       <p:sp>
         <p:nvSpPr>
-          <p:cNvPr id="6" name="Feld Mein Ausbildungsbetrieb"/>
-          <p:cNvSpPr/>
-          <p:nvPr/>
-        </p:nvSpPr>
-        <p:spPr>
-          <a:xfrm>
-            <a:off x="6172200" y="1691640"/>
-            <a:ext cx="5349240" cy="4343400"/>
-          </a:xfrm>
-          <a:prstGeom prst="rect">
-            <a:avLst/>
-          </a:prstGeom>
-          <a:solidFill>
-            <a:schemeClr val="bg2"/>
-          </a:solidFill>
-          <a:ln/>
-        </p:spPr>
-      </p:sp>
-      <p:sp>
-        <p:nvSpPr>
-          <p:cNvPr id="7" name="Text 5"/>
-          <p:cNvSpPr txBox="1"/>
-          <p:nvPr/>
-        </p:nvSpPr>
-        <p:spPr>
-          <a:xfrm>
-            <a:off x="6446520" y="1874520"/>
-            <a:ext cx="4572000" cy="274320"/>
-          </a:xfrm>
-          <a:prstGeom prst="rect">
-            <a:avLst/>
-          </a:prstGeom>
-          <a:noFill/>
-          <a:ln/>
-        </p:spPr>
-        <p:txBody>
-          <a:bodyPr wrap="square" lIns="0" tIns="0" rIns="0" bIns="0" rtlCol="0" anchor="t"/>
-          <a:lstStyle/>
-          <a:p>
-            <a:pPr indent="0" marL="0">
-              <a:buNone/>
-            </a:pPr>
-            <a:r>
-              <a:rPr lang="en-US" sz="1000" b="1" spc="400" kern="0" dirty="0">
-                <a:solidFill>
-                  <a:schemeClr val="accent1"/>
-                </a:solidFill>
-              </a:rPr>
-              <a:t>AUFGABE 7</a:t>
-            </a:r>
-            <a:endParaRPr lang="en-US" sz="1000" dirty="0"/>
-          </a:p>
-        </p:txBody>
-      </p:sp>
-      <p:sp>
-        <p:nvSpPr>
-          <p:cNvPr id="8" name="Text 6"/>
-          <p:cNvSpPr txBox="1"/>
-          <p:nvPr/>
-        </p:nvSpPr>
-        <p:spPr>
-          <a:xfrm>
-            <a:off x="6446520" y="2103120"/>
-            <a:ext cx="4754880" cy="411480"/>
-          </a:xfrm>
-          <a:prstGeom prst="rect">
-            <a:avLst/>
-          </a:prstGeom>
-          <a:noFill/>
-          <a:ln/>
-        </p:spPr>
-        <p:txBody>
-          <a:bodyPr wrap="square" lIns="0" tIns="0" rIns="0" bIns="0" rtlCol="0" anchor="t"/>
-          <a:lstStyle/>
-          <a:p>
-            <a:pPr indent="0" marL="0">
-              <a:buNone/>
-            </a:pPr>
-            <a:r>
-              <a:rPr lang="en-US" sz="1900" b="1" dirty="0">
-                <a:solidFill>
-                  <a:schemeClr val="tx1"/>
-                </a:solidFill>
-              </a:rPr>
-              <a:t>Mein Ausbildungsbetrieb</a:t>
-            </a:r>
-            <a:endParaRPr lang="en-US" sz="1900" dirty="0"/>
-          </a:p>
-        </p:txBody>
-      </p:sp>
-      <p:sp>
-        <p:nvSpPr>
-          <p:cNvPr id="9" name="Plus"/>
-          <p:cNvSpPr/>
-          <p:nvPr/>
-        </p:nvSpPr>
-        <p:spPr>
-          <a:xfrm>
-            <a:off x="11311128" y="1691640"/>
-            <a:ext cx="329184" cy="0"/>
-          </a:xfrm>
-          <a:prstGeom prst="line">
-            <a:avLst/>
-          </a:prstGeom>
-          <a:noFill/>
-          <a:ln w="19050">
-            <a:solidFill>
-              <a:schemeClr val="accent1"/>
-            </a:solidFill>
-            <a:prstDash val="solid"/>
-          </a:ln>
-        </p:spPr>
-      </p:sp>
-      <p:sp>
-        <p:nvSpPr>
-          <p:cNvPr id="10" name="Plus"/>
-          <p:cNvSpPr/>
-          <p:nvPr/>
-        </p:nvSpPr>
-        <p:spPr>
-          <a:xfrm>
-            <a:off x="11475720" y="1527048"/>
-            <a:ext cx="0" cy="329184"/>
-          </a:xfrm>
-          <a:prstGeom prst="line">
-            <a:avLst/>
-          </a:prstGeom>
-          <a:noFill/>
-          <a:ln w="19050">
-            <a:solidFill>
-              <a:schemeClr val="accent1"/>
-            </a:solidFill>
-            <a:prstDash val="solid"/>
-          </a:ln>
-        </p:spPr>
-      </p:sp>
-      <p:sp>
-        <p:nvSpPr>
-          <p:cNvPr id="11" name="Text 0"/>
+          <p:cNvPr id="10" name="Text 0"/>
           <p:cNvSpPr/>
           <p:nvPr>
             <p:ph idx="100" type="title" hasCustomPrompt="1"/>
@@ -9507,7 +9550,7 @@
       </p:sp>
       <p:sp>
         <p:nvSpPr>
-          <p:cNvPr id="12" name="Text 0"/>
+          <p:cNvPr id="11" name="Text 0"/>
           <p:cNvSpPr/>
           <p:nvPr>
             <p:ph idx="101" type="body" hasCustomPrompt="1"/>
@@ -9540,7 +9583,7 @@
       </p:sp>
       <p:sp>
         <p:nvSpPr>
-          <p:cNvPr id="13" name="Text 0"/>
+          <p:cNvPr id="12" name="Text 0"/>
           <p:cNvSpPr/>
           <p:nvPr>
             <p:ph idx="102" type="body" hasCustomPrompt="1"/>
@@ -9567,65 +9610,6 @@
               </a:spcAft>
               <a:buNone/>
             </a:pPr>
-            <a:r>
-              <a:rPr lang="en-US" sz="1600" dirty="0">
-                <a:solidFill>
-                  <a:schemeClr val="tx1"/>
-                </a:solidFill>
-              </a:rPr>
-              <a:t>Karnevalsware ab: …</a:t>
-            </a:r>
-            <a:endParaRPr lang="en-US" sz="1600" dirty="0"/>
-          </a:p>
-          <a:p>
-            <a:pPr indent="0" marL="0">
-              <a:spcAft>
-                <a:spcPts val="600"/>
-              </a:spcAft>
-              <a:buNone/>
-            </a:pPr>
-            <a:r>
-              <a:rPr lang="en-US" sz="1600" dirty="0">
-                <a:solidFill>
-                  <a:schemeClr val="tx1"/>
-                </a:solidFill>
-              </a:rPr>
-              <a:t>Osterware ab: …</a:t>
-            </a:r>
-            <a:endParaRPr lang="en-US" sz="1600" dirty="0"/>
-          </a:p>
-          <a:p>
-            <a:pPr indent="0" marL="0">
-              <a:spcAft>
-                <a:spcPts val="600"/>
-              </a:spcAft>
-              <a:buNone/>
-            </a:pPr>
-            <a:r>
-              <a:rPr lang="en-US" sz="1600" dirty="0">
-                <a:solidFill>
-                  <a:schemeClr val="tx1"/>
-                </a:solidFill>
-              </a:rPr>
-              <a:t>Aktionen: …</a:t>
-            </a:r>
-            <a:endParaRPr lang="en-US" sz="1600" dirty="0"/>
-          </a:p>
-          <a:p>
-            <a:pPr indent="0" marL="0">
-              <a:spcAft>
-                <a:spcPts val="600"/>
-              </a:spcAft>
-              <a:buNone/>
-            </a:pPr>
-            <a:r>
-              <a:rPr lang="en-US" sz="1600" dirty="0">
-                <a:solidFill>
-                  <a:schemeClr val="tx1"/>
-                </a:solidFill>
-              </a:rPr>
-              <a:t>Feiertage, Öffnungszeiten &amp; Dienstplan: …</a:t>
-            </a:r>
             <a:endParaRPr lang="en-US" sz="1600" dirty="0"/>
           </a:p>
         </p:txBody>
@@ -9686,6 +9670,722 @@
 <file path=ppt/slides/slide18.xml><?xml version="1.0" encoding="utf-8"?>
 <p:sld xmlns:a="http://schemas.openxmlformats.org/drawingml/2006/main" xmlns:r="http://schemas.openxmlformats.org/officeDocument/2006/relationships" xmlns:p="http://schemas.openxmlformats.org/presentationml/2006/main">
   <p:cSld name="Slide 18">
+    <p:spTree>
+      <p:nvGrpSpPr>
+        <p:cNvPr id="1" name=""/>
+        <p:cNvGrpSpPr/>
+        <p:nvPr/>
+      </p:nvGrpSpPr>
+      <p:grpSpPr>
+        <a:xfrm>
+          <a:off x="0" y="0"/>
+          <a:ext cx="0" cy="0"/>
+          <a:chOff x="0" y="0"/>
+          <a:chExt cx="0" cy="0"/>
+        </a:xfrm>
+      </p:grpSpPr>
+      <p:sp>
+        <p:nvSpPr>
+          <p:cNvPr id="2" name="Text 0"/>
+          <p:cNvSpPr txBox="1"/>
+          <p:nvPr/>
+        </p:nvSpPr>
+        <p:spPr>
+          <a:xfrm>
+            <a:off x="640080" y="502920"/>
+            <a:ext cx="5486400" cy="274320"/>
+          </a:xfrm>
+          <a:prstGeom prst="rect">
+            <a:avLst/>
+          </a:prstGeom>
+          <a:noFill/>
+          <a:ln/>
+        </p:spPr>
+        <p:txBody>
+          <a:bodyPr wrap="square" lIns="0" tIns="0" rIns="0" bIns="0" rtlCol="0" anchor="t"/>
+          <a:lstStyle/>
+          <a:p>
+            <a:pPr indent="0" marL="0">
+              <a:buNone/>
+            </a:pPr>
+            <a:r>
+              <a:rPr lang="en-US" sz="1100" b="1" spc="500" kern="0" dirty="0">
+                <a:solidFill>
+                  <a:schemeClr val="accent1"/>
+                </a:solidFill>
+              </a:rPr>
+              <a:t>AUFGABE 7 · MEIN AUSBILDUNGSBETRIEB</a:t>
+            </a:r>
+            <a:endParaRPr lang="en-US" sz="1100" dirty="0"/>
+          </a:p>
+        </p:txBody>
+      </p:sp>
+      <p:sp>
+        <p:nvSpPr>
+          <p:cNvPr id="3" name="Text 1"/>
+          <p:cNvSpPr txBox="1"/>
+          <p:nvPr/>
+        </p:nvSpPr>
+        <p:spPr>
+          <a:xfrm>
+            <a:off x="640080" y="1783080"/>
+            <a:ext cx="3291840" cy="274320"/>
+          </a:xfrm>
+          <a:prstGeom prst="rect">
+            <a:avLst/>
+          </a:prstGeom>
+          <a:noFill/>
+          <a:ln/>
+        </p:spPr>
+        <p:txBody>
+          <a:bodyPr wrap="square" lIns="0" tIns="0" rIns="0" bIns="0" rtlCol="0" anchor="t"/>
+          <a:lstStyle/>
+          <a:p>
+            <a:pPr indent="0" marL="0">
+              <a:buNone/>
+            </a:pPr>
+            <a:r>
+              <a:rPr lang="en-US" sz="1000" b="1" spc="400" kern="0" dirty="0">
+                <a:solidFill>
+                  <a:schemeClr val="accent1"/>
+                </a:solidFill>
+              </a:rPr>
+              <a:t>AB WANN?</a:t>
+            </a:r>
+            <a:endParaRPr lang="en-US" sz="1000" dirty="0"/>
+          </a:p>
+        </p:txBody>
+      </p:sp>
+      <p:sp>
+        <p:nvSpPr>
+          <p:cNvPr id="4" name="Text 2"/>
+          <p:cNvSpPr txBox="1"/>
+          <p:nvPr/>
+        </p:nvSpPr>
+        <p:spPr>
+          <a:xfrm>
+            <a:off x="640080" y="2084832"/>
+            <a:ext cx="3291840" cy="457200"/>
+          </a:xfrm>
+          <a:prstGeom prst="rect">
+            <a:avLst/>
+          </a:prstGeom>
+          <a:noFill/>
+          <a:ln/>
+        </p:spPr>
+        <p:txBody>
+          <a:bodyPr wrap="square" lIns="0" tIns="0" rIns="0" bIns="0" rtlCol="0" anchor="t"/>
+          <a:lstStyle/>
+          <a:p>
+            <a:pPr indent="0" marL="0">
+              <a:buNone/>
+            </a:pPr>
+            <a:r>
+              <a:rPr lang="en-US" sz="2100" b="1" dirty="0">
+                <a:solidFill>
+                  <a:schemeClr val="tx1"/>
+                </a:solidFill>
+                <a:latin typeface="Arial" pitchFamily="34" charset="0"/>
+                <a:ea typeface="Arial" pitchFamily="34" charset="-122"/>
+                <a:cs typeface="Arial" pitchFamily="34" charset="-120"/>
+              </a:rPr>
+              <a:t>Saisonware</a:t>
+            </a:r>
+            <a:endParaRPr lang="en-US" sz="2100" dirty="0"/>
+          </a:p>
+        </p:txBody>
+      </p:sp>
+      <p:sp>
+        <p:nvSpPr>
+          <p:cNvPr id="5" name="Text 3"/>
+          <p:cNvSpPr txBox="1"/>
+          <p:nvPr/>
+        </p:nvSpPr>
+        <p:spPr>
+          <a:xfrm>
+            <a:off x="640080" y="2743200"/>
+            <a:ext cx="3291840" cy="3383280"/>
+          </a:xfrm>
+          <a:prstGeom prst="rect">
+            <a:avLst/>
+          </a:prstGeom>
+          <a:noFill/>
+          <a:ln/>
+        </p:spPr>
+        <p:txBody>
+          <a:bodyPr wrap="square" lIns="0" tIns="0" rIns="0" bIns="0" rtlCol="0" anchor="t"/>
+          <a:lstStyle/>
+          <a:p>
+            <a:pPr indent="0" marL="0">
+              <a:buNone/>
+            </a:pPr>
+            <a:r>
+              <a:rPr lang="en-US" sz="1500" b="1" dirty="0">
+                <a:solidFill>
+                  <a:schemeClr val="tx1"/>
+                </a:solidFill>
+              </a:rPr>
+              <a:t>Osterware:</a:t>
+            </a:r>
+            <a:pPr indent="0" marL="0">
+              <a:spcAft>
+                <a:spcPts val="1000"/>
+              </a:spcAft>
+              <a:buNone/>
+            </a:pPr>
+            <a:r>
+              <a:rPr lang="en-US" sz="1500" dirty="0">
+                <a:solidFill>
+                  <a:schemeClr val="tx2"/>
+                </a:solidFill>
+              </a:rPr>
+              <a:t> ab Mitte Februar in den Filialen. Die Schoko-Hasen werden schon ab Mitte Dezember produziert und kommen Ende Januar ins Lager.</a:t>
+            </a:r>
+            <a:endParaRPr lang="en-US" sz="1500" dirty="0"/>
+          </a:p>
+          <a:p>
+            <a:pPr indent="0" marL="0">
+              <a:buNone/>
+            </a:pPr>
+            <a:r>
+              <a:rPr lang="en-US" sz="1500" b="1" dirty="0">
+                <a:solidFill>
+                  <a:schemeClr val="tx1"/>
+                </a:solidFill>
+              </a:rPr>
+              <a:t>Karneval:</a:t>
+            </a:r>
+            <a:pPr indent="0" marL="0">
+              <a:spcAft>
+                <a:spcPts val="1000"/>
+              </a:spcAft>
+              <a:buNone/>
+            </a:pPr>
+            <a:r>
+              <a:rPr lang="en-US" sz="1500" dirty="0">
+                <a:solidFill>
+                  <a:schemeClr val="tx2"/>
+                </a:solidFill>
+              </a:rPr>
+              <a:t> Kostüme als Aktionsware – 2026 z. B. Kinderkostüme ab 5. Februar für 6,99 €.</a:t>
+            </a:r>
+            <a:endParaRPr lang="en-US" sz="1500" dirty="0"/>
+          </a:p>
+        </p:txBody>
+      </p:sp>
+      <p:sp>
+        <p:nvSpPr>
+          <p:cNvPr id="6" name="Text 4"/>
+          <p:cNvSpPr txBox="1"/>
+          <p:nvPr/>
+        </p:nvSpPr>
+        <p:spPr>
+          <a:xfrm>
+            <a:off x="4343400" y="1783080"/>
+            <a:ext cx="3291840" cy="274320"/>
+          </a:xfrm>
+          <a:prstGeom prst="rect">
+            <a:avLst/>
+          </a:prstGeom>
+          <a:noFill/>
+          <a:ln/>
+        </p:spPr>
+        <p:txBody>
+          <a:bodyPr wrap="square" lIns="0" tIns="0" rIns="0" bIns="0" rtlCol="0" anchor="t"/>
+          <a:lstStyle/>
+          <a:p>
+            <a:pPr indent="0" marL="0">
+              <a:buNone/>
+            </a:pPr>
+            <a:r>
+              <a:rPr lang="en-US" sz="1000" b="1" spc="400" kern="0" dirty="0">
+                <a:solidFill>
+                  <a:schemeClr val="accent1"/>
+                </a:solidFill>
+              </a:rPr>
+              <a:t>WAS LÄUFT?</a:t>
+            </a:r>
+            <a:endParaRPr lang="en-US" sz="1000" dirty="0"/>
+          </a:p>
+        </p:txBody>
+      </p:sp>
+      <p:sp>
+        <p:nvSpPr>
+          <p:cNvPr id="7" name="Text 5"/>
+          <p:cNvSpPr txBox="1"/>
+          <p:nvPr/>
+        </p:nvSpPr>
+        <p:spPr>
+          <a:xfrm>
+            <a:off x="4343400" y="2084832"/>
+            <a:ext cx="3291840" cy="457200"/>
+          </a:xfrm>
+          <a:prstGeom prst="rect">
+            <a:avLst/>
+          </a:prstGeom>
+          <a:noFill/>
+          <a:ln/>
+        </p:spPr>
+        <p:txBody>
+          <a:bodyPr wrap="square" lIns="0" tIns="0" rIns="0" bIns="0" rtlCol="0" anchor="t"/>
+          <a:lstStyle/>
+          <a:p>
+            <a:pPr indent="0" marL="0">
+              <a:buNone/>
+            </a:pPr>
+            <a:r>
+              <a:rPr lang="en-US" sz="2100" b="1" dirty="0">
+                <a:solidFill>
+                  <a:schemeClr val="tx1"/>
+                </a:solidFill>
+                <a:latin typeface="Arial" pitchFamily="34" charset="0"/>
+                <a:ea typeface="Arial" pitchFamily="34" charset="-122"/>
+                <a:cs typeface="Arial" pitchFamily="34" charset="-120"/>
+              </a:rPr>
+              <a:t>Aktionen</a:t>
+            </a:r>
+            <a:endParaRPr lang="en-US" sz="2100" dirty="0"/>
+          </a:p>
+        </p:txBody>
+      </p:sp>
+      <p:sp>
+        <p:nvSpPr>
+          <p:cNvPr id="8" name="Text 6"/>
+          <p:cNvSpPr txBox="1"/>
+          <p:nvPr/>
+        </p:nvSpPr>
+        <p:spPr>
+          <a:xfrm>
+            <a:off x="4343400" y="2743200"/>
+            <a:ext cx="3291840" cy="3383280"/>
+          </a:xfrm>
+          <a:prstGeom prst="rect">
+            <a:avLst/>
+          </a:prstGeom>
+          <a:noFill/>
+          <a:ln/>
+        </p:spPr>
+        <p:txBody>
+          <a:bodyPr wrap="square" lIns="0" tIns="0" rIns="0" bIns="0" rtlCol="0" anchor="t"/>
+          <a:lstStyle/>
+          <a:p>
+            <a:pPr indent="0" marL="0">
+              <a:buNone/>
+            </a:pPr>
+            <a:r>
+              <a:rPr lang="en-US" sz="1500" b="1" dirty="0">
+                <a:solidFill>
+                  <a:schemeClr val="tx1"/>
+                </a:solidFill>
+              </a:rPr>
+              <a:t>Ostern:</a:t>
+            </a:r>
+            <a:pPr indent="0" marL="0">
+              <a:spcAft>
+                <a:spcPts val="1000"/>
+              </a:spcAft>
+              <a:buNone/>
+            </a:pPr>
+            <a:r>
+              <a:rPr lang="en-US" sz="1500" dirty="0">
+                <a:solidFill>
+                  <a:schemeClr val="tx2"/>
+                </a:solidFill>
+              </a:rPr>
+              <a:t> Kampagne „Wer Ostern sucht, findet es bei ALDI“ (2025, TV, Kino, Radio, online), Schoko-Osterhase für 1,49 €, Preissenkungen vor Ostern.</a:t>
+            </a:r>
+            <a:endParaRPr lang="en-US" sz="1500" dirty="0"/>
+          </a:p>
+          <a:p>
+            <a:pPr indent="0" marL="0">
+              <a:buNone/>
+            </a:pPr>
+            <a:r>
+              <a:rPr lang="en-US" sz="1500" b="1" dirty="0">
+                <a:solidFill>
+                  <a:schemeClr val="tx1"/>
+                </a:solidFill>
+              </a:rPr>
+              <a:t>Karneval:</a:t>
+            </a:r>
+            <a:pPr indent="0" marL="0">
+              <a:spcAft>
+                <a:spcPts val="1000"/>
+              </a:spcAft>
+              <a:buNone/>
+            </a:pPr>
+            <a:r>
+              <a:rPr lang="en-US" sz="1500" dirty="0">
+                <a:solidFill>
+                  <a:schemeClr val="tx2"/>
+                </a:solidFill>
+              </a:rPr>
+              <a:t> Kamelle in Großpackungen, Berliner; 2024 brachte meinALDI Kamelle zum Mülheimer Rosenmontagszug.</a:t>
+            </a:r>
+            <a:endParaRPr lang="en-US" sz="1500" dirty="0"/>
+          </a:p>
+        </p:txBody>
+      </p:sp>
+      <p:sp>
+        <p:nvSpPr>
+          <p:cNvPr id="9" name="Linie"/>
+          <p:cNvSpPr/>
+          <p:nvPr/>
+        </p:nvSpPr>
+        <p:spPr>
+          <a:xfrm>
+            <a:off x="4114800" y="1828800"/>
+            <a:ext cx="0" cy="4206240"/>
+          </a:xfrm>
+          <a:prstGeom prst="line">
+            <a:avLst/>
+          </a:prstGeom>
+          <a:noFill/>
+          <a:ln w="9525">
+            <a:solidFill>
+              <a:schemeClr val="accent2"/>
+            </a:solidFill>
+            <a:prstDash val="solid"/>
+          </a:ln>
+        </p:spPr>
+      </p:sp>
+      <p:sp>
+        <p:nvSpPr>
+          <p:cNvPr id="10" name="Text 8"/>
+          <p:cNvSpPr txBox="1"/>
+          <p:nvPr/>
+        </p:nvSpPr>
+        <p:spPr>
+          <a:xfrm>
+            <a:off x="8046720" y="1783080"/>
+            <a:ext cx="3291840" cy="274320"/>
+          </a:xfrm>
+          <a:prstGeom prst="rect">
+            <a:avLst/>
+          </a:prstGeom>
+          <a:noFill/>
+          <a:ln/>
+        </p:spPr>
+        <p:txBody>
+          <a:bodyPr wrap="square" lIns="0" tIns="0" rIns="0" bIns="0" rtlCol="0" anchor="t"/>
+          <a:lstStyle/>
+          <a:p>
+            <a:pPr indent="0" marL="0">
+              <a:buNone/>
+            </a:pPr>
+            <a:r>
+              <a:rPr lang="en-US" sz="1000" b="1" spc="400" kern="0" dirty="0">
+                <a:solidFill>
+                  <a:schemeClr val="accent1"/>
+                </a:solidFill>
+              </a:rPr>
+              <a:t>WANN OFFEN?</a:t>
+            </a:r>
+            <a:endParaRPr lang="en-US" sz="1000" dirty="0"/>
+          </a:p>
+        </p:txBody>
+      </p:sp>
+      <p:sp>
+        <p:nvSpPr>
+          <p:cNvPr id="11" name="Text 9"/>
+          <p:cNvSpPr txBox="1"/>
+          <p:nvPr/>
+        </p:nvSpPr>
+        <p:spPr>
+          <a:xfrm>
+            <a:off x="8046720" y="2084832"/>
+            <a:ext cx="3291840" cy="457200"/>
+          </a:xfrm>
+          <a:prstGeom prst="rect">
+            <a:avLst/>
+          </a:prstGeom>
+          <a:noFill/>
+          <a:ln/>
+        </p:spPr>
+        <p:txBody>
+          <a:bodyPr wrap="square" lIns="0" tIns="0" rIns="0" bIns="0" rtlCol="0" anchor="t"/>
+          <a:lstStyle/>
+          <a:p>
+            <a:pPr indent="0" marL="0">
+              <a:buNone/>
+            </a:pPr>
+            <a:r>
+              <a:rPr lang="en-US" sz="2100" b="1" dirty="0">
+                <a:solidFill>
+                  <a:schemeClr val="tx1"/>
+                </a:solidFill>
+                <a:latin typeface="Arial" pitchFamily="34" charset="0"/>
+                <a:ea typeface="Arial" pitchFamily="34" charset="-122"/>
+                <a:cs typeface="Arial" pitchFamily="34" charset="-120"/>
+              </a:rPr>
+              <a:t>Feiertage &amp; Dienstplan</a:t>
+            </a:r>
+            <a:endParaRPr lang="en-US" sz="2100" dirty="0"/>
+          </a:p>
+        </p:txBody>
+      </p:sp>
+      <p:sp>
+        <p:nvSpPr>
+          <p:cNvPr id="12" name="Text 10"/>
+          <p:cNvSpPr txBox="1"/>
+          <p:nvPr/>
+        </p:nvSpPr>
+        <p:spPr>
+          <a:xfrm>
+            <a:off x="8046720" y="2743200"/>
+            <a:ext cx="3291840" cy="3383280"/>
+          </a:xfrm>
+          <a:prstGeom prst="rect">
+            <a:avLst/>
+          </a:prstGeom>
+          <a:noFill/>
+          <a:ln/>
+        </p:spPr>
+        <p:txBody>
+          <a:bodyPr wrap="square" lIns="0" tIns="0" rIns="0" bIns="0" rtlCol="0" anchor="t"/>
+          <a:lstStyle/>
+          <a:p>
+            <a:pPr indent="0" marL="0">
+              <a:buNone/>
+            </a:pPr>
+            <a:r>
+              <a:rPr lang="en-US" sz="1500" b="1" dirty="0">
+                <a:solidFill>
+                  <a:schemeClr val="tx1"/>
+                </a:solidFill>
+              </a:rPr>
+              <a:t>Geschlossen:</a:t>
+            </a:r>
+            <a:pPr indent="0" marL="0">
+              <a:spcAft>
+                <a:spcPts val="1000"/>
+              </a:spcAft>
+              <a:buNone/>
+            </a:pPr>
+            <a:r>
+              <a:rPr lang="en-US" sz="1500" dirty="0">
+                <a:solidFill>
+                  <a:schemeClr val="tx2"/>
+                </a:solidFill>
+              </a:rPr>
+              <a:t> Karfreitag, Ostersonntag, Ostermontag.</a:t>
+            </a:r>
+            <a:endParaRPr lang="en-US" sz="1500" dirty="0"/>
+          </a:p>
+          <a:p>
+            <a:pPr indent="0" marL="0">
+              <a:buNone/>
+            </a:pPr>
+            <a:r>
+              <a:rPr lang="en-US" sz="1500" b="1" dirty="0">
+                <a:solidFill>
+                  <a:schemeClr val="tx1"/>
+                </a:solidFill>
+              </a:rPr>
+              <a:t>Geöffnet:</a:t>
+            </a:r>
+            <a:pPr indent="0" marL="0">
+              <a:spcAft>
+                <a:spcPts val="1000"/>
+              </a:spcAft>
+              <a:buNone/>
+            </a:pPr>
+            <a:r>
+              <a:rPr lang="en-US" sz="1500" dirty="0">
+                <a:solidFill>
+                  <a:schemeClr val="tx2"/>
+                </a:solidFill>
+              </a:rPr>
+              <a:t> Gründonnerstag und Karsamstag; Rosenmontag je nach Region.</a:t>
+            </a:r>
+            <a:endParaRPr lang="en-US" sz="1500" dirty="0"/>
+          </a:p>
+          <a:p>
+            <a:pPr indent="0" marL="0">
+              <a:buNone/>
+            </a:pPr>
+            <a:r>
+              <a:rPr lang="en-US" sz="1500" b="1" dirty="0">
+                <a:solidFill>
+                  <a:schemeClr val="tx1"/>
+                </a:solidFill>
+              </a:rPr>
+              <a:t>Dienstplan:</a:t>
+            </a:r>
+            <a:pPr indent="0" marL="0">
+              <a:spcAft>
+                <a:spcPts val="1000"/>
+              </a:spcAft>
+              <a:buNone/>
+            </a:pPr>
+            <a:r>
+              <a:rPr lang="en-US" sz="1500" dirty="0">
+                <a:solidFill>
+                  <a:schemeClr val="tx2"/>
+                </a:solidFill>
+              </a:rPr>
+              <a:t> Wer an Feiertagen arbeitet, bekommt einen Ersatzruhetag; Zuschläge regelt der Tarifvertrag.</a:t>
+            </a:r>
+            <a:endParaRPr lang="en-US" sz="1500" dirty="0"/>
+          </a:p>
+        </p:txBody>
+      </p:sp>
+      <p:sp>
+        <p:nvSpPr>
+          <p:cNvPr id="13" name="Linie"/>
+          <p:cNvSpPr/>
+          <p:nvPr/>
+        </p:nvSpPr>
+        <p:spPr>
+          <a:xfrm>
+            <a:off x="7818120" y="1828800"/>
+            <a:ext cx="0" cy="4206240"/>
+          </a:xfrm>
+          <a:prstGeom prst="line">
+            <a:avLst/>
+          </a:prstGeom>
+          <a:noFill/>
+          <a:ln w="9525">
+            <a:solidFill>
+              <a:schemeClr val="accent2"/>
+            </a:solidFill>
+            <a:prstDash val="solid"/>
+          </a:ln>
+        </p:spPr>
+      </p:sp>
+      <p:sp>
+        <p:nvSpPr>
+          <p:cNvPr id="14" name="Text 0"/>
+          <p:cNvSpPr/>
+          <p:nvPr>
+            <p:ph idx="100" type="title" hasCustomPrompt="1"/>
+          </p:nvPr>
+        </p:nvSpPr>
+        <p:spPr>
+          <a:xfrm>
+            <a:off x="640080" y="822960"/>
+            <a:ext cx="10241280" cy="731520"/>
+          </a:xfrm>
+          <a:prstGeom prst="rect">
+            <a:avLst/>
+          </a:prstGeom>
+          <a:noFill/>
+          <a:ln/>
+        </p:spPr>
+        <p:txBody>
+          <a:bodyPr wrap="square" lIns="0" tIns="0" rIns="0" bIns="0" rtlCol="0" anchor="t"/>
+          <a:lstStyle/>
+          <a:p>
+            <a:pPr algn="l" indent="0" marL="0">
+              <a:buNone/>
+            </a:pPr>
+            <a:r>
+              <a:rPr lang="en-US" sz="2800" b="1" dirty="0">
+                <a:solidFill>
+                  <a:schemeClr val="tx1"/>
+                </a:solidFill>
+                <a:latin typeface="Arial" pitchFamily="34" charset="0"/>
+                <a:ea typeface="Arial" pitchFamily="34" charset="-122"/>
+                <a:cs typeface="Arial" pitchFamily="34" charset="-120"/>
+              </a:rPr>
+              <a:t>Karneval &amp; Ostern bei ALDI SÜD</a:t>
+            </a:r>
+            <a:endParaRPr lang="en-US" sz="2800" dirty="0"/>
+          </a:p>
+        </p:txBody>
+      </p:sp>
+      <p:sp>
+        <p:nvSpPr>
+          <p:cNvPr id="15" name="Text 13"/>
+          <p:cNvSpPr txBox="1"/>
+          <p:nvPr/>
+        </p:nvSpPr>
+        <p:spPr>
+          <a:xfrm>
+            <a:off x="4389120" y="6382512"/>
+            <a:ext cx="6492240" cy="228600"/>
+          </a:xfrm>
+          <a:prstGeom prst="rect">
+            <a:avLst/>
+          </a:prstGeom>
+          <a:noFill/>
+          <a:ln/>
+        </p:spPr>
+        <p:txBody>
+          <a:bodyPr wrap="square" lIns="0" tIns="0" rIns="0" bIns="0" rtlCol="0" anchor="t"/>
+          <a:lstStyle/>
+          <a:p>
+            <a:pPr algn="r" indent="0" marL="0">
+              <a:buNone/>
+            </a:pPr>
+            <a:r>
+              <a:rPr lang="en-US" sz="900" i="1" dirty="0">
+                <a:solidFill>
+                  <a:schemeClr val="tx2"/>
+                </a:solidFill>
+              </a:rPr>
+              <a:t>Quellen: ALDI SÜD Newsroom, Blog &amp; Karnevalsseite; t-online.de; generali.de</a:t>
+            </a:r>
+            <a:endParaRPr lang="en-US" sz="900" dirty="0"/>
+          </a:p>
+        </p:txBody>
+      </p:sp>
+      <p:sp>
+        <p:nvSpPr>
+          <p:cNvPr id="25" name="Slide Number Placeholder 0"/>
+          <p:cNvSpPr>
+            <a:spLocks noGrp="1"/>
+          </p:cNvSpPr>
+          <p:nvPr>
+            <p:ph type="sldNum" sz="quarter" idx="4294967295"/>
+          </p:nvPr>
+        </p:nvSpPr>
+        <p:spPr>
+          <a:xfrm>
+            <a:off x="11155680" y="347472"/>
+            <a:ext cx="566928" cy="329184"/>
+          </a:xfrm>
+          <a:prstGeom prst="rect">
+            <a:avLst/>
+          </a:prstGeom>
+          <a:extLst>
+            <a:ext uri="{C572A759-6A51-4108-AA02-DFA0A04FC94B}">
+              <ma14:wrappingTextBoxFlag xmlns:ma14="http://schemas.microsoft.com/office/mac/drawingml/2011/main" val="0"/>
+            </a:ext>
+          </a:extLst>
+        </p:spPr>
+        <p:txBody>
+          <a:bodyPr lIns="0" tIns="0" rIns="0" bIns="0" anchor="ctr"/>
+          <a:lstStyle>
+            <a:lvl1pPr>
+              <a:defRPr sz="1000">
+                <a:solidFill>
+                  <a:schemeClr val="tx1"/>
+                </a:solidFill>
+              </a:defRPr>
+            </a:lvl1pPr>
+          </a:lstStyle>
+          <a:p>
+            <a:pPr algn="ctr"/>
+            <a:fld id="{F7021451-1387-4CA6-816F-3879F97B5CBC}" type="slidenum">
+              <a:rPr b="0" lang="en-US"/>
+              <a:t>18</a:t>
+            </a:fld>
+            <a:endParaRPr lang="en-US"/>
+          </a:p>
+        </p:txBody>
+      </p:sp>
+    </p:spTree>
+  </p:cSld>
+  <p:clrMapOvr>
+    <a:masterClrMapping/>
+  </p:clrMapOvr>
+</p:sld>
+</file>
+
+<file path=ppt/slides/slide19.xml><?xml version="1.0" encoding="utf-8"?>
+<p:sld xmlns:a="http://schemas.openxmlformats.org/drawingml/2006/main" xmlns:r="http://schemas.openxmlformats.org/officeDocument/2006/relationships" xmlns:p="http://schemas.openxmlformats.org/presentationml/2006/main">
+  <p:cSld name="Slide 19">
     <p:bg>
       <p:bgPr>
         <a:blipFill dpi="0" rotWithShape="1">
@@ -9981,665 +10681,6 @@
               <a:defRPr sz="1000">
                 <a:solidFill>
                   <a:schemeClr val="bg1"/>
-                </a:solidFill>
-              </a:defRPr>
-            </a:lvl1pPr>
-          </a:lstStyle>
-          <a:p>
-            <a:pPr algn="ctr"/>
-            <a:fld id="{F7021451-1387-4CA6-816F-3879F97B5CBC}" type="slidenum">
-              <a:rPr b="0" lang="en-US"/>
-              <a:t>18</a:t>
-            </a:fld>
-            <a:endParaRPr lang="en-US"/>
-          </a:p>
-        </p:txBody>
-      </p:sp>
-    </p:spTree>
-  </p:cSld>
-  <p:clrMapOvr>
-    <a:masterClrMapping/>
-  </p:clrMapOvr>
-</p:sld>
-</file>
-
-<file path=ppt/slides/slide19.xml><?xml version="1.0" encoding="utf-8"?>
-<p:sld xmlns:a="http://schemas.openxmlformats.org/drawingml/2006/main" xmlns:r="http://schemas.openxmlformats.org/officeDocument/2006/relationships" xmlns:p="http://schemas.openxmlformats.org/presentationml/2006/main">
-  <p:cSld name="Slide 19">
-    <p:spTree>
-      <p:nvGrpSpPr>
-        <p:cNvPr id="1" name=""/>
-        <p:cNvGrpSpPr/>
-        <p:nvPr/>
-      </p:nvGrpSpPr>
-      <p:grpSpPr>
-        <a:xfrm>
-          <a:off x="0" y="0"/>
-          <a:ext cx="0" cy="0"/>
-          <a:chOff x="0" y="0"/>
-          <a:chExt cx="0" cy="0"/>
-        </a:xfrm>
-      </p:grpSpPr>
-      <p:sp>
-        <p:nvSpPr>
-          <p:cNvPr id="2" name="Text 0"/>
-          <p:cNvSpPr txBox="1"/>
-          <p:nvPr/>
-        </p:nvSpPr>
-        <p:spPr>
-          <a:xfrm>
-            <a:off x="640080" y="502920"/>
-            <a:ext cx="5486400" cy="274320"/>
-          </a:xfrm>
-          <a:prstGeom prst="rect">
-            <a:avLst/>
-          </a:prstGeom>
-          <a:noFill/>
-          <a:ln/>
-        </p:spPr>
-        <p:txBody>
-          <a:bodyPr wrap="square" lIns="0" tIns="0" rIns="0" bIns="0" rtlCol="0" anchor="t"/>
-          <a:lstStyle/>
-          <a:p>
-            <a:pPr indent="0" marL="0">
-              <a:buNone/>
-            </a:pPr>
-            <a:r>
-              <a:rPr lang="en-US" sz="1100" b="1" spc="500" kern="0" dirty="0">
-                <a:solidFill>
-                  <a:schemeClr val="accent1"/>
-                </a:solidFill>
-              </a:rPr>
-              <a:t>QUELLEN</a:t>
-            </a:r>
-            <a:endParaRPr lang="en-US" sz="1100" dirty="0"/>
-          </a:p>
-        </p:txBody>
-      </p:sp>
-      <p:sp>
-        <p:nvSpPr>
-          <p:cNvPr id="3" name="Text 1"/>
-          <p:cNvSpPr txBox="1"/>
-          <p:nvPr/>
-        </p:nvSpPr>
-        <p:spPr>
-          <a:xfrm>
-            <a:off x="640080" y="1828800"/>
-            <a:ext cx="822960" cy="548640"/>
-          </a:xfrm>
-          <a:prstGeom prst="rect">
-            <a:avLst/>
-          </a:prstGeom>
-          <a:noFill/>
-          <a:ln/>
-        </p:spPr>
-        <p:txBody>
-          <a:bodyPr wrap="square" lIns="0" tIns="0" rIns="0" bIns="0" rtlCol="0" anchor="t"/>
-          <a:lstStyle/>
-          <a:p>
-            <a:pPr indent="0" marL="0">
-              <a:buNone/>
-            </a:pPr>
-            <a:r>
-              <a:rPr lang="en-US" sz="2400" dirty="0">
-                <a:solidFill>
-                  <a:schemeClr val="accent1"/>
-                </a:solidFill>
-                <a:latin typeface="Arial" pitchFamily="34" charset="0"/>
-                <a:ea typeface="Arial" pitchFamily="34" charset="-122"/>
-                <a:cs typeface="Arial" pitchFamily="34" charset="-120"/>
-              </a:rPr>
-              <a:t>01</a:t>
-            </a:r>
-            <a:endParaRPr lang="en-US" sz="2400" dirty="0"/>
-          </a:p>
-        </p:txBody>
-      </p:sp>
-      <p:sp>
-        <p:nvSpPr>
-          <p:cNvPr id="4" name="Text 2"/>
-          <p:cNvSpPr txBox="1"/>
-          <p:nvPr/>
-        </p:nvSpPr>
-        <p:spPr>
-          <a:xfrm>
-            <a:off x="1554480" y="1828800"/>
-            <a:ext cx="9966960" cy="685800"/>
-          </a:xfrm>
-          <a:prstGeom prst="rect">
-            <a:avLst/>
-          </a:prstGeom>
-          <a:noFill/>
-          <a:ln/>
-        </p:spPr>
-        <p:txBody>
-          <a:bodyPr wrap="square" lIns="0" tIns="0" rIns="0" bIns="0" rtlCol="0" anchor="t"/>
-          <a:lstStyle/>
-          <a:p>
-            <a:pPr indent="0" marL="0">
-              <a:buNone/>
-            </a:pPr>
-            <a:r>
-              <a:rPr lang="en-US" sz="1600" b="1" dirty="0">
-                <a:solidFill>
-                  <a:schemeClr val="tx1"/>
-                </a:solidFill>
-              </a:rPr>
-              <a:t>Erzbistum Köln: Karneval – Ursprung, Bedeutung und Brauchtum</a:t>
-            </a:r>
-            <a:endParaRPr lang="en-US" sz="1600" dirty="0"/>
-          </a:p>
-          <a:p>
-            <a:pPr indent="0" marL="0">
-              <a:buNone/>
-            </a:pPr>
-            <a:r>
-              <a:rPr lang="en-US" sz="1100" u="sng" dirty="0">
-                <a:solidFill>
-                  <a:schemeClr val="tx2"/>
-                </a:solidFill>
-                <a:hlinkClick r:id="rId1" invalidUrl="" action="" tgtFrame="" tooltip="" history="1" highlightClick="0" endSnd="0">
-                  <a:extLst>
-                    <a:ext uri="{A12FA001-AC4F-418D-AE19-62706E023703}">
-                      <ahyp:hlinkClr xmlns:ahyp="http://schemas.microsoft.com/office/drawing/2018/hyperlinkcolor" val="tx"/>
-                    </a:ext>
-                  </a:extLst>
-                </a:hlinkClick>
-              </a:rPr>
-              <a:t>https://www.erzbistum-koeln.de/presse_und_medien/magazin/Karneval-Ursprung-Bedeutung-und-Brauchtum-des-Karnevals/</a:t>
-            </a:r>
-            <a:endParaRPr lang="en-US" sz="1600" dirty="0"/>
-          </a:p>
-        </p:txBody>
-      </p:sp>
-      <p:sp>
-        <p:nvSpPr>
-          <p:cNvPr id="5" name="Linie"/>
-          <p:cNvSpPr/>
-          <p:nvPr/>
-        </p:nvSpPr>
-        <p:spPr>
-          <a:xfrm>
-            <a:off x="640080" y="2633472"/>
-            <a:ext cx="10881360" cy="0"/>
-          </a:xfrm>
-          <a:prstGeom prst="line">
-            <a:avLst/>
-          </a:prstGeom>
-          <a:noFill/>
-          <a:ln w="9525">
-            <a:solidFill>
-              <a:schemeClr val="accent2"/>
-            </a:solidFill>
-            <a:prstDash val="solid"/>
-          </a:ln>
-        </p:spPr>
-      </p:sp>
-      <p:sp>
-        <p:nvSpPr>
-          <p:cNvPr id="6" name="Text 4"/>
-          <p:cNvSpPr txBox="1"/>
-          <p:nvPr/>
-        </p:nvSpPr>
-        <p:spPr>
-          <a:xfrm>
-            <a:off x="640080" y="2743200"/>
-            <a:ext cx="822960" cy="548640"/>
-          </a:xfrm>
-          <a:prstGeom prst="rect">
-            <a:avLst/>
-          </a:prstGeom>
-          <a:noFill/>
-          <a:ln/>
-        </p:spPr>
-        <p:txBody>
-          <a:bodyPr wrap="square" lIns="0" tIns="0" rIns="0" bIns="0" rtlCol="0" anchor="t"/>
-          <a:lstStyle/>
-          <a:p>
-            <a:pPr indent="0" marL="0">
-              <a:buNone/>
-            </a:pPr>
-            <a:r>
-              <a:rPr lang="en-US" sz="2400" dirty="0">
-                <a:solidFill>
-                  <a:schemeClr val="accent1"/>
-                </a:solidFill>
-                <a:latin typeface="Arial" pitchFamily="34" charset="0"/>
-                <a:ea typeface="Arial" pitchFamily="34" charset="-122"/>
-                <a:cs typeface="Arial" pitchFamily="34" charset="-120"/>
-              </a:rPr>
-              <a:t>02</a:t>
-            </a:r>
-            <a:endParaRPr lang="en-US" sz="2400" dirty="0"/>
-          </a:p>
-        </p:txBody>
-      </p:sp>
-      <p:sp>
-        <p:nvSpPr>
-          <p:cNvPr id="7" name="Text 5"/>
-          <p:cNvSpPr txBox="1"/>
-          <p:nvPr/>
-        </p:nvSpPr>
-        <p:spPr>
-          <a:xfrm>
-            <a:off x="1554480" y="2743200"/>
-            <a:ext cx="9966960" cy="685800"/>
-          </a:xfrm>
-          <a:prstGeom prst="rect">
-            <a:avLst/>
-          </a:prstGeom>
-          <a:noFill/>
-          <a:ln/>
-        </p:spPr>
-        <p:txBody>
-          <a:bodyPr wrap="square" lIns="0" tIns="0" rIns="0" bIns="0" rtlCol="0" anchor="t"/>
-          <a:lstStyle/>
-          <a:p>
-            <a:pPr indent="0" marL="0">
-              <a:buNone/>
-            </a:pPr>
-            <a:r>
-              <a:rPr lang="en-US" sz="1600" b="1" dirty="0">
-                <a:solidFill>
-                  <a:schemeClr val="tx1"/>
-                </a:solidFill>
-              </a:rPr>
-              <a:t>ZDFheute: „Mit Palmsonntag beginnt die Karwoche“</a:t>
-            </a:r>
-            <a:endParaRPr lang="en-US" sz="1600" dirty="0"/>
-          </a:p>
-          <a:p>
-            <a:pPr indent="0" marL="0">
-              <a:buNone/>
-            </a:pPr>
-            <a:r>
-              <a:rPr lang="en-US" sz="1100" u="sng" dirty="0">
-                <a:solidFill>
-                  <a:schemeClr val="tx2"/>
-                </a:solidFill>
-                <a:hlinkClick r:id="rId2" invalidUrl="" action="" tgtFrame="" tooltip="" history="1" highlightClick="0" endSnd="0">
-                  <a:extLst>
-                    <a:ext uri="{A12FA001-AC4F-418D-AE19-62706E023703}">
-                      <ahyp:hlinkClr xmlns:ahyp="http://schemas.microsoft.com/office/drawing/2018/hyperlinkcolor" val="tx"/>
-                    </a:ext>
-                  </a:extLst>
-                </a:hlinkClick>
-              </a:rPr>
-              <a:t>https://www.zdfheute.de/wissen/ostern-feiertage-karfreitag-karwoche-palmsonntag-100.html</a:t>
-            </a:r>
-            <a:endParaRPr lang="en-US" sz="1600" dirty="0"/>
-          </a:p>
-        </p:txBody>
-      </p:sp>
-      <p:sp>
-        <p:nvSpPr>
-          <p:cNvPr id="8" name="Linie"/>
-          <p:cNvSpPr/>
-          <p:nvPr/>
-        </p:nvSpPr>
-        <p:spPr>
-          <a:xfrm>
-            <a:off x="640080" y="3547872"/>
-            <a:ext cx="10881360" cy="0"/>
-          </a:xfrm>
-          <a:prstGeom prst="line">
-            <a:avLst/>
-          </a:prstGeom>
-          <a:noFill/>
-          <a:ln w="9525">
-            <a:solidFill>
-              <a:schemeClr val="accent2"/>
-            </a:solidFill>
-            <a:prstDash val="solid"/>
-          </a:ln>
-        </p:spPr>
-      </p:sp>
-      <p:sp>
-        <p:nvSpPr>
-          <p:cNvPr id="9" name="Text 7"/>
-          <p:cNvSpPr txBox="1"/>
-          <p:nvPr/>
-        </p:nvSpPr>
-        <p:spPr>
-          <a:xfrm>
-            <a:off x="640080" y="3657600"/>
-            <a:ext cx="822960" cy="548640"/>
-          </a:xfrm>
-          <a:prstGeom prst="rect">
-            <a:avLst/>
-          </a:prstGeom>
-          <a:noFill/>
-          <a:ln/>
-        </p:spPr>
-        <p:txBody>
-          <a:bodyPr wrap="square" lIns="0" tIns="0" rIns="0" bIns="0" rtlCol="0" anchor="t"/>
-          <a:lstStyle/>
-          <a:p>
-            <a:pPr indent="0" marL="0">
-              <a:buNone/>
-            </a:pPr>
-            <a:r>
-              <a:rPr lang="en-US" sz="2400" dirty="0">
-                <a:solidFill>
-                  <a:schemeClr val="accent1"/>
-                </a:solidFill>
-                <a:latin typeface="Arial" pitchFamily="34" charset="0"/>
-                <a:ea typeface="Arial" pitchFamily="34" charset="-122"/>
-                <a:cs typeface="Arial" pitchFamily="34" charset="-120"/>
-              </a:rPr>
-              <a:t>03</a:t>
-            </a:r>
-            <a:endParaRPr lang="en-US" sz="2400" dirty="0"/>
-          </a:p>
-        </p:txBody>
-      </p:sp>
-      <p:sp>
-        <p:nvSpPr>
-          <p:cNvPr id="10" name="Text 8"/>
-          <p:cNvSpPr txBox="1"/>
-          <p:nvPr/>
-        </p:nvSpPr>
-        <p:spPr>
-          <a:xfrm>
-            <a:off x="1554480" y="3657600"/>
-            <a:ext cx="9966960" cy="685800"/>
-          </a:xfrm>
-          <a:prstGeom prst="rect">
-            <a:avLst/>
-          </a:prstGeom>
-          <a:noFill/>
-          <a:ln/>
-        </p:spPr>
-        <p:txBody>
-          <a:bodyPr wrap="square" lIns="0" tIns="0" rIns="0" bIns="0" rtlCol="0" anchor="t"/>
-          <a:lstStyle/>
-          <a:p>
-            <a:pPr indent="0" marL="0">
-              <a:buNone/>
-            </a:pPr>
-            <a:r>
-              <a:rPr lang="en-US" sz="1600" b="1" dirty="0">
-                <a:solidFill>
-                  <a:schemeClr val="tx1"/>
-                </a:solidFill>
-              </a:rPr>
-              <a:t>bpb: Ramadan (Deine tägliche Dosis Politik)</a:t>
-            </a:r>
-            <a:endParaRPr lang="en-US" sz="1600" dirty="0"/>
-          </a:p>
-          <a:p>
-            <a:pPr indent="0" marL="0">
-              <a:buNone/>
-            </a:pPr>
-            <a:r>
-              <a:rPr lang="en-US" sz="1100" u="sng" dirty="0">
-                <a:solidFill>
-                  <a:schemeClr val="tx2"/>
-                </a:solidFill>
-                <a:hlinkClick r:id="rId3" invalidUrl="" action="" tgtFrame="" tooltip="" history="1" highlightClick="0" endSnd="0">
-                  <a:extLst>
-                    <a:ext uri="{A12FA001-AC4F-418D-AE19-62706E023703}">
-                      <ahyp:hlinkClr xmlns:ahyp="http://schemas.microsoft.com/office/drawing/2018/hyperlinkcolor" val="tx"/>
-                    </a:ext>
-                  </a:extLst>
-                </a:hlinkClick>
-              </a:rPr>
-              <a:t>https://www.bpb.de/kurz-knapp/taegliche-dosis-politik/559978/ramadan/</a:t>
-            </a:r>
-            <a:endParaRPr lang="en-US" sz="1600" dirty="0"/>
-          </a:p>
-        </p:txBody>
-      </p:sp>
-      <p:sp>
-        <p:nvSpPr>
-          <p:cNvPr id="11" name="Linie"/>
-          <p:cNvSpPr/>
-          <p:nvPr/>
-        </p:nvSpPr>
-        <p:spPr>
-          <a:xfrm>
-            <a:off x="640080" y="4462272"/>
-            <a:ext cx="10881360" cy="0"/>
-          </a:xfrm>
-          <a:prstGeom prst="line">
-            <a:avLst/>
-          </a:prstGeom>
-          <a:noFill/>
-          <a:ln w="9525">
-            <a:solidFill>
-              <a:schemeClr val="accent2"/>
-            </a:solidFill>
-            <a:prstDash val="solid"/>
-          </a:ln>
-        </p:spPr>
-      </p:sp>
-      <p:sp>
-        <p:nvSpPr>
-          <p:cNvPr id="12" name="Text 10"/>
-          <p:cNvSpPr txBox="1"/>
-          <p:nvPr/>
-        </p:nvSpPr>
-        <p:spPr>
-          <a:xfrm>
-            <a:off x="640080" y="4572000"/>
-            <a:ext cx="822960" cy="548640"/>
-          </a:xfrm>
-          <a:prstGeom prst="rect">
-            <a:avLst/>
-          </a:prstGeom>
-          <a:noFill/>
-          <a:ln/>
-        </p:spPr>
-        <p:txBody>
-          <a:bodyPr wrap="square" lIns="0" tIns="0" rIns="0" bIns="0" rtlCol="0" anchor="t"/>
-          <a:lstStyle/>
-          <a:p>
-            <a:pPr indent="0" marL="0">
-              <a:buNone/>
-            </a:pPr>
-            <a:r>
-              <a:rPr lang="en-US" sz="2400" dirty="0">
-                <a:solidFill>
-                  <a:schemeClr val="accent1"/>
-                </a:solidFill>
-                <a:latin typeface="Arial" pitchFamily="34" charset="0"/>
-                <a:ea typeface="Arial" pitchFamily="34" charset="-122"/>
-                <a:cs typeface="Arial" pitchFamily="34" charset="-120"/>
-              </a:rPr>
-              <a:t>04</a:t>
-            </a:r>
-            <a:endParaRPr lang="en-US" sz="2400" dirty="0"/>
-          </a:p>
-        </p:txBody>
-      </p:sp>
-      <p:sp>
-        <p:nvSpPr>
-          <p:cNvPr id="13" name="Text 11"/>
-          <p:cNvSpPr txBox="1"/>
-          <p:nvPr/>
-        </p:nvSpPr>
-        <p:spPr>
-          <a:xfrm>
-            <a:off x="1554480" y="4572000"/>
-            <a:ext cx="9966960" cy="685800"/>
-          </a:xfrm>
-          <a:prstGeom prst="rect">
-            <a:avLst/>
-          </a:prstGeom>
-          <a:noFill/>
-          <a:ln/>
-        </p:spPr>
-        <p:txBody>
-          <a:bodyPr wrap="square" lIns="0" tIns="0" rIns="0" bIns="0" rtlCol="0" anchor="t"/>
-          <a:lstStyle/>
-          <a:p>
-            <a:pPr indent="0" marL="0">
-              <a:buNone/>
-            </a:pPr>
-            <a:r>
-              <a:rPr lang="en-US" sz="1600" b="1" dirty="0">
-                <a:solidFill>
-                  <a:schemeClr val="tx1"/>
-                </a:solidFill>
-              </a:rPr>
-              <a:t>bpb: M 06.06 Gemeinsam (religiöse) Feste feiern</a:t>
-            </a:r>
-            <a:endParaRPr lang="en-US" sz="1600" dirty="0"/>
-          </a:p>
-          <a:p>
-            <a:pPr indent="0" marL="0">
-              <a:buNone/>
-            </a:pPr>
-            <a:r>
-              <a:rPr lang="en-US" sz="1100" u="sng" dirty="0">
-                <a:solidFill>
-                  <a:schemeClr val="tx2"/>
-                </a:solidFill>
-                <a:hlinkClick r:id="rId4" invalidUrl="" action="" tgtFrame="" tooltip="" history="1" highlightClick="0" endSnd="0">
-                  <a:extLst>
-                    <a:ext uri="{A12FA001-AC4F-418D-AE19-62706E023703}">
-                      <ahyp:hlinkClr xmlns:ahyp="http://schemas.microsoft.com/office/drawing/2018/hyperlinkcolor" val="tx"/>
-                    </a:ext>
-                  </a:extLst>
-                </a:hlinkClick>
-              </a:rPr>
-              <a:t>https://www.bpb.de/lernen/angebote/grafstat/projekt-integration/134726/m-06-06-gemeinsam-religioese-feste-feiern/</a:t>
-            </a:r>
-            <a:endParaRPr lang="en-US" sz="1600" dirty="0"/>
-          </a:p>
-        </p:txBody>
-      </p:sp>
-      <p:sp>
-        <p:nvSpPr>
-          <p:cNvPr id="14" name="Linie"/>
-          <p:cNvSpPr/>
-          <p:nvPr/>
-        </p:nvSpPr>
-        <p:spPr>
-          <a:xfrm>
-            <a:off x="640080" y="5376672"/>
-            <a:ext cx="10881360" cy="0"/>
-          </a:xfrm>
-          <a:prstGeom prst="line">
-            <a:avLst/>
-          </a:prstGeom>
-          <a:noFill/>
-          <a:ln w="9525">
-            <a:solidFill>
-              <a:schemeClr val="accent2"/>
-            </a:solidFill>
-            <a:prstDash val="solid"/>
-          </a:ln>
-        </p:spPr>
-      </p:sp>
-      <p:sp>
-        <p:nvSpPr>
-          <p:cNvPr id="15" name="Text 13"/>
-          <p:cNvSpPr txBox="1"/>
-          <p:nvPr/>
-        </p:nvSpPr>
-        <p:spPr>
-          <a:xfrm>
-            <a:off x="1554480" y="5669280"/>
-            <a:ext cx="9966960" cy="320040"/>
-          </a:xfrm>
-          <a:prstGeom prst="rect">
-            <a:avLst/>
-          </a:prstGeom>
-          <a:noFill/>
-          <a:ln/>
-        </p:spPr>
-        <p:txBody>
-          <a:bodyPr wrap="square" lIns="0" tIns="0" rIns="0" bIns="0" rtlCol="0" anchor="t"/>
-          <a:lstStyle/>
-          <a:p>
-            <a:pPr indent="0" marL="0">
-              <a:buNone/>
-            </a:pPr>
-            <a:r>
-              <a:rPr lang="en-US" sz="1300" i="1" dirty="0">
-                <a:solidFill>
-                  <a:schemeClr val="tx2"/>
-                </a:solidFill>
-              </a:rPr>
-              <a:t>Bildquellen: Karneval- und Osterfotos – bitte ergänzen</a:t>
-            </a:r>
-            <a:endParaRPr lang="en-US" sz="1300" dirty="0"/>
-          </a:p>
-        </p:txBody>
-      </p:sp>
-      <p:sp>
-        <p:nvSpPr>
-          <p:cNvPr id="16" name="Text 0"/>
-          <p:cNvSpPr/>
-          <p:nvPr>
-            <p:ph idx="100" type="title" hasCustomPrompt="1"/>
-          </p:nvPr>
-        </p:nvSpPr>
-        <p:spPr>
-          <a:xfrm>
-            <a:off x="640080" y="822960"/>
-            <a:ext cx="10241280" cy="731520"/>
-          </a:xfrm>
-          <a:prstGeom prst="rect">
-            <a:avLst/>
-          </a:prstGeom>
-          <a:noFill/>
-          <a:ln/>
-        </p:spPr>
-        <p:txBody>
-          <a:bodyPr wrap="square" lIns="0" tIns="0" rIns="0" bIns="0" rtlCol="0" anchor="t"/>
-          <a:lstStyle/>
-          <a:p>
-            <a:pPr algn="l" indent="0" marL="0">
-              <a:buNone/>
-            </a:pPr>
-            <a:r>
-              <a:rPr lang="en-US" sz="2800" b="1" dirty="0">
-                <a:solidFill>
-                  <a:schemeClr val="tx1"/>
-                </a:solidFill>
-                <a:latin typeface="Arial" pitchFamily="34" charset="0"/>
-                <a:ea typeface="Arial" pitchFamily="34" charset="-122"/>
-                <a:cs typeface="Arial" pitchFamily="34" charset="-120"/>
-              </a:rPr>
-              <a:t>Quellen</a:t>
-            </a:r>
-            <a:endParaRPr lang="en-US" sz="2800" dirty="0"/>
-          </a:p>
-        </p:txBody>
-      </p:sp>
-      <p:sp>
-        <p:nvSpPr>
-          <p:cNvPr id="25" name="Slide Number Placeholder 0"/>
-          <p:cNvSpPr>
-            <a:spLocks noGrp="1"/>
-          </p:cNvSpPr>
-          <p:nvPr>
-            <p:ph type="sldNum" sz="quarter" idx="4294967295"/>
-          </p:nvPr>
-        </p:nvSpPr>
-        <p:spPr>
-          <a:xfrm>
-            <a:off x="11155680" y="347472"/>
-            <a:ext cx="566928" cy="329184"/>
-          </a:xfrm>
-          <a:prstGeom prst="rect">
-            <a:avLst/>
-          </a:prstGeom>
-          <a:extLst>
-            <a:ext uri="{C572A759-6A51-4108-AA02-DFA0A04FC94B}">
-              <ma14:wrappingTextBoxFlag xmlns:ma14="http://schemas.microsoft.com/office/mac/drawingml/2011/main" val="0"/>
-            </a:ext>
-          </a:extLst>
-        </p:spPr>
-        <p:txBody>
-          <a:bodyPr lIns="0" tIns="0" rIns="0" bIns="0" anchor="ctr"/>
-          <a:lstStyle>
-            <a:lvl1pPr>
-              <a:defRPr sz="1000">
-                <a:solidFill>
-                  <a:schemeClr val="tx1"/>
                 </a:solidFill>
               </a:defRPr>
             </a:lvl1pPr>
@@ -11273,6 +11314,701 @@
 <file path=ppt/slides/slide20.xml><?xml version="1.0" encoding="utf-8"?>
 <p:sld xmlns:a="http://schemas.openxmlformats.org/drawingml/2006/main" xmlns:r="http://schemas.openxmlformats.org/officeDocument/2006/relationships" xmlns:p="http://schemas.openxmlformats.org/presentationml/2006/main">
   <p:cSld name="Slide 20">
+    <p:spTree>
+      <p:nvGrpSpPr>
+        <p:cNvPr id="1" name=""/>
+        <p:cNvGrpSpPr/>
+        <p:nvPr/>
+      </p:nvGrpSpPr>
+      <p:grpSpPr>
+        <a:xfrm>
+          <a:off x="0" y="0"/>
+          <a:ext cx="0" cy="0"/>
+          <a:chOff x="0" y="0"/>
+          <a:chExt cx="0" cy="0"/>
+        </a:xfrm>
+      </p:grpSpPr>
+      <p:sp>
+        <p:nvSpPr>
+          <p:cNvPr id="2" name="Text 0"/>
+          <p:cNvSpPr txBox="1"/>
+          <p:nvPr/>
+        </p:nvSpPr>
+        <p:spPr>
+          <a:xfrm>
+            <a:off x="640080" y="502920"/>
+            <a:ext cx="5486400" cy="274320"/>
+          </a:xfrm>
+          <a:prstGeom prst="rect">
+            <a:avLst/>
+          </a:prstGeom>
+          <a:noFill/>
+          <a:ln/>
+        </p:spPr>
+        <p:txBody>
+          <a:bodyPr wrap="square" lIns="0" tIns="0" rIns="0" bIns="0" rtlCol="0" anchor="t"/>
+          <a:lstStyle/>
+          <a:p>
+            <a:pPr indent="0" marL="0">
+              <a:buNone/>
+            </a:pPr>
+            <a:r>
+              <a:rPr lang="en-US" sz="1100" b="1" spc="500" kern="0" dirty="0">
+                <a:solidFill>
+                  <a:schemeClr val="accent1"/>
+                </a:solidFill>
+              </a:rPr>
+              <a:t>QUELLEN</a:t>
+            </a:r>
+            <a:endParaRPr lang="en-US" sz="1100" dirty="0"/>
+          </a:p>
+        </p:txBody>
+      </p:sp>
+      <p:sp>
+        <p:nvSpPr>
+          <p:cNvPr id="3" name="Text 1"/>
+          <p:cNvSpPr txBox="1"/>
+          <p:nvPr/>
+        </p:nvSpPr>
+        <p:spPr>
+          <a:xfrm>
+            <a:off x="640080" y="1828800"/>
+            <a:ext cx="822960" cy="548640"/>
+          </a:xfrm>
+          <a:prstGeom prst="rect">
+            <a:avLst/>
+          </a:prstGeom>
+          <a:noFill/>
+          <a:ln/>
+        </p:spPr>
+        <p:txBody>
+          <a:bodyPr wrap="square" lIns="0" tIns="0" rIns="0" bIns="0" rtlCol="0" anchor="t"/>
+          <a:lstStyle/>
+          <a:p>
+            <a:pPr indent="0" marL="0">
+              <a:buNone/>
+            </a:pPr>
+            <a:r>
+              <a:rPr lang="en-US" sz="2400" dirty="0">
+                <a:solidFill>
+                  <a:schemeClr val="accent1"/>
+                </a:solidFill>
+                <a:latin typeface="Arial" pitchFamily="34" charset="0"/>
+                <a:ea typeface="Arial" pitchFamily="34" charset="-122"/>
+                <a:cs typeface="Arial" pitchFamily="34" charset="-120"/>
+              </a:rPr>
+              <a:t>01</a:t>
+            </a:r>
+            <a:endParaRPr lang="en-US" sz="2400" dirty="0"/>
+          </a:p>
+        </p:txBody>
+      </p:sp>
+      <p:sp>
+        <p:nvSpPr>
+          <p:cNvPr id="4" name="Text 2"/>
+          <p:cNvSpPr txBox="1"/>
+          <p:nvPr/>
+        </p:nvSpPr>
+        <p:spPr>
+          <a:xfrm>
+            <a:off x="1554480" y="1828800"/>
+            <a:ext cx="9966960" cy="685800"/>
+          </a:xfrm>
+          <a:prstGeom prst="rect">
+            <a:avLst/>
+          </a:prstGeom>
+          <a:noFill/>
+          <a:ln/>
+        </p:spPr>
+        <p:txBody>
+          <a:bodyPr wrap="square" lIns="0" tIns="0" rIns="0" bIns="0" rtlCol="0" anchor="t"/>
+          <a:lstStyle/>
+          <a:p>
+            <a:pPr indent="0" marL="0">
+              <a:buNone/>
+            </a:pPr>
+            <a:r>
+              <a:rPr lang="en-US" sz="1600" b="1" dirty="0">
+                <a:solidFill>
+                  <a:schemeClr val="tx1"/>
+                </a:solidFill>
+              </a:rPr>
+              <a:t>Erzbistum Köln: Karneval – Ursprung, Bedeutung und Brauchtum</a:t>
+            </a:r>
+            <a:endParaRPr lang="en-US" sz="1600" dirty="0"/>
+          </a:p>
+          <a:p>
+            <a:pPr indent="0" marL="0">
+              <a:buNone/>
+            </a:pPr>
+            <a:r>
+              <a:rPr lang="en-US" sz="1100" u="sng" dirty="0">
+                <a:solidFill>
+                  <a:schemeClr val="tx2"/>
+                </a:solidFill>
+                <a:hlinkClick r:id="rId1" invalidUrl="" action="" tgtFrame="" tooltip="" history="1" highlightClick="0" endSnd="0">
+                  <a:extLst>
+                    <a:ext uri="{A12FA001-AC4F-418D-AE19-62706E023703}">
+                      <ahyp:hlinkClr xmlns:ahyp="http://schemas.microsoft.com/office/drawing/2018/hyperlinkcolor" val="tx"/>
+                    </a:ext>
+                  </a:extLst>
+                </a:hlinkClick>
+              </a:rPr>
+              <a:t>https://www.erzbistum-koeln.de/presse_und_medien/magazin/Karneval-Ursprung-Bedeutung-und-Brauchtum-des-Karnevals/</a:t>
+            </a:r>
+            <a:endParaRPr lang="en-US" sz="1600" dirty="0"/>
+          </a:p>
+        </p:txBody>
+      </p:sp>
+      <p:sp>
+        <p:nvSpPr>
+          <p:cNvPr id="5" name="Linie"/>
+          <p:cNvSpPr/>
+          <p:nvPr/>
+        </p:nvSpPr>
+        <p:spPr>
+          <a:xfrm>
+            <a:off x="640080" y="2633472"/>
+            <a:ext cx="10881360" cy="0"/>
+          </a:xfrm>
+          <a:prstGeom prst="line">
+            <a:avLst/>
+          </a:prstGeom>
+          <a:noFill/>
+          <a:ln w="9525">
+            <a:solidFill>
+              <a:schemeClr val="accent2"/>
+            </a:solidFill>
+            <a:prstDash val="solid"/>
+          </a:ln>
+        </p:spPr>
+      </p:sp>
+      <p:sp>
+        <p:nvSpPr>
+          <p:cNvPr id="6" name="Text 4"/>
+          <p:cNvSpPr txBox="1"/>
+          <p:nvPr/>
+        </p:nvSpPr>
+        <p:spPr>
+          <a:xfrm>
+            <a:off x="640080" y="2743200"/>
+            <a:ext cx="822960" cy="548640"/>
+          </a:xfrm>
+          <a:prstGeom prst="rect">
+            <a:avLst/>
+          </a:prstGeom>
+          <a:noFill/>
+          <a:ln/>
+        </p:spPr>
+        <p:txBody>
+          <a:bodyPr wrap="square" lIns="0" tIns="0" rIns="0" bIns="0" rtlCol="0" anchor="t"/>
+          <a:lstStyle/>
+          <a:p>
+            <a:pPr indent="0" marL="0">
+              <a:buNone/>
+            </a:pPr>
+            <a:r>
+              <a:rPr lang="en-US" sz="2400" dirty="0">
+                <a:solidFill>
+                  <a:schemeClr val="accent1"/>
+                </a:solidFill>
+                <a:latin typeface="Arial" pitchFamily="34" charset="0"/>
+                <a:ea typeface="Arial" pitchFamily="34" charset="-122"/>
+                <a:cs typeface="Arial" pitchFamily="34" charset="-120"/>
+              </a:rPr>
+              <a:t>02</a:t>
+            </a:r>
+            <a:endParaRPr lang="en-US" sz="2400" dirty="0"/>
+          </a:p>
+        </p:txBody>
+      </p:sp>
+      <p:sp>
+        <p:nvSpPr>
+          <p:cNvPr id="7" name="Text 5"/>
+          <p:cNvSpPr txBox="1"/>
+          <p:nvPr/>
+        </p:nvSpPr>
+        <p:spPr>
+          <a:xfrm>
+            <a:off x="1554480" y="2743200"/>
+            <a:ext cx="9966960" cy="685800"/>
+          </a:xfrm>
+          <a:prstGeom prst="rect">
+            <a:avLst/>
+          </a:prstGeom>
+          <a:noFill/>
+          <a:ln/>
+        </p:spPr>
+        <p:txBody>
+          <a:bodyPr wrap="square" lIns="0" tIns="0" rIns="0" bIns="0" rtlCol="0" anchor="t"/>
+          <a:lstStyle/>
+          <a:p>
+            <a:pPr indent="0" marL="0">
+              <a:buNone/>
+            </a:pPr>
+            <a:r>
+              <a:rPr lang="en-US" sz="1600" b="1" dirty="0">
+                <a:solidFill>
+                  <a:schemeClr val="tx1"/>
+                </a:solidFill>
+              </a:rPr>
+              <a:t>ZDFheute: „Mit Palmsonntag beginnt die Karwoche“</a:t>
+            </a:r>
+            <a:endParaRPr lang="en-US" sz="1600" dirty="0"/>
+          </a:p>
+          <a:p>
+            <a:pPr indent="0" marL="0">
+              <a:buNone/>
+            </a:pPr>
+            <a:r>
+              <a:rPr lang="en-US" sz="1100" u="sng" dirty="0">
+                <a:solidFill>
+                  <a:schemeClr val="tx2"/>
+                </a:solidFill>
+                <a:hlinkClick r:id="rId2" invalidUrl="" action="" tgtFrame="" tooltip="" history="1" highlightClick="0" endSnd="0">
+                  <a:extLst>
+                    <a:ext uri="{A12FA001-AC4F-418D-AE19-62706E023703}">
+                      <ahyp:hlinkClr xmlns:ahyp="http://schemas.microsoft.com/office/drawing/2018/hyperlinkcolor" val="tx"/>
+                    </a:ext>
+                  </a:extLst>
+                </a:hlinkClick>
+              </a:rPr>
+              <a:t>https://www.zdfheute.de/wissen/ostern-feiertage-karfreitag-karwoche-palmsonntag-100.html</a:t>
+            </a:r>
+            <a:endParaRPr lang="en-US" sz="1600" dirty="0"/>
+          </a:p>
+        </p:txBody>
+      </p:sp>
+      <p:sp>
+        <p:nvSpPr>
+          <p:cNvPr id="8" name="Linie"/>
+          <p:cNvSpPr/>
+          <p:nvPr/>
+        </p:nvSpPr>
+        <p:spPr>
+          <a:xfrm>
+            <a:off x="640080" y="3547872"/>
+            <a:ext cx="10881360" cy="0"/>
+          </a:xfrm>
+          <a:prstGeom prst="line">
+            <a:avLst/>
+          </a:prstGeom>
+          <a:noFill/>
+          <a:ln w="9525">
+            <a:solidFill>
+              <a:schemeClr val="accent2"/>
+            </a:solidFill>
+            <a:prstDash val="solid"/>
+          </a:ln>
+        </p:spPr>
+      </p:sp>
+      <p:sp>
+        <p:nvSpPr>
+          <p:cNvPr id="9" name="Text 7"/>
+          <p:cNvSpPr txBox="1"/>
+          <p:nvPr/>
+        </p:nvSpPr>
+        <p:spPr>
+          <a:xfrm>
+            <a:off x="640080" y="3657600"/>
+            <a:ext cx="822960" cy="548640"/>
+          </a:xfrm>
+          <a:prstGeom prst="rect">
+            <a:avLst/>
+          </a:prstGeom>
+          <a:noFill/>
+          <a:ln/>
+        </p:spPr>
+        <p:txBody>
+          <a:bodyPr wrap="square" lIns="0" tIns="0" rIns="0" bIns="0" rtlCol="0" anchor="t"/>
+          <a:lstStyle/>
+          <a:p>
+            <a:pPr indent="0" marL="0">
+              <a:buNone/>
+            </a:pPr>
+            <a:r>
+              <a:rPr lang="en-US" sz="2400" dirty="0">
+                <a:solidFill>
+                  <a:schemeClr val="accent1"/>
+                </a:solidFill>
+                <a:latin typeface="Arial" pitchFamily="34" charset="0"/>
+                <a:ea typeface="Arial" pitchFamily="34" charset="-122"/>
+                <a:cs typeface="Arial" pitchFamily="34" charset="-120"/>
+              </a:rPr>
+              <a:t>03</a:t>
+            </a:r>
+            <a:endParaRPr lang="en-US" sz="2400" dirty="0"/>
+          </a:p>
+        </p:txBody>
+      </p:sp>
+      <p:sp>
+        <p:nvSpPr>
+          <p:cNvPr id="10" name="Text 8"/>
+          <p:cNvSpPr txBox="1"/>
+          <p:nvPr/>
+        </p:nvSpPr>
+        <p:spPr>
+          <a:xfrm>
+            <a:off x="1554480" y="3657600"/>
+            <a:ext cx="9966960" cy="685800"/>
+          </a:xfrm>
+          <a:prstGeom prst="rect">
+            <a:avLst/>
+          </a:prstGeom>
+          <a:noFill/>
+          <a:ln/>
+        </p:spPr>
+        <p:txBody>
+          <a:bodyPr wrap="square" lIns="0" tIns="0" rIns="0" bIns="0" rtlCol="0" anchor="t"/>
+          <a:lstStyle/>
+          <a:p>
+            <a:pPr indent="0" marL="0">
+              <a:buNone/>
+            </a:pPr>
+            <a:r>
+              <a:rPr lang="en-US" sz="1600" b="1" dirty="0">
+                <a:solidFill>
+                  <a:schemeClr val="tx1"/>
+                </a:solidFill>
+              </a:rPr>
+              <a:t>bpb: Ramadan (Deine tägliche Dosis Politik)</a:t>
+            </a:r>
+            <a:endParaRPr lang="en-US" sz="1600" dirty="0"/>
+          </a:p>
+          <a:p>
+            <a:pPr indent="0" marL="0">
+              <a:buNone/>
+            </a:pPr>
+            <a:r>
+              <a:rPr lang="en-US" sz="1100" u="sng" dirty="0">
+                <a:solidFill>
+                  <a:schemeClr val="tx2"/>
+                </a:solidFill>
+                <a:hlinkClick r:id="rId3" invalidUrl="" action="" tgtFrame="" tooltip="" history="1" highlightClick="0" endSnd="0">
+                  <a:extLst>
+                    <a:ext uri="{A12FA001-AC4F-418D-AE19-62706E023703}">
+                      <ahyp:hlinkClr xmlns:ahyp="http://schemas.microsoft.com/office/drawing/2018/hyperlinkcolor" val="tx"/>
+                    </a:ext>
+                  </a:extLst>
+                </a:hlinkClick>
+              </a:rPr>
+              <a:t>https://www.bpb.de/kurz-knapp/taegliche-dosis-politik/559978/ramadan/</a:t>
+            </a:r>
+            <a:endParaRPr lang="en-US" sz="1600" dirty="0"/>
+          </a:p>
+        </p:txBody>
+      </p:sp>
+      <p:sp>
+        <p:nvSpPr>
+          <p:cNvPr id="11" name="Linie"/>
+          <p:cNvSpPr/>
+          <p:nvPr/>
+        </p:nvSpPr>
+        <p:spPr>
+          <a:xfrm>
+            <a:off x="640080" y="4462272"/>
+            <a:ext cx="10881360" cy="0"/>
+          </a:xfrm>
+          <a:prstGeom prst="line">
+            <a:avLst/>
+          </a:prstGeom>
+          <a:noFill/>
+          <a:ln w="9525">
+            <a:solidFill>
+              <a:schemeClr val="accent2"/>
+            </a:solidFill>
+            <a:prstDash val="solid"/>
+          </a:ln>
+        </p:spPr>
+      </p:sp>
+      <p:sp>
+        <p:nvSpPr>
+          <p:cNvPr id="12" name="Text 10"/>
+          <p:cNvSpPr txBox="1"/>
+          <p:nvPr/>
+        </p:nvSpPr>
+        <p:spPr>
+          <a:xfrm>
+            <a:off x="640080" y="4572000"/>
+            <a:ext cx="822960" cy="548640"/>
+          </a:xfrm>
+          <a:prstGeom prst="rect">
+            <a:avLst/>
+          </a:prstGeom>
+          <a:noFill/>
+          <a:ln/>
+        </p:spPr>
+        <p:txBody>
+          <a:bodyPr wrap="square" lIns="0" tIns="0" rIns="0" bIns="0" rtlCol="0" anchor="t"/>
+          <a:lstStyle/>
+          <a:p>
+            <a:pPr indent="0" marL="0">
+              <a:buNone/>
+            </a:pPr>
+            <a:r>
+              <a:rPr lang="en-US" sz="2400" dirty="0">
+                <a:solidFill>
+                  <a:schemeClr val="accent1"/>
+                </a:solidFill>
+                <a:latin typeface="Arial" pitchFamily="34" charset="0"/>
+                <a:ea typeface="Arial" pitchFamily="34" charset="-122"/>
+                <a:cs typeface="Arial" pitchFamily="34" charset="-120"/>
+              </a:rPr>
+              <a:t>04</a:t>
+            </a:r>
+            <a:endParaRPr lang="en-US" sz="2400" dirty="0"/>
+          </a:p>
+        </p:txBody>
+      </p:sp>
+      <p:sp>
+        <p:nvSpPr>
+          <p:cNvPr id="13" name="Text 11"/>
+          <p:cNvSpPr txBox="1"/>
+          <p:nvPr/>
+        </p:nvSpPr>
+        <p:spPr>
+          <a:xfrm>
+            <a:off x="1554480" y="4572000"/>
+            <a:ext cx="9966960" cy="685800"/>
+          </a:xfrm>
+          <a:prstGeom prst="rect">
+            <a:avLst/>
+          </a:prstGeom>
+          <a:noFill/>
+          <a:ln/>
+        </p:spPr>
+        <p:txBody>
+          <a:bodyPr wrap="square" lIns="0" tIns="0" rIns="0" bIns="0" rtlCol="0" anchor="t"/>
+          <a:lstStyle/>
+          <a:p>
+            <a:pPr indent="0" marL="0">
+              <a:buNone/>
+            </a:pPr>
+            <a:r>
+              <a:rPr lang="en-US" sz="1600" b="1" dirty="0">
+                <a:solidFill>
+                  <a:schemeClr val="tx1"/>
+                </a:solidFill>
+              </a:rPr>
+              <a:t>bpb: M 06.06 Gemeinsam (religiöse) Feste feiern</a:t>
+            </a:r>
+            <a:endParaRPr lang="en-US" sz="1600" dirty="0"/>
+          </a:p>
+          <a:p>
+            <a:pPr indent="0" marL="0">
+              <a:buNone/>
+            </a:pPr>
+            <a:r>
+              <a:rPr lang="en-US" sz="1100" u="sng" dirty="0">
+                <a:solidFill>
+                  <a:schemeClr val="tx2"/>
+                </a:solidFill>
+                <a:hlinkClick r:id="rId4" invalidUrl="" action="" tgtFrame="" tooltip="" history="1" highlightClick="0" endSnd="0">
+                  <a:extLst>
+                    <a:ext uri="{A12FA001-AC4F-418D-AE19-62706E023703}">
+                      <ahyp:hlinkClr xmlns:ahyp="http://schemas.microsoft.com/office/drawing/2018/hyperlinkcolor" val="tx"/>
+                    </a:ext>
+                  </a:extLst>
+                </a:hlinkClick>
+              </a:rPr>
+              <a:t>https://www.bpb.de/lernen/angebote/grafstat/projekt-integration/134726/m-06-06-gemeinsam-religioese-feste-feiern/</a:t>
+            </a:r>
+            <a:endParaRPr lang="en-US" sz="1600" dirty="0"/>
+          </a:p>
+        </p:txBody>
+      </p:sp>
+      <p:sp>
+        <p:nvSpPr>
+          <p:cNvPr id="14" name="Linie"/>
+          <p:cNvSpPr/>
+          <p:nvPr/>
+        </p:nvSpPr>
+        <p:spPr>
+          <a:xfrm>
+            <a:off x="640080" y="5376672"/>
+            <a:ext cx="10881360" cy="0"/>
+          </a:xfrm>
+          <a:prstGeom prst="line">
+            <a:avLst/>
+          </a:prstGeom>
+          <a:noFill/>
+          <a:ln w="9525">
+            <a:solidFill>
+              <a:schemeClr val="accent2"/>
+            </a:solidFill>
+            <a:prstDash val="solid"/>
+          </a:ln>
+        </p:spPr>
+      </p:sp>
+      <p:sp>
+        <p:nvSpPr>
+          <p:cNvPr id="15" name="Text 13"/>
+          <p:cNvSpPr txBox="1"/>
+          <p:nvPr/>
+        </p:nvSpPr>
+        <p:spPr>
+          <a:xfrm>
+            <a:off x="1554480" y="5532120"/>
+            <a:ext cx="9966960" cy="274320"/>
+          </a:xfrm>
+          <a:prstGeom prst="rect">
+            <a:avLst/>
+          </a:prstGeom>
+          <a:noFill/>
+          <a:ln/>
+        </p:spPr>
+        <p:txBody>
+          <a:bodyPr wrap="square" lIns="0" tIns="0" rIns="0" bIns="0" rtlCol="0" anchor="t"/>
+          <a:lstStyle/>
+          <a:p>
+            <a:pPr indent="0" marL="0">
+              <a:buNone/>
+            </a:pPr>
+            <a:r>
+              <a:rPr lang="en-US" sz="1200" dirty="0">
+                <a:solidFill>
+                  <a:schemeClr val="tx2"/>
+                </a:solidFill>
+              </a:rPr>
+              <a:t>Aufgabe 7 (ALDI SÜD): aldi-sued.de (Newsroom, Blog, Karnevalsseite) · t-online.de · web.de · generali.de</a:t>
+            </a:r>
+            <a:endParaRPr lang="en-US" sz="1200" dirty="0"/>
+          </a:p>
+        </p:txBody>
+      </p:sp>
+      <p:sp>
+        <p:nvSpPr>
+          <p:cNvPr id="16" name="Text 14"/>
+          <p:cNvSpPr txBox="1"/>
+          <p:nvPr/>
+        </p:nvSpPr>
+        <p:spPr>
+          <a:xfrm>
+            <a:off x="1554480" y="5852160"/>
+            <a:ext cx="9966960" cy="274320"/>
+          </a:xfrm>
+          <a:prstGeom prst="rect">
+            <a:avLst/>
+          </a:prstGeom>
+          <a:noFill/>
+          <a:ln/>
+        </p:spPr>
+        <p:txBody>
+          <a:bodyPr wrap="square" lIns="0" tIns="0" rIns="0" bIns="0" rtlCol="0" anchor="t"/>
+          <a:lstStyle/>
+          <a:p>
+            <a:pPr indent="0" marL="0">
+              <a:buNone/>
+            </a:pPr>
+            <a:r>
+              <a:rPr lang="en-US" sz="1200" i="1" dirty="0">
+                <a:solidFill>
+                  <a:schemeClr val="tx2"/>
+                </a:solidFill>
+              </a:rPr>
+              <a:t>Bildquellen: Karneval- und Osterfotos – bitte ergänzen</a:t>
+            </a:r>
+            <a:endParaRPr lang="en-US" sz="1200" dirty="0"/>
+          </a:p>
+        </p:txBody>
+      </p:sp>
+      <p:sp>
+        <p:nvSpPr>
+          <p:cNvPr id="17" name="Text 0"/>
+          <p:cNvSpPr/>
+          <p:nvPr>
+            <p:ph idx="100" type="title" hasCustomPrompt="1"/>
+          </p:nvPr>
+        </p:nvSpPr>
+        <p:spPr>
+          <a:xfrm>
+            <a:off x="640080" y="822960"/>
+            <a:ext cx="10241280" cy="731520"/>
+          </a:xfrm>
+          <a:prstGeom prst="rect">
+            <a:avLst/>
+          </a:prstGeom>
+          <a:noFill/>
+          <a:ln/>
+        </p:spPr>
+        <p:txBody>
+          <a:bodyPr wrap="square" lIns="0" tIns="0" rIns="0" bIns="0" rtlCol="0" anchor="t"/>
+          <a:lstStyle/>
+          <a:p>
+            <a:pPr algn="l" indent="0" marL="0">
+              <a:buNone/>
+            </a:pPr>
+            <a:r>
+              <a:rPr lang="en-US" sz="2800" b="1" dirty="0">
+                <a:solidFill>
+                  <a:schemeClr val="tx1"/>
+                </a:solidFill>
+                <a:latin typeface="Arial" pitchFamily="34" charset="0"/>
+                <a:ea typeface="Arial" pitchFamily="34" charset="-122"/>
+                <a:cs typeface="Arial" pitchFamily="34" charset="-120"/>
+              </a:rPr>
+              <a:t>Quellen</a:t>
+            </a:r>
+            <a:endParaRPr lang="en-US" sz="2800" dirty="0"/>
+          </a:p>
+        </p:txBody>
+      </p:sp>
+      <p:sp>
+        <p:nvSpPr>
+          <p:cNvPr id="25" name="Slide Number Placeholder 0"/>
+          <p:cNvSpPr>
+            <a:spLocks noGrp="1"/>
+          </p:cNvSpPr>
+          <p:nvPr>
+            <p:ph type="sldNum" sz="quarter" idx="4294967295"/>
+          </p:nvPr>
+        </p:nvSpPr>
+        <p:spPr>
+          <a:xfrm>
+            <a:off x="11155680" y="347472"/>
+            <a:ext cx="566928" cy="329184"/>
+          </a:xfrm>
+          <a:prstGeom prst="rect">
+            <a:avLst/>
+          </a:prstGeom>
+          <a:extLst>
+            <a:ext uri="{C572A759-6A51-4108-AA02-DFA0A04FC94B}">
+              <ma14:wrappingTextBoxFlag xmlns:ma14="http://schemas.microsoft.com/office/mac/drawingml/2011/main" val="0"/>
+            </a:ext>
+          </a:extLst>
+        </p:spPr>
+        <p:txBody>
+          <a:bodyPr lIns="0" tIns="0" rIns="0" bIns="0" anchor="ctr"/>
+          <a:lstStyle>
+            <a:lvl1pPr>
+              <a:defRPr sz="1000">
+                <a:solidFill>
+                  <a:schemeClr val="tx1"/>
+                </a:solidFill>
+              </a:defRPr>
+            </a:lvl1pPr>
+          </a:lstStyle>
+          <a:p>
+            <a:pPr algn="ctr"/>
+            <a:fld id="{F7021451-1387-4CA6-816F-3879F97B5CBC}" type="slidenum">
+              <a:rPr b="0" lang="en-US"/>
+              <a:t>20</a:t>
+            </a:fld>
+            <a:endParaRPr lang="en-US"/>
+          </a:p>
+        </p:txBody>
+      </p:sp>
+    </p:spTree>
+  </p:cSld>
+  <p:clrMapOvr>
+    <a:masterClrMapping/>
+  </p:clrMapOvr>
+</p:sld>
+</file>
+
+<file path=ppt/slides/slide21.xml><?xml version="1.0" encoding="utf-8"?>
+<p:sld xmlns:a="http://schemas.openxmlformats.org/drawingml/2006/main" xmlns:r="http://schemas.openxmlformats.org/officeDocument/2006/relationships" xmlns:p="http://schemas.openxmlformats.org/presentationml/2006/main">
+  <p:cSld name="Slide 21">
     <p:bg>
       <p:bgPr>
         <a:blipFill dpi="0" rotWithShape="1">

</xml_diff>

<commit_message>
Eigene Mitschriften zu Aufgabe 1 und 2 einarbeiten
Bedeutung von Ostern nach Mitschrift vom 12.10. (Quelle Wikipedia),
Zeitstrahl Aschermittwoch bis Ostersonntag nach Mitschrift vom 14.10.
mit Fastenzeit-Klammer; Quellenfolie ergänzt.

Co-Authored-By: Claude Opus 5.5 <noreply@anthropic.com>
Claude-Session: https://claude.ai/code/session_01EsbPSfyjZCqBtDb5d3uQeV
</commit_message>
<xml_diff>
--- a/Karneval_und_Ostern.pptx
+++ b/Karneval_und_Ostern.pptx
@@ -127,13 +127,13 @@
   <p:extLst>
     <p:ext uri="{521415D9-36F7-43E2-AB2F-B90AF26B5E84}">
       <p14:sectionLst xmlns:p14="http://schemas.microsoft.com/office/powerpoint/2010/main">
-        <p14:section name="Einstieg" id="{604d9fda-8042-7380-47d3-3e23b0becd1b}">
+        <p14:section name="Einstieg" id="{38cd89e5-e966-c54b-6657-4107e65c7b7e}">
           <p14:sldIdLst>
             <p14:sldId id="256"/>
             <p14:sldId id="257"/>
           </p14:sldIdLst>
         </p14:section>
-        <p14:section name="Karneval" id="{b19c8424-377e-a99d-0c70-f6e8ac805c96}">
+        <p14:section name="Karneval" id="{03e78eb1-6a02-271c-adde-ddb7cf6e3aa8}">
           <p14:sldIdLst>
             <p14:sldId id="258"/>
             <p14:sldId id="259"/>
@@ -141,13 +141,13 @@
             <p14:sldId id="261"/>
           </p14:sldIdLst>
         </p14:section>
-        <p14:section name="Fastenzeit" id="{2b356bec-be95-0068-c29e-d0b4699dbb36}">
+        <p14:section name="Fastenzeit" id="{1566c174-a0f8-05ab-35da-7bbf1a97df11}">
           <p14:sldIdLst>
             <p14:sldId id="262"/>
             <p14:sldId id="263"/>
           </p14:sldIdLst>
         </p14:section>
-        <p14:section name="Ostern" id="{10bc8eb9-3a9e-55d7-8964-7ab74131a4fd}">
+        <p14:section name="Ostern" id="{6a2ba4eb-5c81-2de2-baf8-e22675958bfa}">
           <p14:sldIdLst>
             <p14:sldId id="264"/>
             <p14:sldId id="265"/>
@@ -155,7 +155,7 @@
             <p14:sldId id="267"/>
           </p14:sldIdLst>
         </p14:section>
-        <p14:section name="Andere Religionen" id="{d5f62f1e-b3a4-60b5-37f7-f4dd7f0f053a}">
+        <p14:section name="Andere Religionen" id="{25924280-1015-2e55-9b07-4ea75e2b4903}">
           <p14:sldIdLst>
             <p14:sldId id="268"/>
             <p14:sldId id="269"/>
@@ -163,7 +163,7 @@
             <p14:sldId id="271"/>
           </p14:sldIdLst>
         </p14:section>
-        <p14:section name="Abschluss" id="{441c3365-53e4-9015-74cd-54919125d990}">
+        <p14:section name="Abschluss" id="{8a4bde4d-ea80-cc07-0d86-8c275af809a1}">
           <p14:sldIdLst>
             <p14:sldId id="272"/>
             <p14:sldId id="273"/>
@@ -5001,31 +5001,31 @@
         </p:nvSpPr>
         <p:spPr>
           <a:xfrm>
-            <a:off x="6080760" y="1828800"/>
-            <a:ext cx="5394960" cy="4297680"/>
-          </a:xfrm>
-          <a:prstGeom prst="rect">
-            <a:avLst/>
-          </a:prstGeom>
-          <a:noFill/>
-          <a:ln/>
-        </p:spPr>
-        <p:txBody>
-          <a:bodyPr wrap="square" lIns="0" tIns="0" rIns="0" bIns="0" rtlCol="0" anchor="t"/>
-          <a:lstStyle/>
-          <a:p>
-            <a:pPr indent="0" marL="0">
-              <a:buNone/>
-            </a:pPr>
-            <a:r>
-              <a:rPr lang="en-US" sz="1100" b="1" spc="300" kern="0" dirty="0">
+            <a:off x="6080760" y="1783080"/>
+            <a:ext cx="5394960" cy="4480560"/>
+          </a:xfrm>
+          <a:prstGeom prst="rect">
+            <a:avLst/>
+          </a:prstGeom>
+          <a:noFill/>
+          <a:ln/>
+        </p:spPr>
+        <p:txBody>
+          <a:bodyPr wrap="square" lIns="0" tIns="0" rIns="0" bIns="0" rtlCol="0" anchor="t"/>
+          <a:lstStyle/>
+          <a:p>
+            <a:pPr indent="0" marL="0">
+              <a:buNone/>
+            </a:pPr>
+            <a:r>
+              <a:rPr lang="en-US" sz="1050" b="1" spc="300" kern="0" dirty="0">
                 <a:solidFill>
                   <a:schemeClr val="accent1"/>
                 </a:solidFill>
               </a:rPr>
-              <a:t>DAS WICHTIGSTE FEST</a:t>
-            </a:r>
-            <a:endParaRPr lang="en-US" sz="1100" dirty="0"/>
+              <a:t>DAS HÖCHSTE FEST</a:t>
+            </a:r>
+            <a:endParaRPr lang="en-US" sz="1050" dirty="0"/>
           </a:p>
           <a:p>
             <a:pPr indent="0" marL="0">
@@ -5035,28 +5035,28 @@
               <a:buNone/>
             </a:pPr>
             <a:r>
-              <a:rPr lang="en-US" sz="1500" dirty="0">
+              <a:rPr lang="en-US" sz="1450" dirty="0">
                 <a:solidFill>
                   <a:schemeClr val="tx1"/>
                 </a:solidFill>
               </a:rPr>
-              <a:t>Ostern ist das älteste und höchste Fest der Christen.</a:t>
-            </a:r>
-            <a:endParaRPr lang="en-US" sz="1100" dirty="0"/>
-          </a:p>
-          <a:p>
-            <a:pPr indent="0" marL="0">
-              <a:buNone/>
-            </a:pPr>
-            <a:r>
-              <a:rPr lang="en-US" sz="1100" b="1" spc="300" kern="0" dirty="0">
+              <a:t>Ostern ist das höchste christliche Fest.</a:t>
+            </a:r>
+            <a:endParaRPr lang="en-US" sz="1050" dirty="0"/>
+          </a:p>
+          <a:p>
+            <a:pPr indent="0" marL="0">
+              <a:buNone/>
+            </a:pPr>
+            <a:r>
+              <a:rPr lang="en-US" sz="1050" b="1" spc="300" kern="0" dirty="0">
                 <a:solidFill>
                   <a:schemeClr val="accent1"/>
                 </a:solidFill>
               </a:rPr>
               <a:t>AUFERSTEHUNG</a:t>
             </a:r>
-            <a:endParaRPr lang="en-US" sz="1100" dirty="0"/>
+            <a:endParaRPr lang="en-US" sz="1050" dirty="0"/>
           </a:p>
           <a:p>
             <a:pPr indent="0" marL="0">
@@ -5066,28 +5066,28 @@
               <a:buNone/>
             </a:pPr>
             <a:r>
-              <a:rPr lang="en-US" sz="1500" dirty="0">
+              <a:rPr lang="en-US" sz="1450" dirty="0">
                 <a:solidFill>
                   <a:schemeClr val="tx1"/>
                 </a:solidFill>
               </a:rPr>
-              <a:t>Jesus starb am Kreuz – Christen glauben, dass er von den Toten auferstanden ist.</a:t>
-            </a:r>
-            <a:endParaRPr lang="en-US" sz="1100" dirty="0"/>
-          </a:p>
-          <a:p>
-            <a:pPr indent="0" marL="0">
-              <a:buNone/>
-            </a:pPr>
-            <a:r>
-              <a:rPr lang="en-US" sz="1100" b="1" spc="300" kern="0" dirty="0">
+              <a:t>Gefeiert wird die Auferstehung Jesu am dritten Tag nach seinem Tod am Kreuz.</a:t>
+            </a:r>
+            <a:endParaRPr lang="en-US" sz="1050" dirty="0"/>
+          </a:p>
+          <a:p>
+            <a:pPr indent="0" marL="0">
+              <a:buNone/>
+            </a:pPr>
+            <a:r>
+              <a:rPr lang="en-US" sz="1050" b="1" spc="300" kern="0" dirty="0">
                 <a:solidFill>
                   <a:schemeClr val="accent1"/>
                 </a:solidFill>
               </a:rPr>
-              <a:t>HOFFNUNG</a:t>
-            </a:r>
-            <a:endParaRPr lang="en-US" sz="1100" dirty="0"/>
+              <a:t>KARFREITAG &amp; OSTERSONNTAG</a:t>
+            </a:r>
+            <a:endParaRPr lang="en-US" sz="1050" dirty="0"/>
           </a:p>
           <a:p>
             <a:pPr indent="0" marL="0">
@@ -5097,28 +5097,28 @@
               <a:buNone/>
             </a:pPr>
             <a:r>
-              <a:rPr lang="en-US" sz="1500" dirty="0">
+              <a:rPr lang="en-US" sz="1450" dirty="0">
                 <a:solidFill>
                   <a:schemeClr val="tx1"/>
                 </a:solidFill>
               </a:rPr>
-              <a:t>Der Tod hat nicht das letzte Wort. Ostern steht für neues Leben.</a:t>
-            </a:r>
-            <a:endParaRPr lang="en-US" sz="1100" dirty="0"/>
-          </a:p>
-          <a:p>
-            <a:pPr indent="0" marL="0">
-              <a:buNone/>
-            </a:pPr>
-            <a:r>
-              <a:rPr lang="en-US" sz="1100" b="1" spc="300" kern="0" dirty="0">
+              <a:t>Karfreitag ist der Todestag, Ostersonntag der Tag der Auferstehung.</a:t>
+            </a:r>
+            <a:endParaRPr lang="en-US" sz="1050" dirty="0"/>
+          </a:p>
+          <a:p>
+            <a:pPr indent="0" marL="0">
+              <a:buNone/>
+            </a:pPr>
+            <a:r>
+              <a:rPr lang="en-US" sz="1050" b="1" spc="300" kern="0" dirty="0">
                 <a:solidFill>
                   <a:schemeClr val="accent1"/>
                 </a:solidFill>
               </a:rPr>
-              <a:t>BEWEGLICHER FEIERTAG</a:t>
-            </a:r>
-            <a:endParaRPr lang="en-US" sz="1100" dirty="0"/>
+              <a:t>WANN?</a:t>
+            </a:r>
+            <a:endParaRPr lang="en-US" sz="1050" dirty="0"/>
           </a:p>
           <a:p>
             <a:pPr indent="0" marL="0">
@@ -5128,14 +5128,45 @@
               <a:buNone/>
             </a:pPr>
             <a:r>
-              <a:rPr lang="en-US" sz="1500" dirty="0">
+              <a:rPr lang="en-US" sz="1450" dirty="0">
                 <a:solidFill>
                   <a:schemeClr val="tx1"/>
                 </a:solidFill>
               </a:rPr>
-              <a:t>Immer der Sonntag nach dem ersten Vollmond im Frühling.</a:t>
-            </a:r>
-            <a:endParaRPr lang="en-US" sz="1100" dirty="0"/>
+              <a:t>Am Sonntag nach dem ersten Frühlingsvollmond.</a:t>
+            </a:r>
+            <a:endParaRPr lang="en-US" sz="1050" dirty="0"/>
+          </a:p>
+          <a:p>
+            <a:pPr indent="0" marL="0">
+              <a:buNone/>
+            </a:pPr>
+            <a:r>
+              <a:rPr lang="en-US" sz="1050" b="1" spc="300" kern="0" dirty="0">
+                <a:solidFill>
+                  <a:schemeClr val="accent1"/>
+                </a:solidFill>
+              </a:rPr>
+              <a:t>ÖSTERLICHE FREUDENZEIT</a:t>
+            </a:r>
+            <a:endParaRPr lang="en-US" sz="1050" dirty="0"/>
+          </a:p>
+          <a:p>
+            <a:pPr indent="0" marL="0">
+              <a:spcAft>
+                <a:spcPts val="1400"/>
+              </a:spcAft>
+              <a:buNone/>
+            </a:pPr>
+            <a:r>
+              <a:rPr lang="en-US" sz="1450" dirty="0">
+                <a:solidFill>
+                  <a:schemeClr val="tx1"/>
+                </a:solidFill>
+              </a:rPr>
+              <a:t>Sie beginnt mit der Nacht zum Ostersonntag und dauert bis Pfingsten.</a:t>
+            </a:r>
+            <a:endParaRPr lang="en-US" sz="1050" dirty="0"/>
           </a:p>
         </p:txBody>
       </p:sp>
@@ -5210,7 +5241,7 @@
                   <a:schemeClr val="tx2"/>
                 </a:solidFill>
               </a:rPr>
-              <a:t>Quelle: ZDFheute</a:t>
+              <a:t>Quelle: Wikipedia, Artikel „Ostern“ (abgerufen am 12.10.2026)</a:t>
             </a:r>
             <a:endParaRPr lang="en-US" sz="900" dirty="0"/>
           </a:p>
@@ -5410,7 +5441,7 @@
         <p:spPr>
           <a:xfrm>
             <a:off x="640080" y="3383280"/>
-            <a:ext cx="1947672" cy="274320"/>
+            <a:ext cx="1947672" cy="457200"/>
           </a:xfrm>
           <a:prstGeom prst="rect">
             <a:avLst/>
@@ -5445,8 +5476,8 @@
         </p:nvSpPr>
         <p:spPr>
           <a:xfrm>
-            <a:off x="640080" y="3794760"/>
-            <a:ext cx="1901952" cy="2377440"/>
+            <a:off x="640080" y="3931920"/>
+            <a:ext cx="1901952" cy="2286000"/>
           </a:xfrm>
           <a:prstGeom prst="rect">
             <a:avLst/>
@@ -5538,7 +5569,7 @@
         <p:spPr>
           <a:xfrm>
             <a:off x="2816352" y="3383280"/>
-            <a:ext cx="1947672" cy="274320"/>
+            <a:ext cx="1947672" cy="457200"/>
           </a:xfrm>
           <a:prstGeom prst="rect">
             <a:avLst/>
@@ -5573,8 +5604,8 @@
         </p:nvSpPr>
         <p:spPr>
           <a:xfrm>
-            <a:off x="2816352" y="3794760"/>
-            <a:ext cx="1901952" cy="2377440"/>
+            <a:off x="2816352" y="3931920"/>
+            <a:ext cx="1901952" cy="2286000"/>
           </a:xfrm>
           <a:prstGeom prst="rect">
             <a:avLst/>
@@ -5666,7 +5697,7 @@
         <p:spPr>
           <a:xfrm>
             <a:off x="4992624" y="3383280"/>
-            <a:ext cx="1947672" cy="274320"/>
+            <a:ext cx="1947672" cy="457200"/>
           </a:xfrm>
           <a:prstGeom prst="rect">
             <a:avLst/>
@@ -5701,8 +5732,8 @@
         </p:nvSpPr>
         <p:spPr>
           <a:xfrm>
-            <a:off x="4992624" y="3794760"/>
-            <a:ext cx="1901952" cy="2377440"/>
+            <a:off x="4992624" y="3931920"/>
+            <a:ext cx="1901952" cy="2286000"/>
           </a:xfrm>
           <a:prstGeom prst="rect">
             <a:avLst/>
@@ -5794,7 +5825,7 @@
         <p:spPr>
           <a:xfrm>
             <a:off x="7168896" y="3383280"/>
-            <a:ext cx="1947672" cy="274320"/>
+            <a:ext cx="1947672" cy="457200"/>
           </a:xfrm>
           <a:prstGeom prst="rect">
             <a:avLst/>
@@ -5829,8 +5860,8 @@
         </p:nvSpPr>
         <p:spPr>
           <a:xfrm>
-            <a:off x="7168896" y="3794760"/>
-            <a:ext cx="1901952" cy="2377440"/>
+            <a:off x="7168896" y="3931920"/>
+            <a:ext cx="1901952" cy="2286000"/>
           </a:xfrm>
           <a:prstGeom prst="rect">
             <a:avLst/>
@@ -5922,7 +5953,7 @@
         <p:spPr>
           <a:xfrm>
             <a:off x="9345168" y="3383280"/>
-            <a:ext cx="1947672" cy="274320"/>
+            <a:ext cx="1947672" cy="457200"/>
           </a:xfrm>
           <a:prstGeom prst="rect">
             <a:avLst/>
@@ -5957,8 +5988,8 @@
         </p:nvSpPr>
         <p:spPr>
           <a:xfrm>
-            <a:off x="9345168" y="3794760"/>
-            <a:ext cx="1901952" cy="2377440"/>
+            <a:off x="9345168" y="3931920"/>
+            <a:ext cx="1901952" cy="2286000"/>
           </a:xfrm>
           <a:prstGeom prst="rect">
             <a:avLst/>
@@ -11848,8 +11879,8 @@
         </p:nvSpPr>
         <p:spPr>
           <a:xfrm>
-            <a:off x="1554480" y="5532120"/>
-            <a:ext cx="9966960" cy="274320"/>
+            <a:off x="1554480" y="5440680"/>
+            <a:ext cx="9966960" cy="256032"/>
           </a:xfrm>
           <a:prstGeom prst="rect">
             <a:avLst/>
@@ -11870,6 +11901,42 @@
                   <a:schemeClr val="tx2"/>
                 </a:solidFill>
               </a:rPr>
+              <a:t>Aufgabe 1: Wikipedia, Artikel „Ostern“ – https://de.wikipedia.org/wiki/Ostern (abgerufen am 12.10.2026)</a:t>
+            </a:r>
+            <a:endParaRPr lang="en-US" sz="1200" dirty="0"/>
+          </a:p>
+        </p:txBody>
+      </p:sp>
+      <p:sp>
+        <p:nvSpPr>
+          <p:cNvPr id="16" name="Text 14"/>
+          <p:cNvSpPr txBox="1"/>
+          <p:nvPr/>
+        </p:nvSpPr>
+        <p:spPr>
+          <a:xfrm>
+            <a:off x="1554480" y="5696712"/>
+            <a:ext cx="9966960" cy="256032"/>
+          </a:xfrm>
+          <a:prstGeom prst="rect">
+            <a:avLst/>
+          </a:prstGeom>
+          <a:noFill/>
+          <a:ln/>
+        </p:spPr>
+        <p:txBody>
+          <a:bodyPr wrap="square" lIns="0" tIns="0" rIns="0" bIns="0" rtlCol="0" anchor="t"/>
+          <a:lstStyle/>
+          <a:p>
+            <a:pPr indent="0" marL="0">
+              <a:buNone/>
+            </a:pPr>
+            <a:r>
+              <a:rPr lang="en-US" sz="1200" dirty="0">
+                <a:solidFill>
+                  <a:schemeClr val="tx2"/>
+                </a:solidFill>
+              </a:rPr>
               <a:t>Aufgabe 7 (ALDI SÜD): aldi-sued.de (Newsroom, Blog, Karnevalsseite) · t-online.de · web.de · generali.de</a:t>
             </a:r>
             <a:endParaRPr lang="en-US" sz="1200" dirty="0"/>
@@ -11878,14 +11945,14 @@
       </p:sp>
       <p:sp>
         <p:nvSpPr>
-          <p:cNvPr id="16" name="Text 14"/>
-          <p:cNvSpPr txBox="1"/>
-          <p:nvPr/>
-        </p:nvSpPr>
-        <p:spPr>
-          <a:xfrm>
-            <a:off x="1554480" y="5852160"/>
-            <a:ext cx="9966960" cy="274320"/>
+          <p:cNvPr id="17" name="Text 15"/>
+          <p:cNvSpPr txBox="1"/>
+          <p:nvPr/>
+        </p:nvSpPr>
+        <p:spPr>
+          <a:xfrm>
+            <a:off x="1554480" y="5952744"/>
+            <a:ext cx="9966960" cy="256032"/>
           </a:xfrm>
           <a:prstGeom prst="rect">
             <a:avLst/>
@@ -11914,7 +11981,7 @@
       </p:sp>
       <p:sp>
         <p:nvSpPr>
-          <p:cNvPr id="17" name="Text 0"/>
+          <p:cNvPr id="18" name="Text 0"/>
           <p:cNvSpPr/>
           <p:nvPr>
             <p:ph idx="100" type="title" hasCustomPrompt="1"/>
@@ -13711,7 +13778,7 @@
         <p:spPr>
           <a:xfrm>
             <a:off x="640080" y="3383280"/>
-            <a:ext cx="2491740" cy="274320"/>
+            <a:ext cx="2491740" cy="457200"/>
           </a:xfrm>
           <a:prstGeom prst="rect">
             <a:avLst/>
@@ -13746,8 +13813,8 @@
         </p:nvSpPr>
         <p:spPr>
           <a:xfrm>
-            <a:off x="640080" y="3794760"/>
-            <a:ext cx="2446020" cy="2377440"/>
+            <a:off x="640080" y="3931920"/>
+            <a:ext cx="2446020" cy="2286000"/>
           </a:xfrm>
           <a:prstGeom prst="rect">
             <a:avLst/>
@@ -13839,7 +13906,7 @@
         <p:spPr>
           <a:xfrm>
             <a:off x="3360420" y="3383280"/>
-            <a:ext cx="2491740" cy="274320"/>
+            <a:ext cx="2491740" cy="457200"/>
           </a:xfrm>
           <a:prstGeom prst="rect">
             <a:avLst/>
@@ -13874,8 +13941,8 @@
         </p:nvSpPr>
         <p:spPr>
           <a:xfrm>
-            <a:off x="3360420" y="3794760"/>
-            <a:ext cx="2446020" cy="2377440"/>
+            <a:off x="3360420" y="3931920"/>
+            <a:ext cx="2446020" cy="2286000"/>
           </a:xfrm>
           <a:prstGeom prst="rect">
             <a:avLst/>
@@ -13967,7 +14034,7 @@
         <p:spPr>
           <a:xfrm>
             <a:off x="6080760" y="3383280"/>
-            <a:ext cx="2491740" cy="274320"/>
+            <a:ext cx="2491740" cy="457200"/>
           </a:xfrm>
           <a:prstGeom prst="rect">
             <a:avLst/>
@@ -14002,8 +14069,8 @@
         </p:nvSpPr>
         <p:spPr>
           <a:xfrm>
-            <a:off x="6080760" y="3794760"/>
-            <a:ext cx="2446020" cy="2377440"/>
+            <a:off x="6080760" y="3931920"/>
+            <a:ext cx="2446020" cy="2286000"/>
           </a:xfrm>
           <a:prstGeom prst="rect">
             <a:avLst/>
@@ -14095,7 +14162,7 @@
         <p:spPr>
           <a:xfrm>
             <a:off x="8801100" y="3383280"/>
-            <a:ext cx="2491740" cy="274320"/>
+            <a:ext cx="2491740" cy="457200"/>
           </a:xfrm>
           <a:prstGeom prst="rect">
             <a:avLst/>
@@ -14130,8 +14197,8 @@
         </p:nvSpPr>
         <p:spPr>
           <a:xfrm>
-            <a:off x="8801100" y="3794760"/>
-            <a:ext cx="2446020" cy="2377440"/>
+            <a:off x="8801100" y="3931920"/>
+            <a:ext cx="2446020" cy="2286000"/>
           </a:xfrm>
           <a:prstGeom prst="rect">
             <a:avLst/>
@@ -14677,7 +14744,7 @@
         </p:nvSpPr>
         <p:spPr>
           <a:xfrm>
-            <a:off x="640080" y="3108960"/>
+            <a:off x="640080" y="3291840"/>
             <a:ext cx="10881360" cy="0"/>
           </a:xfrm>
           <a:prstGeom prst="line">
@@ -14700,8 +14767,8 @@
         </p:nvSpPr>
         <p:spPr>
           <a:xfrm>
-            <a:off x="640080" y="2148840"/>
-            <a:ext cx="2491740" cy="731520"/>
+            <a:off x="640080" y="2331720"/>
+            <a:ext cx="1947672" cy="731520"/>
           </a:xfrm>
           <a:prstGeom prst="rect">
             <a:avLst/>
@@ -14717,14 +14784,14 @@
               <a:buNone/>
             </a:pPr>
             <a:r>
-              <a:rPr lang="en-US" sz="2400" b="1" dirty="0">
+              <a:rPr lang="en-US" sz="1900" b="1" dirty="0">
                 <a:solidFill>
                   <a:schemeClr val="tx1"/>
                 </a:solidFill>
               </a:rPr>
               <a:t>Aschermittwoch</a:t>
             </a:r>
-            <a:endParaRPr lang="en-US" sz="2400" dirty="0"/>
+            <a:endParaRPr lang="en-US" sz="1900" dirty="0"/>
           </a:p>
         </p:txBody>
       </p:sp>
@@ -14736,7 +14803,7 @@
         </p:nvSpPr>
         <p:spPr>
           <a:xfrm>
-            <a:off x="640080" y="3026664"/>
+            <a:off x="640080" y="3209544"/>
             <a:ext cx="164592" cy="164592"/>
           </a:xfrm>
           <a:prstGeom prst="ellipse">
@@ -14756,8 +14823,8 @@
         </p:nvSpPr>
         <p:spPr>
           <a:xfrm>
-            <a:off x="640080" y="3383280"/>
-            <a:ext cx="2491740" cy="274320"/>
+            <a:off x="640080" y="3566160"/>
+            <a:ext cx="1947672" cy="457200"/>
           </a:xfrm>
           <a:prstGeom prst="rect">
             <a:avLst/>
@@ -14778,7 +14845,7 @@
                   <a:schemeClr val="accent1"/>
                 </a:solidFill>
               </a:rPr>
-              <a:t>&amp; FASTENZEIT</a:t>
+              <a:t>BEGINN DER FASTENZEIT</a:t>
             </a:r>
             <a:endParaRPr lang="en-US" sz="950" dirty="0"/>
           </a:p>
@@ -14792,31 +14859,31 @@
         </p:nvSpPr>
         <p:spPr>
           <a:xfrm>
-            <a:off x="640080" y="3794760"/>
-            <a:ext cx="2446020" cy="2377440"/>
-          </a:xfrm>
-          <a:prstGeom prst="rect">
-            <a:avLst/>
-          </a:prstGeom>
-          <a:noFill/>
-          <a:ln/>
-        </p:spPr>
-        <p:txBody>
-          <a:bodyPr wrap="square" lIns="0" tIns="0" rIns="0" bIns="0" rtlCol="0" anchor="t"/>
-          <a:lstStyle/>
-          <a:p>
-            <a:pPr indent="0" marL="0">
-              <a:buNone/>
-            </a:pPr>
-            <a:r>
-              <a:rPr lang="en-US" sz="1450" dirty="0">
+            <a:off x="640080" y="4114800"/>
+            <a:ext cx="1901952" cy="2286000"/>
+          </a:xfrm>
+          <a:prstGeom prst="rect">
+            <a:avLst/>
+          </a:prstGeom>
+          <a:noFill/>
+          <a:ln/>
+        </p:spPr>
+        <p:txBody>
+          <a:bodyPr wrap="square" lIns="0" tIns="0" rIns="0" bIns="0" rtlCol="0" anchor="t"/>
+          <a:lstStyle/>
+          <a:p>
+            <a:pPr indent="0" marL="0">
+              <a:buNone/>
+            </a:pPr>
+            <a:r>
+              <a:rPr lang="en-US" sz="1350" dirty="0">
                 <a:solidFill>
                   <a:schemeClr val="tx2"/>
                 </a:solidFill>
               </a:rPr>
-              <a:t>Ende des Karnevals. Im Gottesdienst gibt es ein Kreuz aus Asche auf die Stirn. Dann folgen 40 Tage Verzicht als Vorbereitung auf Ostern.</a:t>
-            </a:r>
-            <a:endParaRPr lang="en-US" sz="1450" dirty="0"/>
+              <a:t>Der Karneval ist vorbei. Im Gottesdienst gibt es ein Kreuz aus Asche auf die Stirn.</a:t>
+            </a:r>
+            <a:endParaRPr lang="en-US" sz="1350" dirty="0"/>
           </a:p>
         </p:txBody>
       </p:sp>
@@ -14828,8 +14895,8 @@
         </p:nvSpPr>
         <p:spPr>
           <a:xfrm>
-            <a:off x="3360420" y="2148840"/>
-            <a:ext cx="2491740" cy="731520"/>
+            <a:off x="2816352" y="2331720"/>
+            <a:ext cx="1947672" cy="731520"/>
           </a:xfrm>
           <a:prstGeom prst="rect">
             <a:avLst/>
@@ -14845,14 +14912,14 @@
               <a:buNone/>
             </a:pPr>
             <a:r>
-              <a:rPr lang="en-US" sz="2400" b="1" dirty="0">
+              <a:rPr lang="en-US" sz="1900" b="1" dirty="0">
                 <a:solidFill>
                   <a:schemeClr val="tx1"/>
                 </a:solidFill>
               </a:rPr>
-              <a:t>Karwoche</a:t>
-            </a:r>
-            <a:endParaRPr lang="en-US" sz="2400" dirty="0"/>
+              <a:t>Palmsonntag</a:t>
+            </a:r>
+            <a:endParaRPr lang="en-US" sz="1900" dirty="0"/>
           </a:p>
         </p:txBody>
       </p:sp>
@@ -14864,7 +14931,7 @@
         </p:nvSpPr>
         <p:spPr>
           <a:xfrm>
-            <a:off x="3360420" y="3026664"/>
+            <a:off x="2816352" y="3209544"/>
             <a:ext cx="164592" cy="164592"/>
           </a:xfrm>
           <a:prstGeom prst="ellipse">
@@ -14884,8 +14951,8 @@
         </p:nvSpPr>
         <p:spPr>
           <a:xfrm>
-            <a:off x="3360420" y="3383280"/>
-            <a:ext cx="2491740" cy="274320"/>
+            <a:off x="2816352" y="3566160"/>
+            <a:ext cx="1947672" cy="457200"/>
           </a:xfrm>
           <a:prstGeom prst="rect">
             <a:avLst/>
@@ -14906,7 +14973,7 @@
                   <a:schemeClr val="accent1"/>
                 </a:solidFill>
               </a:rPr>
-              <a:t>AB PALMSONNTAG</a:t>
+              <a:t>BEGINN DER KARWOCHE</a:t>
             </a:r>
             <a:endParaRPr lang="en-US" sz="950" dirty="0"/>
           </a:p>
@@ -14920,31 +14987,31 @@
         </p:nvSpPr>
         <p:spPr>
           <a:xfrm>
-            <a:off x="3360420" y="3794760"/>
-            <a:ext cx="2446020" cy="2377440"/>
-          </a:xfrm>
-          <a:prstGeom prst="rect">
-            <a:avLst/>
-          </a:prstGeom>
-          <a:noFill/>
-          <a:ln/>
-        </p:spPr>
-        <p:txBody>
-          <a:bodyPr wrap="square" lIns="0" tIns="0" rIns="0" bIns="0" rtlCol="0" anchor="t"/>
-          <a:lstStyle/>
-          <a:p>
-            <a:pPr indent="0" marL="0">
-              <a:buNone/>
-            </a:pPr>
-            <a:r>
-              <a:rPr lang="en-US" sz="1450" dirty="0">
+            <a:off x="2816352" y="4114800"/>
+            <a:ext cx="1901952" cy="2286000"/>
+          </a:xfrm>
+          <a:prstGeom prst="rect">
+            <a:avLst/>
+          </a:prstGeom>
+          <a:noFill/>
+          <a:ln/>
+        </p:spPr>
+        <p:txBody>
+          <a:bodyPr wrap="square" lIns="0" tIns="0" rIns="0" bIns="0" rtlCol="0" anchor="t"/>
+          <a:lstStyle/>
+          <a:p>
+            <a:pPr indent="0" marL="0">
+              <a:buNone/>
+            </a:pPr>
+            <a:r>
+              <a:rPr lang="en-US" sz="1350" dirty="0">
                 <a:solidFill>
                   <a:schemeClr val="tx2"/>
                 </a:solidFill>
               </a:rPr>
-              <a:t>Jesus zieht auf einem Esel in Jerusalem ein und wird bejubelt. „Kar“ heißt Klage oder Trauer: Christen denken an sein Leiden.</a:t>
-            </a:r>
-            <a:endParaRPr lang="en-US" sz="1450" dirty="0"/>
+              <a:t>Jesus zieht auf einem Esel in Jerusalem ein und wird bejubelt.</a:t>
+            </a:r>
+            <a:endParaRPr lang="en-US" sz="1350" dirty="0"/>
           </a:p>
         </p:txBody>
       </p:sp>
@@ -14956,8 +15023,8 @@
         </p:nvSpPr>
         <p:spPr>
           <a:xfrm>
-            <a:off x="6080760" y="2148840"/>
-            <a:ext cx="2491740" cy="731520"/>
+            <a:off x="4992624" y="2331720"/>
+            <a:ext cx="1947672" cy="731520"/>
           </a:xfrm>
           <a:prstGeom prst="rect">
             <a:avLst/>
@@ -14973,14 +15040,14 @@
               <a:buNone/>
             </a:pPr>
             <a:r>
-              <a:rPr lang="en-US" sz="2400" b="1" dirty="0">
+              <a:rPr lang="en-US" sz="1900" b="1" dirty="0">
                 <a:solidFill>
                   <a:schemeClr val="tx1"/>
                 </a:solidFill>
               </a:rPr>
               <a:t>Gründonnerstag</a:t>
             </a:r>
-            <a:endParaRPr lang="en-US" sz="2400" dirty="0"/>
+            <a:endParaRPr lang="en-US" sz="1900" dirty="0"/>
           </a:p>
         </p:txBody>
       </p:sp>
@@ -14992,7 +15059,7 @@
         </p:nvSpPr>
         <p:spPr>
           <a:xfrm>
-            <a:off x="6080760" y="3026664"/>
+            <a:off x="4992624" y="3209544"/>
             <a:ext cx="164592" cy="164592"/>
           </a:xfrm>
           <a:prstGeom prst="ellipse">
@@ -15012,8 +15079,8 @@
         </p:nvSpPr>
         <p:spPr>
           <a:xfrm>
-            <a:off x="6080760" y="3383280"/>
-            <a:ext cx="2491740" cy="274320"/>
+            <a:off x="4992624" y="3566160"/>
+            <a:ext cx="1947672" cy="457200"/>
           </a:xfrm>
           <a:prstGeom prst="rect">
             <a:avLst/>
@@ -15034,7 +15101,7 @@
                   <a:schemeClr val="accent1"/>
                 </a:solidFill>
               </a:rPr>
-              <a:t>&amp; KARFREITAG</a:t>
+              <a:t>ERINNERUNG AN DAS LETZTE ABENDMAHL</a:t>
             </a:r>
             <a:endParaRPr lang="en-US" sz="950" dirty="0"/>
           </a:p>
@@ -15048,31 +15115,31 @@
         </p:nvSpPr>
         <p:spPr>
           <a:xfrm>
-            <a:off x="6080760" y="3794760"/>
-            <a:ext cx="2446020" cy="2377440"/>
-          </a:xfrm>
-          <a:prstGeom prst="rect">
-            <a:avLst/>
-          </a:prstGeom>
-          <a:noFill/>
-          <a:ln/>
-        </p:spPr>
-        <p:txBody>
-          <a:bodyPr wrap="square" lIns="0" tIns="0" rIns="0" bIns="0" rtlCol="0" anchor="t"/>
-          <a:lstStyle/>
-          <a:p>
-            <a:pPr indent="0" marL="0">
-              <a:buNone/>
-            </a:pPr>
-            <a:r>
-              <a:rPr lang="en-US" sz="1450" dirty="0">
+            <a:off x="4992624" y="4114800"/>
+            <a:ext cx="1901952" cy="2286000"/>
+          </a:xfrm>
+          <a:prstGeom prst="rect">
+            <a:avLst/>
+          </a:prstGeom>
+          <a:noFill/>
+          <a:ln/>
+        </p:spPr>
+        <p:txBody>
+          <a:bodyPr wrap="square" lIns="0" tIns="0" rIns="0" bIns="0" rtlCol="0" anchor="t"/>
+          <a:lstStyle/>
+          <a:p>
+            <a:pPr indent="0" marL="0">
+              <a:buNone/>
+            </a:pPr>
+            <a:r>
+              <a:rPr lang="en-US" sz="1350" dirty="0">
                 <a:solidFill>
                   <a:schemeClr val="tx2"/>
                 </a:solidFill>
               </a:rPr>
-              <a:t>Gründonnerstag: letztes Abendmahl mit den Jüngern. Karfreitag: Kreuzigung und Tod Jesu – Gottesdienste um 15 Uhr.</a:t>
-            </a:r>
-            <a:endParaRPr lang="en-US" sz="1450" dirty="0"/>
+              <a:t>Jesus feiert mit seinen Jüngern das letzte Abendmahl.</a:t>
+            </a:r>
+            <a:endParaRPr lang="en-US" sz="1350" dirty="0"/>
           </a:p>
         </p:txBody>
       </p:sp>
@@ -15084,8 +15151,8 @@
         </p:nvSpPr>
         <p:spPr>
           <a:xfrm>
-            <a:off x="8801100" y="2148840"/>
-            <a:ext cx="2491740" cy="731520"/>
+            <a:off x="7168896" y="2331720"/>
+            <a:ext cx="1947672" cy="731520"/>
           </a:xfrm>
           <a:prstGeom prst="rect">
             <a:avLst/>
@@ -15101,14 +15168,14 @@
               <a:buNone/>
             </a:pPr>
             <a:r>
-              <a:rPr lang="en-US" sz="2400" b="1" dirty="0">
+              <a:rPr lang="en-US" sz="1900" b="1" dirty="0">
                 <a:solidFill>
                   <a:schemeClr val="tx1"/>
                 </a:solidFill>
               </a:rPr>
-              <a:t>Ostersonntag</a:t>
-            </a:r>
-            <a:endParaRPr lang="en-US" sz="2400" dirty="0"/>
+              <a:t>Karfreitag</a:t>
+            </a:r>
+            <a:endParaRPr lang="en-US" sz="1900" dirty="0"/>
           </a:p>
         </p:txBody>
       </p:sp>
@@ -15120,7 +15187,7 @@
         </p:nvSpPr>
         <p:spPr>
           <a:xfrm>
-            <a:off x="8801100" y="3026664"/>
+            <a:off x="7168896" y="3209544"/>
             <a:ext cx="164592" cy="164592"/>
           </a:xfrm>
           <a:prstGeom prst="ellipse">
@@ -15140,8 +15207,8 @@
         </p:nvSpPr>
         <p:spPr>
           <a:xfrm>
-            <a:off x="8801100" y="3383280"/>
-            <a:ext cx="2491740" cy="274320"/>
+            <a:off x="7168896" y="3566160"/>
+            <a:ext cx="1947672" cy="457200"/>
           </a:xfrm>
           <a:prstGeom prst="rect">
             <a:avLst/>
@@ -15162,7 +15229,7 @@
                   <a:schemeClr val="accent1"/>
                 </a:solidFill>
               </a:rPr>
-              <a:t>AUFERSTEHUNG</a:t>
+              <a:t>KREUZIGUNG JESU CHRISTI</a:t>
             </a:r>
             <a:endParaRPr lang="en-US" sz="950" dirty="0"/>
           </a:p>
@@ -15176,37 +15243,270 @@
         </p:nvSpPr>
         <p:spPr>
           <a:xfrm>
-            <a:off x="8801100" y="3794760"/>
-            <a:ext cx="2446020" cy="2377440"/>
-          </a:xfrm>
-          <a:prstGeom prst="rect">
-            <a:avLst/>
-          </a:prstGeom>
-          <a:noFill/>
-          <a:ln/>
-        </p:spPr>
-        <p:txBody>
-          <a:bodyPr wrap="square" lIns="0" tIns="0" rIns="0" bIns="0" rtlCol="0" anchor="t"/>
-          <a:lstStyle/>
-          <a:p>
-            <a:pPr indent="0" marL="0">
-              <a:buNone/>
-            </a:pPr>
-            <a:r>
-              <a:rPr lang="en-US" sz="1450" dirty="0">
+            <a:off x="7168896" y="4114800"/>
+            <a:ext cx="1901952" cy="2286000"/>
+          </a:xfrm>
+          <a:prstGeom prst="rect">
+            <a:avLst/>
+          </a:prstGeom>
+          <a:noFill/>
+          <a:ln/>
+        </p:spPr>
+        <p:txBody>
+          <a:bodyPr wrap="square" lIns="0" tIns="0" rIns="0" bIns="0" rtlCol="0" anchor="t"/>
+          <a:lstStyle/>
+          <a:p>
+            <a:pPr indent="0" marL="0">
+              <a:buNone/>
+            </a:pPr>
+            <a:r>
+              <a:rPr lang="en-US" sz="1350" dirty="0">
                 <a:solidFill>
                   <a:schemeClr val="tx2"/>
                 </a:solidFill>
               </a:rPr>
-              <a:t>Christen feiern, dass Jesus von den Toten auferstanden ist. Das höchste Fest im Christentum.</a:t>
-            </a:r>
-            <a:endParaRPr lang="en-US" sz="1450" dirty="0"/>
-          </a:p>
-        </p:txBody>
-      </p:sp>
-      <p:sp>
-        <p:nvSpPr>
-          <p:cNvPr id="20" name="Text 0"/>
+              <a:t>Todestag Jesu. Viele Gottesdienste beginnen um 15 Uhr.</a:t>
+            </a:r>
+            <a:endParaRPr lang="en-US" sz="1350" dirty="0"/>
+          </a:p>
+        </p:txBody>
+      </p:sp>
+      <p:sp>
+        <p:nvSpPr>
+          <p:cNvPr id="20" name="Text 18"/>
+          <p:cNvSpPr txBox="1"/>
+          <p:nvPr/>
+        </p:nvSpPr>
+        <p:spPr>
+          <a:xfrm>
+            <a:off x="9345168" y="2331720"/>
+            <a:ext cx="1947672" cy="731520"/>
+          </a:xfrm>
+          <a:prstGeom prst="rect">
+            <a:avLst/>
+          </a:prstGeom>
+          <a:noFill/>
+          <a:ln/>
+        </p:spPr>
+        <p:txBody>
+          <a:bodyPr wrap="square" lIns="0" tIns="0" rIns="0" bIns="0" rtlCol="0" anchor="b"/>
+          <a:lstStyle/>
+          <a:p>
+            <a:pPr indent="0" marL="0">
+              <a:buNone/>
+            </a:pPr>
+            <a:r>
+              <a:rPr lang="en-US" sz="1900" b="1" dirty="0">
+                <a:solidFill>
+                  <a:schemeClr val="tx1"/>
+                </a:solidFill>
+              </a:rPr>
+              <a:t>Ostersonntag</a:t>
+            </a:r>
+            <a:endParaRPr lang="en-US" sz="1900" dirty="0"/>
+          </a:p>
+        </p:txBody>
+      </p:sp>
+      <p:sp>
+        <p:nvSpPr>
+          <p:cNvPr id="21" name="Punkt 5"/>
+          <p:cNvSpPr/>
+          <p:nvPr/>
+        </p:nvSpPr>
+        <p:spPr>
+          <a:xfrm>
+            <a:off x="9345168" y="3209544"/>
+            <a:ext cx="164592" cy="164592"/>
+          </a:xfrm>
+          <a:prstGeom prst="ellipse">
+            <a:avLst/>
+          </a:prstGeom>
+          <a:solidFill>
+            <a:schemeClr val="accent1"/>
+          </a:solidFill>
+          <a:ln/>
+        </p:spPr>
+      </p:sp>
+      <p:sp>
+        <p:nvSpPr>
+          <p:cNvPr id="22" name="Text 20"/>
+          <p:cNvSpPr txBox="1"/>
+          <p:nvPr/>
+        </p:nvSpPr>
+        <p:spPr>
+          <a:xfrm>
+            <a:off x="9345168" y="3566160"/>
+            <a:ext cx="1947672" cy="457200"/>
+          </a:xfrm>
+          <a:prstGeom prst="rect">
+            <a:avLst/>
+          </a:prstGeom>
+          <a:noFill/>
+          <a:ln/>
+        </p:spPr>
+        <p:txBody>
+          <a:bodyPr wrap="square" lIns="0" tIns="0" rIns="0" bIns="0" rtlCol="0" anchor="t"/>
+          <a:lstStyle/>
+          <a:p>
+            <a:pPr indent="0" marL="0">
+              <a:buNone/>
+            </a:pPr>
+            <a:r>
+              <a:rPr lang="en-US" sz="950" b="1" spc="300" kern="0" dirty="0">
+                <a:solidFill>
+                  <a:schemeClr val="accent1"/>
+                </a:solidFill>
+              </a:rPr>
+              <a:t>AUFERSTEHUNG JESU CHRISTI</a:t>
+            </a:r>
+            <a:endParaRPr lang="en-US" sz="950" dirty="0"/>
+          </a:p>
+        </p:txBody>
+      </p:sp>
+      <p:sp>
+        <p:nvSpPr>
+          <p:cNvPr id="23" name="Text 21"/>
+          <p:cNvSpPr txBox="1"/>
+          <p:nvPr/>
+        </p:nvSpPr>
+        <p:spPr>
+          <a:xfrm>
+            <a:off x="9345168" y="4114800"/>
+            <a:ext cx="1901952" cy="2286000"/>
+          </a:xfrm>
+          <a:prstGeom prst="rect">
+            <a:avLst/>
+          </a:prstGeom>
+          <a:noFill/>
+          <a:ln/>
+        </p:spPr>
+        <p:txBody>
+          <a:bodyPr wrap="square" lIns="0" tIns="0" rIns="0" bIns="0" rtlCol="0" anchor="t"/>
+          <a:lstStyle/>
+          <a:p>
+            <a:pPr indent="0" marL="0">
+              <a:buNone/>
+            </a:pPr>
+            <a:r>
+              <a:rPr lang="en-US" sz="1350" dirty="0">
+                <a:solidFill>
+                  <a:schemeClr val="tx2"/>
+                </a:solidFill>
+              </a:rPr>
+              <a:t>Das höchste christliche Fest.</a:t>
+            </a:r>
+            <a:endParaRPr lang="en-US" sz="1350" dirty="0"/>
+          </a:p>
+        </p:txBody>
+      </p:sp>
+      <p:sp>
+        <p:nvSpPr>
+          <p:cNvPr id="24" name="Linie"/>
+          <p:cNvSpPr/>
+          <p:nvPr/>
+        </p:nvSpPr>
+        <p:spPr>
+          <a:xfrm>
+            <a:off x="640080" y="2011680"/>
+            <a:ext cx="8430768" cy="0"/>
+          </a:xfrm>
+          <a:prstGeom prst="line">
+            <a:avLst/>
+          </a:prstGeom>
+          <a:noFill/>
+          <a:ln w="9525">
+            <a:solidFill>
+              <a:schemeClr val="accent1"/>
+            </a:solidFill>
+            <a:prstDash val="solid"/>
+          </a:ln>
+        </p:spPr>
+      </p:sp>
+      <p:sp>
+        <p:nvSpPr>
+          <p:cNvPr id="25" name="Linie"/>
+          <p:cNvSpPr/>
+          <p:nvPr/>
+        </p:nvSpPr>
+        <p:spPr>
+          <a:xfrm>
+            <a:off x="640080" y="2011680"/>
+            <a:ext cx="0" cy="137160"/>
+          </a:xfrm>
+          <a:prstGeom prst="line">
+            <a:avLst/>
+          </a:prstGeom>
+          <a:noFill/>
+          <a:ln w="9525">
+            <a:solidFill>
+              <a:schemeClr val="accent1"/>
+            </a:solidFill>
+            <a:prstDash val="solid"/>
+          </a:ln>
+        </p:spPr>
+      </p:sp>
+      <p:sp>
+        <p:nvSpPr>
+          <p:cNvPr id="26" name="Linie"/>
+          <p:cNvSpPr/>
+          <p:nvPr/>
+        </p:nvSpPr>
+        <p:spPr>
+          <a:xfrm>
+            <a:off x="9070848" y="2011680"/>
+            <a:ext cx="0" cy="137160"/>
+          </a:xfrm>
+          <a:prstGeom prst="line">
+            <a:avLst/>
+          </a:prstGeom>
+          <a:noFill/>
+          <a:ln w="9525">
+            <a:solidFill>
+              <a:schemeClr val="accent1"/>
+            </a:solidFill>
+            <a:prstDash val="solid"/>
+          </a:ln>
+        </p:spPr>
+      </p:sp>
+      <p:sp>
+        <p:nvSpPr>
+          <p:cNvPr id="27" name="Text 25"/>
+          <p:cNvSpPr txBox="1"/>
+          <p:nvPr/>
+        </p:nvSpPr>
+        <p:spPr>
+          <a:xfrm>
+            <a:off x="640080" y="1719072"/>
+            <a:ext cx="8430768" cy="256032"/>
+          </a:xfrm>
+          <a:prstGeom prst="rect">
+            <a:avLst/>
+          </a:prstGeom>
+          <a:noFill/>
+          <a:ln/>
+        </p:spPr>
+        <p:txBody>
+          <a:bodyPr wrap="square" lIns="0" tIns="0" rIns="0" bIns="0" rtlCol="0" anchor="t"/>
+          <a:lstStyle/>
+          <a:p>
+            <a:pPr algn="ctr" indent="0" marL="0">
+              <a:buNone/>
+            </a:pPr>
+            <a:r>
+              <a:rPr lang="en-US" sz="1000" b="1" spc="500" kern="0" dirty="0">
+                <a:solidFill>
+                  <a:schemeClr val="accent1"/>
+                </a:solidFill>
+              </a:rPr>
+              <a:t>FASTENZEIT · 40 TAGE</a:t>
+            </a:r>
+            <a:endParaRPr lang="en-US" sz="1000" dirty="0"/>
+          </a:p>
+        </p:txBody>
+      </p:sp>
+      <p:sp>
+        <p:nvSpPr>
+          <p:cNvPr id="28" name="Text 0"/>
           <p:cNvSpPr/>
           <p:nvPr>
             <p:ph idx="100" type="title" hasCustomPrompt="1"/>
@@ -15247,7 +15547,7 @@
       </p:sp>
       <p:sp>
         <p:nvSpPr>
-          <p:cNvPr id="21" name="Text 19"/>
+          <p:cNvPr id="29" name="Text 27"/>
           <p:cNvSpPr txBox="1"/>
           <p:nvPr/>
         </p:nvSpPr>
@@ -15275,7 +15575,7 @@
                   <a:schemeClr val="tx2"/>
                 </a:solidFill>
               </a:rPr>
-              <a:t>Quellen: Erzbistum Köln; ZDFheute</a:t>
+              <a:t>Quellen: eigene Mitschrift (14.10.2026); Erzbistum Köln; ZDFheute</a:t>
             </a:r>
             <a:endParaRPr lang="en-US" sz="900" dirty="0"/>
           </a:p>

</xml_diff>

<commit_message>
Fastnacht-Erklärung aus der Mitschrift übernehmen
Co-Authored-By: Claude Opus 5.5 <noreply@anthropic.com>
Claude-Session: https://claude.ai/code/session_01EsbPSfyjZCqBtDb5d3uQeV
</commit_message>
<xml_diff>
--- a/Karneval_und_Ostern.pptx
+++ b/Karneval_und_Ostern.pptx
@@ -128,13 +128,13 @@
   <p:extLst>
     <p:ext uri="{521415D9-36F7-43E2-AB2F-B90AF26B5E84}">
       <p14:sectionLst xmlns:p14="http://schemas.microsoft.com/office/powerpoint/2010/main">
-        <p14:section name="Einstieg" id="{62fef05e-137f-258e-901e-3ed3f28f877e}">
+        <p14:section name="Einstieg" id="{d5ce03dd-8ad4-bf17-e4ae-51dbba6612d2}">
           <p14:sldIdLst>
             <p14:sldId id="256"/>
             <p14:sldId id="257"/>
           </p14:sldIdLst>
         </p14:section>
-        <p14:section name="Karneval" id="{6e7b7de5-98c3-26e4-2999-21a35b11ddb2}">
+        <p14:section name="Karneval" id="{2d5ba4dc-30bc-6cde-b307-830ca5d4acb1}">
           <p14:sldIdLst>
             <p14:sldId id="258"/>
             <p14:sldId id="259"/>
@@ -142,13 +142,13 @@
             <p14:sldId id="261"/>
           </p14:sldIdLst>
         </p14:section>
-        <p14:section name="Fastenzeit" id="{7d24c955-9352-301b-82b2-d78da592927a}">
+        <p14:section name="Fastenzeit" id="{6176e311-c657-0077-ee01-b89400fd124a}">
           <p14:sldIdLst>
             <p14:sldId id="262"/>
             <p14:sldId id="263"/>
           </p14:sldIdLst>
         </p14:section>
-        <p14:section name="Ostern" id="{9852b36b-6971-86e4-0a99-4e2970f37f26}">
+        <p14:section name="Ostern" id="{c7b976db-f471-09a0-af9c-0e08e47a721a}">
           <p14:sldIdLst>
             <p14:sldId id="264"/>
             <p14:sldId id="265"/>
@@ -156,7 +156,7 @@
             <p14:sldId id="267"/>
           </p14:sldIdLst>
         </p14:section>
-        <p14:section name="Andere Religionen" id="{8f158ab8-fa5f-8007-8ecb-a82470c2f242}">
+        <p14:section name="Andere Religionen" id="{ca052857-5e15-e541-23b3-446d914617d8}">
           <p14:sldIdLst>
             <p14:sldId id="268"/>
             <p14:sldId id="269"/>
@@ -165,7 +165,7 @@
             <p14:sldId id="272"/>
           </p14:sldIdLst>
         </p14:section>
-        <p14:section name="Abschluss" id="{35cfdf01-5183-a982-26f9-9ed41df438f3}">
+        <p14:section name="Abschluss" id="{7004ece1-5294-cdb2-39c7-c76a9ef6694b}">
           <p14:sldIdLst>
             <p14:sldId id="273"/>
             <p14:sldId id="274"/>
@@ -13594,7 +13594,7 @@
                   <a:schemeClr val="tx1"/>
                 </a:solidFill>
               </a:rPr>
-              <a:t>„Die Nacht vor dem Fasten“ – eigentlich der Dienstag vor Aschermittwoch.</a:t>
+              <a:t>Der Name bedeutet wörtlich die „Nacht bzw. Zeit vor dem Fasten“ und verdeutlicht die direkte Abhängigkeit beider Traditionen.</a:t>
             </a:r>
             <a:endParaRPr lang="en-US" sz="1100" dirty="0"/>
           </a:p>

</xml_diff>